<commit_message>
docs: Slide outline refinement — speaker notes, layout fixes, 25-slide structure
Rewrote S5 speaker note to match slide content, fixed S8 inaccurate
"only see individual files" claim, fixed S12 page break orphaning,
added S2 talking point, updated S1 ALM demos reference, centered
cover page divider. Regenerated all PDFs and PPTX.

Co-Authored-By: Claude Opus 4.6 <noreply@anthropic.com>
</commit_message>
<xml_diff>
--- a/decks/agent-fidelity-spectrum.pptx
+++ b/decks/agent-fidelity-spectrum.pptx
@@ -4168,7 +4168,7 @@
               </a:defRPr>
             </a:pPr>
             <a:r>
-              <a:t>Findings from 380 Test Runs Across 19 Agent Configurations</a:t>
+              <a:t>Findings from 462 Test Runs Across 21 Agent Configurations</a:t>
             </a:r>
           </a:p>
         </p:txBody>
@@ -4505,7 +4505,7 @@
               </a:defRPr>
             </a:pPr>
             <a:r>
-              <a:t>380 test runs  |  19 agents  |  21 slides  |  2 use cases</a:t>
+              <a:t>462 test runs  |  21 agents  |  25 slides  |  2 use cases</a:t>
             </a:r>
           </a:p>
         </p:txBody>
@@ -5307,7 +5307,7 @@
               </a:defRPr>
             </a:pPr>
             <a:r>
-              <a:t>These are not hypothetical. We documented each one across 380 test runs.</a:t>
+              <a:t>These are not hypothetical. We documented each one across 462 test runs.</a:t>
             </a:r>
           </a:p>
         </p:txBody>

</xml_diff>

<commit_message>
docs: Live demo script, updated cheat sheet, slide deck, and outline PDFs
Co-Authored-By: Claude Opus 4.6 <noreply@anthropic.com>
</commit_message>
<xml_diff>
--- a/decks/agent-fidelity-spectrum.pptx
+++ b/decks/agent-fidelity-spectrum.pptx
@@ -16848,7 +16848,7 @@
         </p:nvSpPr>
         <p:spPr>
           <a:xfrm>
-            <a:off x="1371600" y="914400"/>
+            <a:off x="1371600" y="548640"/>
             <a:ext cx="9418320" cy="914400"/>
           </a:xfrm>
           <a:prstGeom prst="rect">
@@ -16884,8 +16884,8 @@
         </p:nvSpPr>
         <p:spPr>
           <a:xfrm>
-            <a:off x="1371600" y="2011680"/>
-            <a:ext cx="9418320" cy="731520"/>
+            <a:off x="1371600" y="1463040"/>
+            <a:ext cx="9418320" cy="548640"/>
           </a:xfrm>
           <a:prstGeom prst="rect">
             <a:avLst/>
@@ -16899,7 +16899,7 @@
           <a:lstStyle/>
           <a:p>
             <a:pPr algn="ctr">
-              <a:defRPr sz="2400" b="0">
+              <a:defRPr sz="2200" b="0">
                 <a:solidFill>
                   <a:srgbClr val="A0C4E8"/>
                 </a:solidFill>
@@ -16907,11 +16907,7 @@
               </a:defRPr>
             </a:pPr>
             <a:r>
-              <a:t>"Let me show you the difference</a:t>
-            </a:r>
-            <a:br/>
-            <a:r>
-              <a:t>between Level 2 and Level 4."</a:t>
+              <a:t>"Same agent. Change one variable. Watch the result change."</a:t>
             </a:r>
           </a:p>
         </p:txBody>
@@ -16924,8 +16920,8 @@
         </p:nvSpPr>
         <p:spPr>
           <a:xfrm>
-            <a:off x="2286000" y="3200400"/>
-            <a:ext cx="1371600" cy="457200"/>
+            <a:off x="914400" y="2286000"/>
+            <a:ext cx="5029200" cy="457200"/>
           </a:xfrm>
           <a:prstGeom prst="rect">
             <a:avLst/>
@@ -16938,30 +16934,73 @@
           </a:bodyPr>
           <a:lstStyle/>
           <a:p>
-            <a:pPr algn="r">
-              <a:defRPr sz="1600" b="1">
-                <a:solidFill>
-                  <a:srgbClr val="8BC34A"/>
-                </a:solidFill>
-                <a:latin typeface="Calibri"/>
-              </a:defRPr>
-            </a:pPr>
-            <a:r>
-              <a:t>Level 2:</a:t>
-            </a:r>
-          </a:p>
-        </p:txBody>
-      </p:sp>
-      <p:sp>
-        <p:nvSpPr>
-          <p:cNvPr id="5" name="TextBox 4"/>
+            <a:pPr algn="l">
+              <a:defRPr sz="1800" b="1">
+                <a:solidFill>
+                  <a:srgbClr val="FFFFFF"/>
+                </a:solidFill>
+                <a:latin typeface="Calibri"/>
+              </a:defRPr>
+            </a:pPr>
+            <a:r>
+              <a:t>Part 1: Document Quality  (~10 min)</a:t>
+            </a:r>
+          </a:p>
+        </p:txBody>
+      </p:sp>
+      <p:sp>
+        <p:nvSpPr>
+          <p:cNvPr id="5" name="Rectangle 4"/>
+          <p:cNvSpPr/>
+          <p:nvPr/>
+        </p:nvSpPr>
+        <p:spPr>
+          <a:xfrm>
+            <a:off x="914400" y="2743200"/>
+            <a:ext cx="5029200" cy="36576"/>
+          </a:xfrm>
+          <a:prstGeom prst="rect">
+            <a:avLst/>
+          </a:prstGeom>
+          <a:solidFill>
+            <a:srgbClr val="357ABD"/>
+          </a:solidFill>
+          <a:ln>
+            <a:noFill/>
+          </a:ln>
+        </p:spPr>
+        <p:style>
+          <a:lnRef idx="1">
+            <a:schemeClr val="accent1"/>
+          </a:lnRef>
+          <a:fillRef idx="3">
+            <a:schemeClr val="accent1"/>
+          </a:fillRef>
+          <a:effectRef idx="2">
+            <a:schemeClr val="accent1"/>
+          </a:effectRef>
+          <a:fontRef idx="minor">
+            <a:schemeClr val="lt1"/>
+          </a:fontRef>
+        </p:style>
+        <p:txBody>
+          <a:bodyPr rtlCol="0" anchor="ctr"/>
+          <a:lstStyle/>
+          <a:p>
+            <a:pPr algn="ctr"/>
+          </a:p>
+        </p:txBody>
+      </p:sp>
+      <p:sp>
+        <p:nvSpPr>
+          <p:cNvPr id="6" name="TextBox 5"/>
           <p:cNvSpPr txBox="1"/>
           <p:nvPr/>
         </p:nvSpPr>
         <p:spPr>
           <a:xfrm>
-            <a:off x="3840480" y="3200400"/>
-            <a:ext cx="5029200" cy="457200"/>
+            <a:off x="1188720" y="2926080"/>
+            <a:ext cx="4754880" cy="457200"/>
           </a:xfrm>
           <a:prstGeom prst="rect">
             <a:avLst/>
@@ -16975,29 +17014,29 @@
           <a:lstStyle/>
           <a:p>
             <a:pPr algn="l">
-              <a:defRPr sz="1600" b="0">
-                <a:solidFill>
-                  <a:srgbClr val="FFFFFF"/>
-                </a:solidFill>
-                <a:latin typeface="Calibri"/>
-              </a:defRPr>
-            </a:pPr>
-            <a:r>
-              <a:t>SharePoint document summarization</a:t>
-            </a:r>
-          </a:p>
-        </p:txBody>
-      </p:sp>
-      <p:sp>
-        <p:nvSpPr>
-          <p:cNvPr id="6" name="TextBox 5"/>
+              <a:defRPr sz="1400" b="0">
+                <a:solidFill>
+                  <a:srgbClr val="CCDDEE"/>
+                </a:solidFill>
+                <a:latin typeface="Calibri"/>
+              </a:defRPr>
+            </a:pPr>
+            <a:r>
+              <a:t>3 agents, same model, 3 SharePoint libraries</a:t>
+            </a:r>
+          </a:p>
+        </p:txBody>
+      </p:sp>
+      <p:sp>
+        <p:nvSpPr>
+          <p:cNvPr id="7" name="TextBox 6"/>
           <p:cNvSpPr txBox="1"/>
           <p:nvPr/>
         </p:nvSpPr>
         <p:spPr>
           <a:xfrm>
-            <a:off x="9144000" y="3200400"/>
-            <a:ext cx="1371600" cy="457200"/>
+            <a:off x="1188720" y="3429000"/>
+            <a:ext cx="4754880" cy="457200"/>
           </a:xfrm>
           <a:prstGeom prst="rect">
             <a:avLst/>
@@ -17010,30 +17049,30 @@
           </a:bodyPr>
           <a:lstStyle/>
           <a:p>
-            <a:pPr algn="r">
+            <a:pPr algn="l">
               <a:defRPr sz="1400" b="0">
                 <a:solidFill>
-                  <a:srgbClr val="88AACC"/>
-                </a:solidFill>
-                <a:latin typeface="Calibri"/>
-              </a:defRPr>
-            </a:pPr>
-            <a:r>
-              <a:t>2 min</a:t>
-            </a:r>
-          </a:p>
-        </p:txBody>
-      </p:sp>
-      <p:sp>
-        <p:nvSpPr>
-          <p:cNvPr id="7" name="TextBox 6"/>
+                  <a:srgbClr val="CCDDEE"/>
+                </a:solidFill>
+                <a:latin typeface="Calibri"/>
+              </a:defRPr>
+            </a:pPr>
+            <a:r>
+              <a:t>Raw  -&gt;  Cross-Referenced  -&gt;  Enriched</a:t>
+            </a:r>
+          </a:p>
+        </p:txBody>
+      </p:sp>
+      <p:sp>
+        <p:nvSpPr>
+          <p:cNvPr id="8" name="TextBox 7"/>
           <p:cNvSpPr txBox="1"/>
           <p:nvPr/>
         </p:nvSpPr>
         <p:spPr>
           <a:xfrm>
-            <a:off x="2286000" y="3840480"/>
-            <a:ext cx="1371600" cy="457200"/>
+            <a:off x="1188720" y="3931920"/>
+            <a:ext cx="4754880" cy="457200"/>
           </a:xfrm>
           <a:prstGeom prst="rect">
             <a:avLst/>
@@ -17046,30 +17085,30 @@
           </a:bodyPr>
           <a:lstStyle/>
           <a:p>
-            <a:pPr algn="r">
-              <a:defRPr sz="1600" b="1">
-                <a:solidFill>
-                  <a:srgbClr val="FF9800"/>
-                </a:solidFill>
-                <a:latin typeface="Calibri"/>
-              </a:defRPr>
-            </a:pPr>
-            <a:r>
-              <a:t>Level 3:</a:t>
-            </a:r>
-          </a:p>
-        </p:txBody>
-      </p:sp>
-      <p:sp>
-        <p:nvSpPr>
-          <p:cNvPr id="8" name="TextBox 7"/>
+            <a:pPr algn="l">
+              <a:defRPr sz="1400" b="0">
+                <a:solidFill>
+                  <a:srgbClr val="CCDDEE"/>
+                </a:solidFill>
+                <a:latin typeface="Calibri"/>
+              </a:defRPr>
+            </a:pPr>
+            <a:r>
+              <a:t>Skeletal survey: FAIL -&gt; PASS -&gt; PASS</a:t>
+            </a:r>
+          </a:p>
+        </p:txBody>
+      </p:sp>
+      <p:sp>
+        <p:nvSpPr>
+          <p:cNvPr id="9" name="TextBox 8"/>
           <p:cNvSpPr txBox="1"/>
           <p:nvPr/>
         </p:nvSpPr>
         <p:spPr>
           <a:xfrm>
-            <a:off x="3840480" y="3840480"/>
-            <a:ext cx="5029200" cy="457200"/>
+            <a:off x="1188720" y="4434840"/>
+            <a:ext cx="4754880" cy="457200"/>
           </a:xfrm>
           <a:prstGeom prst="rect">
             <a:avLst/>
@@ -17083,29 +17122,29 @@
           <a:lstStyle/>
           <a:p>
             <a:pPr algn="l">
-              <a:defRPr sz="1600" b="0">
-                <a:solidFill>
-                  <a:srgbClr val="FFFFFF"/>
-                </a:solidFill>
-                <a:latin typeface="Calibri"/>
-              </a:defRPr>
-            </a:pPr>
-            <a:r>
-              <a:t>"How many cases by type?" aggregate query</a:t>
-            </a:r>
-          </a:p>
-        </p:txBody>
-      </p:sp>
-      <p:sp>
-        <p:nvSpPr>
-          <p:cNvPr id="9" name="TextBox 8"/>
+              <a:defRPr sz="1400" b="0">
+                <a:solidFill>
+                  <a:srgbClr val="CCDDEE"/>
+                </a:solidFill>
+                <a:latin typeface="Calibri"/>
+              </a:defRPr>
+            </a:pPr>
+            <a:r>
+              <a:t>Marcus Webb: FAIL -&gt; PARTIAL -&gt; PASS</a:t>
+            </a:r>
+          </a:p>
+        </p:txBody>
+      </p:sp>
+      <p:sp>
+        <p:nvSpPr>
+          <p:cNvPr id="10" name="TextBox 9"/>
           <p:cNvSpPr txBox="1"/>
           <p:nvPr/>
         </p:nvSpPr>
         <p:spPr>
           <a:xfrm>
-            <a:off x="9144000" y="3840480"/>
-            <a:ext cx="1371600" cy="457200"/>
+            <a:off x="1188720" y="4937760"/>
+            <a:ext cx="4754880" cy="457200"/>
           </a:xfrm>
           <a:prstGeom prst="rect">
             <a:avLst/>
@@ -17118,30 +17157,30 @@
           </a:bodyPr>
           <a:lstStyle/>
           <a:p>
-            <a:pPr algn="r">
+            <a:pPr algn="l">
               <a:defRPr sz="1400" b="0">
                 <a:solidFill>
-                  <a:srgbClr val="88AACC"/>
-                </a:solidFill>
-                <a:latin typeface="Calibri"/>
-              </a:defRPr>
-            </a:pPr>
-            <a:r>
-              <a:t>2 min</a:t>
-            </a:r>
-          </a:p>
-        </p:txBody>
-      </p:sp>
-      <p:sp>
-        <p:nvSpPr>
-          <p:cNvPr id="10" name="TextBox 9"/>
+                  <a:srgbClr val="CCDDEE"/>
+                </a:solidFill>
+                <a:latin typeface="Calibri"/>
+              </a:defRPr>
+            </a:pPr>
+            <a:r>
+              <a:t>Score arc: 3/10 -&gt; 7/10 -&gt; 8/10</a:t>
+            </a:r>
+          </a:p>
+        </p:txBody>
+      </p:sp>
+      <p:sp>
+        <p:nvSpPr>
+          <p:cNvPr id="11" name="TextBox 10"/>
           <p:cNvSpPr txBox="1"/>
           <p:nvPr/>
         </p:nvSpPr>
         <p:spPr>
           <a:xfrm>
-            <a:off x="2286000" y="4480560"/>
-            <a:ext cx="1371600" cy="457200"/>
+            <a:off x="1188720" y="5440680"/>
+            <a:ext cx="4754880" cy="457200"/>
           </a:xfrm>
           <a:prstGeom prst="rect">
             <a:avLst/>
@@ -17154,29 +17193,29 @@
           </a:bodyPr>
           <a:lstStyle/>
           <a:p>
-            <a:pPr algn="r">
-              <a:defRPr sz="1600" b="1">
-                <a:solidFill>
-                  <a:srgbClr val="F4511E"/>
-                </a:solidFill>
-                <a:latin typeface="Calibri"/>
-              </a:defRPr>
-            </a:pPr>
-            <a:r>
-              <a:t>Level 4:</a:t>
-            </a:r>
-          </a:p>
-        </p:txBody>
-      </p:sp>
-      <p:sp>
-        <p:nvSpPr>
-          <p:cNvPr id="11" name="TextBox 10"/>
+            <a:pPr algn="l">
+              <a:defRPr sz="1400" b="0">
+                <a:solidFill>
+                  <a:srgbClr val="CCDDEE"/>
+                </a:solidFill>
+                <a:latin typeface="Calibri"/>
+              </a:defRPr>
+            </a:pPr>
+            <a:r>
+              <a:t>Cost: $0, 45 minutes of document hygiene</a:t>
+            </a:r>
+          </a:p>
+        </p:txBody>
+      </p:sp>
+      <p:sp>
+        <p:nvSpPr>
+          <p:cNvPr id="12" name="TextBox 11"/>
           <p:cNvSpPr txBox="1"/>
           <p:nvPr/>
         </p:nvSpPr>
         <p:spPr>
           <a:xfrm>
-            <a:off x="3840480" y="4480560"/>
+            <a:off x="6400800" y="2286000"/>
             <a:ext cx="5029200" cy="457200"/>
           </a:xfrm>
           <a:prstGeom prst="rect">
@@ -17191,7 +17230,7 @@
           <a:lstStyle/>
           <a:p>
             <a:pPr algn="l">
-              <a:defRPr sz="1600" b="0">
+              <a:defRPr sz="1800" b="1">
                 <a:solidFill>
                   <a:srgbClr val="FFFFFF"/>
                 </a:solidFill>
@@ -17199,21 +17238,64 @@
               </a:defRPr>
             </a:pPr>
             <a:r>
-              <a:t>The money prompt -- timeline, discrepancies, statements</a:t>
-            </a:r>
-          </a:p>
-        </p:txBody>
-      </p:sp>
-      <p:sp>
-        <p:nvSpPr>
-          <p:cNvPr id="12" name="TextBox 11"/>
+              <a:t>Part 2: Model Selection  (~8 min)</a:t>
+            </a:r>
+          </a:p>
+        </p:txBody>
+      </p:sp>
+      <p:sp>
+        <p:nvSpPr>
+          <p:cNvPr id="13" name="Rectangle 12"/>
+          <p:cNvSpPr/>
+          <p:nvPr/>
+        </p:nvSpPr>
+        <p:spPr>
+          <a:xfrm>
+            <a:off x="6400800" y="2743200"/>
+            <a:ext cx="5029200" cy="36576"/>
+          </a:xfrm>
+          <a:prstGeom prst="rect">
+            <a:avLst/>
+          </a:prstGeom>
+          <a:solidFill>
+            <a:srgbClr val="357ABD"/>
+          </a:solidFill>
+          <a:ln>
+            <a:noFill/>
+          </a:ln>
+        </p:spPr>
+        <p:style>
+          <a:lnRef idx="1">
+            <a:schemeClr val="accent1"/>
+          </a:lnRef>
+          <a:fillRef idx="3">
+            <a:schemeClr val="accent1"/>
+          </a:fillRef>
+          <a:effectRef idx="2">
+            <a:schemeClr val="accent1"/>
+          </a:effectRef>
+          <a:fontRef idx="minor">
+            <a:schemeClr val="lt1"/>
+          </a:fontRef>
+        </p:style>
+        <p:txBody>
+          <a:bodyPr rtlCol="0" anchor="ctr"/>
+          <a:lstStyle/>
+          <a:p>
+            <a:pPr algn="ctr"/>
+          </a:p>
+        </p:txBody>
+      </p:sp>
+      <p:sp>
+        <p:nvSpPr>
+          <p:cNvPr id="14" name="TextBox 13"/>
           <p:cNvSpPr txBox="1"/>
           <p:nvPr/>
         </p:nvSpPr>
         <p:spPr>
           <a:xfrm>
-            <a:off x="9144000" y="4480560"/>
-            <a:ext cx="1371600" cy="457200"/>
+            <a:off x="6675120" y="2926080"/>
+            <a:ext cx="4754880" cy="457200"/>
           </a:xfrm>
           <a:prstGeom prst="rect">
             <a:avLst/>
@@ -17226,30 +17308,30 @@
           </a:bodyPr>
           <a:lstStyle/>
           <a:p>
-            <a:pPr algn="r">
+            <a:pPr algn="l">
               <a:defRPr sz="1400" b="0">
                 <a:solidFill>
-                  <a:srgbClr val="88AACC"/>
-                </a:solidFill>
-                <a:latin typeface="Calibri"/>
-              </a:defRPr>
-            </a:pPr>
-            <a:r>
-              <a:t>5 min</a:t>
-            </a:r>
-          </a:p>
-        </p:txBody>
-      </p:sp>
-      <p:sp>
-        <p:nvSpPr>
-          <p:cNvPr id="13" name="TextBox 12"/>
+                  <a:srgbClr val="CCDDEE"/>
+                </a:solidFill>
+                <a:latin typeface="Calibri"/>
+              </a:defRPr>
+            </a:pPr>
+            <a:r>
+              <a:t>1 Dataverse MCP agent, swap model live</a:t>
+            </a:r>
+          </a:p>
+        </p:txBody>
+      </p:sp>
+      <p:sp>
+        <p:nvSpPr>
+          <p:cNvPr id="15" name="TextBox 14"/>
           <p:cNvSpPr txBox="1"/>
           <p:nvPr/>
         </p:nvSpPr>
         <p:spPr>
           <a:xfrm>
-            <a:off x="2286000" y="5120640"/>
-            <a:ext cx="1371600" cy="457200"/>
+            <a:off x="6675120" y="3429000"/>
+            <a:ext cx="4754880" cy="457200"/>
           </a:xfrm>
           <a:prstGeom prst="rect">
             <a:avLst/>
@@ -17262,30 +17344,30 @@
           </a:bodyPr>
           <a:lstStyle/>
           <a:p>
-            <a:pPr algn="r">
-              <a:defRPr sz="1600" b="1">
-                <a:solidFill>
-                  <a:srgbClr val="E53935"/>
-                </a:solidFill>
-                <a:latin typeface="Calibri"/>
-              </a:defRPr>
-            </a:pPr>
-            <a:r>
-              <a:t>Level 5:</a:t>
-            </a:r>
-          </a:p>
-        </p:txBody>
-      </p:sp>
-      <p:sp>
-        <p:nvSpPr>
-          <p:cNvPr id="14" name="TextBox 13"/>
+            <a:pPr algn="l">
+              <a:defRPr sz="1400" b="0">
+                <a:solidFill>
+                  <a:srgbClr val="CCDDEE"/>
+                </a:solidFill>
+                <a:latin typeface="Calibri"/>
+              </a:defRPr>
+            </a:pPr>
+            <a:r>
+              <a:t>GPT-4o  -&gt;  Sonnet 4.6</a:t>
+            </a:r>
+          </a:p>
+        </p:txBody>
+      </p:sp>
+      <p:sp>
+        <p:nvSpPr>
+          <p:cNvPr id="16" name="TextBox 15"/>
           <p:cNvSpPr txBox="1"/>
           <p:nvPr/>
         </p:nvSpPr>
         <p:spPr>
           <a:xfrm>
-            <a:off x="3840480" y="5120640"/>
-            <a:ext cx="5029200" cy="457200"/>
+            <a:off x="6675120" y="3931920"/>
+            <a:ext cx="4754880" cy="457200"/>
           </a:xfrm>
           <a:prstGeom prst="rect">
             <a:avLst/>
@@ -17299,29 +17381,29 @@
           <a:lstStyle/>
           <a:p>
             <a:pPr algn="l">
-              <a:defRPr sz="1600" b="0">
-                <a:solidFill>
-                  <a:srgbClr val="FFFFFF"/>
-                </a:solidFill>
-                <a:latin typeface="Calibri"/>
-              </a:defRPr>
-            </a:pPr>
-            <a:r>
-              <a:t>The skeletal survey question</a:t>
-            </a:r>
-          </a:p>
-        </p:txBody>
-      </p:sp>
-      <p:sp>
-        <p:nvSpPr>
-          <p:cNvPr id="15" name="TextBox 14"/>
+              <a:defRPr sz="1400" b="0">
+                <a:solidFill>
+                  <a:srgbClr val="CCDDEE"/>
+                </a:solidFill>
+                <a:latin typeface="Calibri"/>
+              </a:defRPr>
+            </a:pPr>
+            <a:r>
+              <a:t>TPR case filter: 0 -&gt; 10</a:t>
+            </a:r>
+          </a:p>
+        </p:txBody>
+      </p:sp>
+      <p:sp>
+        <p:nvSpPr>
+          <p:cNvPr id="17" name="TextBox 16"/>
           <p:cNvSpPr txBox="1"/>
           <p:nvPr/>
         </p:nvSpPr>
         <p:spPr>
           <a:xfrm>
-            <a:off x="9144000" y="5120640"/>
-            <a:ext cx="1371600" cy="457200"/>
+            <a:off x="6675120" y="4434840"/>
+            <a:ext cx="4754880" cy="457200"/>
           </a:xfrm>
           <a:prstGeom prst="rect">
             <a:avLst/>
@@ -17334,16 +17416,124 @@
           </a:bodyPr>
           <a:lstStyle/>
           <a:p>
-            <a:pPr algn="r">
+            <a:pPr algn="l">
               <a:defRPr sz="1400" b="0">
                 <a:solidFill>
+                  <a:srgbClr val="CCDDEE"/>
+                </a:solidFill>
+                <a:latin typeface="Calibri"/>
+              </a:defRPr>
+            </a:pPr>
+            <a:r>
+              <a:t>Cross-doc reasoning: 0 -&gt; 10</a:t>
+            </a:r>
+          </a:p>
+        </p:txBody>
+      </p:sp>
+      <p:sp>
+        <p:nvSpPr>
+          <p:cNvPr id="18" name="TextBox 17"/>
+          <p:cNvSpPr txBox="1"/>
+          <p:nvPr/>
+        </p:nvSpPr>
+        <p:spPr>
+          <a:xfrm>
+            <a:off x="6675120" y="4937760"/>
+            <a:ext cx="4754880" cy="457200"/>
+          </a:xfrm>
+          <a:prstGeom prst="rect">
+            <a:avLst/>
+          </a:prstGeom>
+          <a:noFill/>
+        </p:spPr>
+        <p:txBody>
+          <a:bodyPr wrap="square">
+            <a:spAutoFit/>
+          </a:bodyPr>
+          <a:lstStyle/>
+          <a:p>
+            <a:pPr algn="l">
+              <a:defRPr sz="1400" b="0">
+                <a:solidFill>
+                  <a:srgbClr val="CCDDEE"/>
+                </a:solidFill>
+                <a:latin typeface="Calibri"/>
+              </a:defRPr>
+            </a:pPr>
+            <a:r>
+              <a:t>Time gap calculation: 0 -&gt; 10</a:t>
+            </a:r>
+          </a:p>
+        </p:txBody>
+      </p:sp>
+      <p:sp>
+        <p:nvSpPr>
+          <p:cNvPr id="19" name="TextBox 18"/>
+          <p:cNvSpPr txBox="1"/>
+          <p:nvPr/>
+        </p:nvSpPr>
+        <p:spPr>
+          <a:xfrm>
+            <a:off x="6675120" y="5440680"/>
+            <a:ext cx="4754880" cy="457200"/>
+          </a:xfrm>
+          <a:prstGeom prst="rect">
+            <a:avLst/>
+          </a:prstGeom>
+          <a:noFill/>
+        </p:spPr>
+        <p:txBody>
+          <a:bodyPr wrap="square">
+            <a:spAutoFit/>
+          </a:bodyPr>
+          <a:lstStyle/>
+          <a:p>
+            <a:pPr algn="l">
+              <a:defRPr sz="1400" b="0">
+                <a:solidFill>
+                  <a:srgbClr val="CCDDEE"/>
+                </a:solidFill>
+                <a:latin typeface="Calibri"/>
+              </a:defRPr>
+            </a:pPr>
+            <a:r>
+              <a:t>Full battery: 1/11 -&gt; 6/11 -&gt; 11/11</a:t>
+            </a:r>
+          </a:p>
+        </p:txBody>
+      </p:sp>
+      <p:sp>
+        <p:nvSpPr>
+          <p:cNvPr id="20" name="TextBox 19"/>
+          <p:cNvSpPr txBox="1"/>
+          <p:nvPr/>
+        </p:nvSpPr>
+        <p:spPr>
+          <a:xfrm>
+            <a:off x="1371600" y="5943600"/>
+            <a:ext cx="9418320" cy="457200"/>
+          </a:xfrm>
+          <a:prstGeom prst="rect">
+            <a:avLst/>
+          </a:prstGeom>
+          <a:noFill/>
+        </p:spPr>
+        <p:txBody>
+          <a:bodyPr wrap="square">
+            <a:spAutoFit/>
+          </a:bodyPr>
+          <a:lstStyle/>
+          <a:p>
+            <a:pPr algn="ctr">
+              <a:defRPr sz="1400" b="1">
+                <a:solidFill>
                   <a:srgbClr val="88AACC"/>
                 </a:solidFill>
                 <a:latin typeface="Calibri"/>
               </a:defRPr>
             </a:pPr>
             <a:r>
-              <a:t>3 min</a:t>
+              <a:t>All demos run in Copilot Studio -- no custom code UI</a:t>
             </a:r>
           </a:p>
         </p:txBody>

</xml_diff>

<commit_message>
docs: Add S22 "One Prompt, Three Interventions" slide to deck
New slide shows Marcus Webb prompt progression across Raw (FAIL),
Cross-Referenced (PARTIAL), and Enriched (PASS) document tiers.
Deck now 27 slides.

Co-Authored-By: Claude Opus 4.6 <noreply@anthropic.com>
</commit_message>
<xml_diff>
--- a/decks/agent-fidelity-spectrum.pptx
+++ b/decks/agent-fidelity-spectrum.pptx
@@ -31,6 +31,7 @@
     <p:sldId id="279" r:id="rId31"/>
     <p:sldId id="280" r:id="rId32"/>
     <p:sldId id="281" r:id="rId33"/>
+    <p:sldId id="282" r:id="rId34"/>
   </p:sldIdLst>
   <p:sldSz cx="12191695" cy="6858000" type="screen4x3"/>
   <p:notesSz cx="6858000" cy="9144000"/>
@@ -597,7 +598,7 @@
           <a:lstStyle/>
           <a:p>
             <a:r>
-              <a:t>So what do we do? Do we just give up on agents? No -- you continue to test them and make them better, and you always adhere to trust but verify. I have agents building apps for me right now. If I were building production enterprise apps, I'd have a team of human developers checking the work, helping test, reviewing agentic results. The AI accelerates the team. The team validates the AI.</a:t>
+              <a:t>This is the most relatable prompt in the deck. Everyone understands 'did the parent tell the same story to the nurse and the police?' Raw docs: agent only found the Sheriff Report. Cross-refs: found both sources but couldn't retrieve the nursing notes detail. Metadata: the keywords 'nursing interview' and 'parent statements' on Medical Records told the agent exactly where to look. $0, 45 minutes, no code.</a:t>
             </a:r>
           </a:p>
         </p:txBody>
@@ -623,6 +624,76 @@
 </file>
 
 <file path=ppt/notesSlides/notesSlide11.xml><?xml version="1.0" encoding="utf-8"?>
+<p:notes xmlns:a="http://schemas.openxmlformats.org/drawingml/2006/main" xmlns:p="http://schemas.openxmlformats.org/presentationml/2006/main" xmlns:r="http://schemas.openxmlformats.org/officeDocument/2006/relationships">
+  <p:cSld>
+    <p:spTree>
+      <p:nvGrpSpPr>
+        <p:cNvPr id="1" name=""/>
+        <p:cNvGrpSpPr/>
+        <p:nvPr/>
+      </p:nvGrpSpPr>
+      <p:grpSpPr>
+        <a:xfrm>
+          <a:off x="0" y="0"/>
+          <a:ext cx="0" cy="0"/>
+          <a:chOff x="0" y="0"/>
+          <a:chExt cx="0" cy="0"/>
+        </a:xfrm>
+      </p:grpSpPr>
+      <p:sp>
+        <p:nvSpPr>
+          <p:cNvPr id="2" name="Slide Image Placeholder 1"/>
+          <p:cNvSpPr>
+            <a:spLocks noGrp="1"/>
+          </p:cNvSpPr>
+          <p:nvPr>
+            <p:ph type="sldImg" idx="2"/>
+          </p:nvPr>
+        </p:nvSpPr>
+        <p:spPr/>
+      </p:sp>
+      <p:sp>
+        <p:nvSpPr>
+          <p:cNvPr id="3" name="Notes Placeholder 2"/>
+          <p:cNvSpPr>
+            <a:spLocks noGrp="1"/>
+          </p:cNvSpPr>
+          <p:nvPr>
+            <p:ph type="body" idx="3" sz="quarter"/>
+          </p:nvPr>
+        </p:nvSpPr>
+        <p:spPr/>
+        <p:txBody>
+          <a:bodyPr/>
+          <a:lstStyle/>
+          <a:p>
+            <a:r>
+              <a:t>So what do we do? Do we just give up on agents? No -- you continue to test them and make them better, and you always adhere to trust but verify. I have agents building apps for me right now. If I were building production enterprise apps, I'd have a team of human developers checking the work, helping test, reviewing agentic results. The AI accelerates the team. The team validates the AI.</a:t>
+            </a:r>
+          </a:p>
+        </p:txBody>
+      </p:sp>
+      <p:sp>
+        <p:nvSpPr>
+          <p:cNvPr id="4" name="Slide Number Placeholder 3"/>
+          <p:cNvSpPr>
+            <a:spLocks noGrp="1"/>
+          </p:cNvSpPr>
+          <p:nvPr>
+            <p:ph type="sldNum" idx="5" sz="quarter"/>
+          </p:nvPr>
+        </p:nvSpPr>
+        <p:spPr/>
+      </p:sp>
+    </p:spTree>
+  </p:cSld>
+  <p:clrMapOvr>
+    <a:masterClrMapping/>
+  </p:clrMapOvr>
+</p:notes>
+</file>
+
+<file path=ppt/notesSlides/notesSlide12.xml><?xml version="1.0" encoding="utf-8"?>
 <p:notes xmlns:a="http://schemas.openxmlformats.org/drawingml/2006/main" xmlns:p="http://schemas.openxmlformats.org/presentationml/2006/main" xmlns:r="http://schemas.openxmlformats.org/officeDocument/2006/relationships">
   <p:cSld>
     <p:spTree>
@@ -4419,7 +4490,7 @@
               </a:defRPr>
             </a:pPr>
             <a:r>
-              <a:t>26 Slides  |  March 2026</a:t>
+              <a:t>27 Slides  |  March 2026</a:t>
             </a:r>
           </a:p>
         </p:txBody>
@@ -4720,7 +4791,7 @@
               </a:defRPr>
             </a:pPr>
             <a:r>
-              <a:t>462 test runs  |  21 agents  |  26 slides  |  2 use cases</a:t>
+              <a:t>462 test runs  |  21 agents  |  27 slides  |  2 use cases</a:t>
             </a:r>
           </a:p>
         </p:txBody>
@@ -17587,7 +17658,7 @@
           <a:lstStyle/>
           <a:p>
             <a:pPr algn="l">
-              <a:defRPr sz="2800" b="1">
+              <a:defRPr sz="3200" b="1">
                 <a:solidFill>
                   <a:srgbClr val="1B2A4A"/>
                 </a:solidFill>
@@ -17595,7 +17666,7 @@
               </a:defRPr>
             </a:pPr>
             <a:r>
-              <a:t>Surprising Finding: Agent Challenged Its Own Premise</a:t>
+              <a:t>One Prompt, Three Interventions</a:t>
             </a:r>
           </a:p>
         </p:txBody>
@@ -17645,14 +17716,57 @@
       </p:sp>
       <p:sp>
         <p:nvSpPr>
-          <p:cNvPr id="4" name="TextBox 3"/>
+          <p:cNvPr id="4" name="Rounded Rectangle 3"/>
+          <p:cNvSpPr/>
+          <p:nvPr/>
+        </p:nvSpPr>
+        <p:spPr>
+          <a:xfrm>
+            <a:off x="1097280" y="1234440"/>
+            <a:ext cx="9966960" cy="640080"/>
+          </a:xfrm>
+          <a:prstGeom prst="roundRect">
+            <a:avLst/>
+          </a:prstGeom>
+          <a:solidFill>
+            <a:srgbClr val="F5F5F5"/>
+          </a:solidFill>
+          <a:ln>
+            <a:noFill/>
+          </a:ln>
+        </p:spPr>
+        <p:style>
+          <a:lnRef idx="1">
+            <a:schemeClr val="accent1"/>
+          </a:lnRef>
+          <a:fillRef idx="3">
+            <a:schemeClr val="accent1"/>
+          </a:fillRef>
+          <a:effectRef idx="2">
+            <a:schemeClr val="accent1"/>
+          </a:effectRef>
+          <a:fontRef idx="minor">
+            <a:schemeClr val="lt1"/>
+          </a:fontRef>
+        </p:style>
+        <p:txBody>
+          <a:bodyPr rtlCol="0" anchor="ctr"/>
+          <a:lstStyle/>
+          <a:p>
+            <a:pPr algn="ctr"/>
+          </a:p>
+        </p:txBody>
+      </p:sp>
+      <p:sp>
+        <p:nvSpPr>
+          <p:cNvPr id="5" name="TextBox 4"/>
           <p:cNvSpPr txBox="1"/>
           <p:nvPr/>
         </p:nvSpPr>
         <p:spPr>
           <a:xfrm>
-            <a:off x="1097280" y="1371600"/>
-            <a:ext cx="9966960" cy="457200"/>
+            <a:off x="1371600" y="1280160"/>
+            <a:ext cx="9418320" cy="548640"/>
           </a:xfrm>
           <a:prstGeom prst="rect">
             <a:avLst/>
@@ -17665,30 +17779,116 @@
           </a:bodyPr>
           <a:lstStyle/>
           <a:p>
-            <a:pPr algn="l">
-              <a:defRPr sz="2000" b="1">
-                <a:solidFill>
-                  <a:srgbClr val="2D2D2D"/>
-                </a:solidFill>
-                <a:latin typeface="Calibri"/>
-              </a:defRPr>
-            </a:pPr>
-            <a:r>
-              <a:t>A pro-code agent questioned the question -- and was right</a:t>
-            </a:r>
-          </a:p>
-        </p:txBody>
-      </p:sp>
-      <p:sp>
-        <p:nvSpPr>
-          <p:cNvPr id="5" name="TextBox 4"/>
+            <a:pPr algn="ctr">
+              <a:defRPr sz="1500" b="1">
+                <a:solidFill>
+                  <a:srgbClr val="555555"/>
+                </a:solidFill>
+                <a:latin typeface="Calibri"/>
+              </a:defRPr>
+            </a:pPr>
+            <a:r>
+              <a:t>"What did Marcus Webb tell hospital staff about when he put Jaylen to bed, and did he give the same answer to law enforcement?"</a:t>
+            </a:r>
+          </a:p>
+        </p:txBody>
+      </p:sp>
+      <p:sp>
+        <p:nvSpPr>
+          <p:cNvPr id="6" name="Rounded Rectangle 5"/>
+          <p:cNvSpPr/>
+          <p:nvPr/>
+        </p:nvSpPr>
+        <p:spPr>
+          <a:xfrm>
+            <a:off x="822960" y="2057400"/>
+            <a:ext cx="3383280" cy="3383280"/>
+          </a:xfrm>
+          <a:prstGeom prst="roundRect">
+            <a:avLst/>
+          </a:prstGeom>
+          <a:solidFill>
+            <a:srgbClr val="FFEBEE"/>
+          </a:solidFill>
+          <a:ln>
+            <a:noFill/>
+          </a:ln>
+        </p:spPr>
+        <p:style>
+          <a:lnRef idx="1">
+            <a:schemeClr val="accent1"/>
+          </a:lnRef>
+          <a:fillRef idx="3">
+            <a:schemeClr val="accent1"/>
+          </a:fillRef>
+          <a:effectRef idx="2">
+            <a:schemeClr val="accent1"/>
+          </a:effectRef>
+          <a:fontRef idx="minor">
+            <a:schemeClr val="lt1"/>
+          </a:fontRef>
+        </p:style>
+        <p:txBody>
+          <a:bodyPr rtlCol="0" anchor="ctr"/>
+          <a:lstStyle/>
+          <a:p>
+            <a:pPr algn="ctr"/>
+          </a:p>
+        </p:txBody>
+      </p:sp>
+      <p:sp>
+        <p:nvSpPr>
+          <p:cNvPr id="7" name="Rectangle 6"/>
+          <p:cNvSpPr/>
+          <p:nvPr/>
+        </p:nvSpPr>
+        <p:spPr>
+          <a:xfrm>
+            <a:off x="822960" y="2057400"/>
+            <a:ext cx="3383280" cy="109728"/>
+          </a:xfrm>
+          <a:prstGeom prst="rect">
+            <a:avLst/>
+          </a:prstGeom>
+          <a:solidFill>
+            <a:srgbClr val="C62828"/>
+          </a:solidFill>
+          <a:ln>
+            <a:noFill/>
+          </a:ln>
+        </p:spPr>
+        <p:style>
+          <a:lnRef idx="1">
+            <a:schemeClr val="accent1"/>
+          </a:lnRef>
+          <a:fillRef idx="3">
+            <a:schemeClr val="accent1"/>
+          </a:fillRef>
+          <a:effectRef idx="2">
+            <a:schemeClr val="accent1"/>
+          </a:effectRef>
+          <a:fontRef idx="minor">
+            <a:schemeClr val="lt1"/>
+          </a:fontRef>
+        </p:style>
+        <p:txBody>
+          <a:bodyPr rtlCol="0" anchor="ctr"/>
+          <a:lstStyle/>
+          <a:p>
+            <a:pPr algn="ctr"/>
+          </a:p>
+        </p:txBody>
+      </p:sp>
+      <p:sp>
+        <p:nvSpPr>
+          <p:cNvPr id="8" name="TextBox 7"/>
           <p:cNvSpPr txBox="1"/>
           <p:nvPr/>
         </p:nvSpPr>
         <p:spPr>
           <a:xfrm>
-            <a:off x="1097280" y="2103120"/>
-            <a:ext cx="9966960" cy="2286000"/>
+            <a:off x="960120" y="2240280"/>
+            <a:ext cx="3108960" cy="320040"/>
           </a:xfrm>
           <a:prstGeom prst="rect">
             <a:avLst/>
@@ -17701,81 +17901,867 @@
           </a:bodyPr>
           <a:lstStyle/>
           <a:p>
-            <a:pPr>
-              <a:spcAft>
-                <a:spcPts val="600"/>
-              </a:spcAft>
-            </a:pPr>
-            <a:r>
-              <a:rPr sz="1800">
+            <a:pPr algn="ctr">
+              <a:defRPr sz="1600" b="1">
                 <a:solidFill>
                   <a:srgbClr val="2D2D2D"/>
                 </a:solidFill>
                 <a:latin typeface="Calibri"/>
-              </a:rPr>
-              <a:t>Asked about a $146,000 purchase vs a $357,100 assessment</a:t>
-            </a:r>
-          </a:p>
-          <a:p>
-            <a:pPr>
-              <a:spcAft>
-                <a:spcPts val="600"/>
-              </a:spcAft>
-            </a:pPr>
-            <a:r>
-              <a:rPr sz="1800">
+              </a:defRPr>
+            </a:pPr>
+            <a:r>
+              <a:t>Raw Documents</a:t>
+            </a:r>
+          </a:p>
+        </p:txBody>
+      </p:sp>
+      <p:sp>
+        <p:nvSpPr>
+          <p:cNvPr id="9" name="Rounded Rectangle 8"/>
+          <p:cNvSpPr/>
+          <p:nvPr/>
+        </p:nvSpPr>
+        <p:spPr>
+          <a:xfrm>
+            <a:off x="1874519" y="2606040"/>
+            <a:ext cx="1280160" cy="365760"/>
+          </a:xfrm>
+          <a:prstGeom prst="roundRect">
+            <a:avLst/>
+          </a:prstGeom>
+          <a:solidFill>
+            <a:srgbClr val="C62828"/>
+          </a:solidFill>
+          <a:ln>
+            <a:noFill/>
+          </a:ln>
+        </p:spPr>
+        <p:style>
+          <a:lnRef idx="1">
+            <a:schemeClr val="accent1"/>
+          </a:lnRef>
+          <a:fillRef idx="3">
+            <a:schemeClr val="accent1"/>
+          </a:fillRef>
+          <a:effectRef idx="2">
+            <a:schemeClr val="accent1"/>
+          </a:effectRef>
+          <a:fontRef idx="minor">
+            <a:schemeClr val="lt1"/>
+          </a:fontRef>
+        </p:style>
+        <p:txBody>
+          <a:bodyPr rtlCol="0" anchor="ctr"/>
+          <a:lstStyle/>
+          <a:p>
+            <a:pPr algn="ctr">
+              <a:defRPr sz="1400" b="1">
+                <a:solidFill>
+                  <a:srgbClr val="FFFFFF"/>
+                </a:solidFill>
+                <a:latin typeface="Calibri"/>
+              </a:defRPr>
+            </a:pPr>
+            <a:r>
+              <a:t>FAIL</a:t>
+            </a:r>
+          </a:p>
+        </p:txBody>
+      </p:sp>
+      <p:sp>
+        <p:nvSpPr>
+          <p:cNvPr id="10" name="TextBox 9"/>
+          <p:cNvSpPr txBox="1"/>
+          <p:nvPr/>
+        </p:nvSpPr>
+        <p:spPr>
+          <a:xfrm>
+            <a:off x="1005840" y="3108960"/>
+            <a:ext cx="3017520" cy="411480"/>
+          </a:xfrm>
+          <a:prstGeom prst="rect">
+            <a:avLst/>
+          </a:prstGeom>
+          <a:noFill/>
+        </p:spPr>
+        <p:txBody>
+          <a:bodyPr wrap="square">
+            <a:spAutoFit/>
+          </a:bodyPr>
+          <a:lstStyle/>
+          <a:p>
+            <a:pPr algn="l">
+              <a:defRPr sz="1200" b="0">
                 <a:solidFill>
                   <a:srgbClr val="2D2D2D"/>
                 </a:solidFill>
                 <a:latin typeface="Calibri"/>
-              </a:rPr>
-              <a:t>Agent checked the source data: actual assessment was $53,155</a:t>
-            </a:r>
-          </a:p>
-          <a:p>
-            <a:pPr>
-              <a:spcAft>
-                <a:spcPts val="600"/>
-              </a:spcAft>
-            </a:pPr>
-            <a:r>
-              <a:rPr sz="1800">
+              </a:defRPr>
+            </a:pPr>
+            <a:r>
+              <a:t>Found: Sheriff Report interview</a:t>
+            </a:r>
+          </a:p>
+        </p:txBody>
+      </p:sp>
+      <p:sp>
+        <p:nvSpPr>
+          <p:cNvPr id="11" name="TextBox 10"/>
+          <p:cNvSpPr txBox="1"/>
+          <p:nvPr/>
+        </p:nvSpPr>
+        <p:spPr>
+          <a:xfrm>
+            <a:off x="1005840" y="3520440"/>
+            <a:ext cx="3017520" cy="411480"/>
+          </a:xfrm>
+          <a:prstGeom prst="rect">
+            <a:avLst/>
+          </a:prstGeom>
+          <a:noFill/>
+        </p:spPr>
+        <p:txBody>
+          <a:bodyPr wrap="square">
+            <a:spAutoFit/>
+          </a:bodyPr>
+          <a:lstStyle/>
+          <a:p>
+            <a:pPr algn="l">
+              <a:defRPr sz="1200" b="1">
+                <a:solidFill>
+                  <a:srgbClr val="C62828"/>
+                </a:solidFill>
+                <a:latin typeface="Calibri"/>
+              </a:defRPr>
+            </a:pPr>
+            <a:r>
+              <a:t>Missed: Nursing notes in Medical Records</a:t>
+            </a:r>
+          </a:p>
+        </p:txBody>
+      </p:sp>
+      <p:sp>
+        <p:nvSpPr>
+          <p:cNvPr id="12" name="TextBox 11"/>
+          <p:cNvSpPr txBox="1"/>
+          <p:nvPr/>
+        </p:nvSpPr>
+        <p:spPr>
+          <a:xfrm>
+            <a:off x="1005840" y="4023360"/>
+            <a:ext cx="3017520" cy="1097280"/>
+          </a:xfrm>
+          <a:prstGeom prst="rect">
+            <a:avLst/>
+          </a:prstGeom>
+          <a:noFill/>
+        </p:spPr>
+        <p:txBody>
+          <a:bodyPr wrap="square">
+            <a:spAutoFit/>
+          </a:bodyPr>
+          <a:lstStyle/>
+          <a:p>
+            <a:pPr algn="l">
+              <a:defRPr sz="1100" b="0">
+                <a:solidFill>
+                  <a:srgbClr val="555555"/>
+                </a:solidFill>
+                <a:latin typeface="Calibri"/>
+              </a:defRPr>
+            </a:pPr>
+            <a:r>
+              <a:t>The agent has no reason to look</a:t>
+            </a:r>
+            <a:br/>
+            <a:r>
+              <a:t>in a medical record for</a:t>
+            </a:r>
+            <a:br/>
+            <a:r>
+              <a:t>parent statements.</a:t>
+            </a:r>
+          </a:p>
+        </p:txBody>
+      </p:sp>
+      <p:sp>
+        <p:nvSpPr>
+          <p:cNvPr id="13" name="Rounded Rectangle 12"/>
+          <p:cNvSpPr/>
+          <p:nvPr/>
+        </p:nvSpPr>
+        <p:spPr>
+          <a:xfrm>
+            <a:off x="4572000" y="2057400"/>
+            <a:ext cx="3383280" cy="3383280"/>
+          </a:xfrm>
+          <a:prstGeom prst="roundRect">
+            <a:avLst/>
+          </a:prstGeom>
+          <a:solidFill>
+            <a:srgbClr val="FFF8E1"/>
+          </a:solidFill>
+          <a:ln>
+            <a:noFill/>
+          </a:ln>
+        </p:spPr>
+        <p:style>
+          <a:lnRef idx="1">
+            <a:schemeClr val="accent1"/>
+          </a:lnRef>
+          <a:fillRef idx="3">
+            <a:schemeClr val="accent1"/>
+          </a:fillRef>
+          <a:effectRef idx="2">
+            <a:schemeClr val="accent1"/>
+          </a:effectRef>
+          <a:fontRef idx="minor">
+            <a:schemeClr val="lt1"/>
+          </a:fontRef>
+        </p:style>
+        <p:txBody>
+          <a:bodyPr rtlCol="0" anchor="ctr"/>
+          <a:lstStyle/>
+          <a:p>
+            <a:pPr algn="ctr"/>
+          </a:p>
+        </p:txBody>
+      </p:sp>
+      <p:sp>
+        <p:nvSpPr>
+          <p:cNvPr id="14" name="Rectangle 13"/>
+          <p:cNvSpPr/>
+          <p:nvPr/>
+        </p:nvSpPr>
+        <p:spPr>
+          <a:xfrm>
+            <a:off x="4572000" y="2057400"/>
+            <a:ext cx="3383280" cy="109728"/>
+          </a:xfrm>
+          <a:prstGeom prst="rect">
+            <a:avLst/>
+          </a:prstGeom>
+          <a:solidFill>
+            <a:srgbClr val="F9A825"/>
+          </a:solidFill>
+          <a:ln>
+            <a:noFill/>
+          </a:ln>
+        </p:spPr>
+        <p:style>
+          <a:lnRef idx="1">
+            <a:schemeClr val="accent1"/>
+          </a:lnRef>
+          <a:fillRef idx="3">
+            <a:schemeClr val="accent1"/>
+          </a:fillRef>
+          <a:effectRef idx="2">
+            <a:schemeClr val="accent1"/>
+          </a:effectRef>
+          <a:fontRef idx="minor">
+            <a:schemeClr val="lt1"/>
+          </a:fontRef>
+        </p:style>
+        <p:txBody>
+          <a:bodyPr rtlCol="0" anchor="ctr"/>
+          <a:lstStyle/>
+          <a:p>
+            <a:pPr algn="ctr"/>
+          </a:p>
+        </p:txBody>
+      </p:sp>
+      <p:sp>
+        <p:nvSpPr>
+          <p:cNvPr id="15" name="TextBox 14"/>
+          <p:cNvSpPr txBox="1"/>
+          <p:nvPr/>
+        </p:nvSpPr>
+        <p:spPr>
+          <a:xfrm>
+            <a:off x="4709160" y="2240280"/>
+            <a:ext cx="3108960" cy="320040"/>
+          </a:xfrm>
+          <a:prstGeom prst="rect">
+            <a:avLst/>
+          </a:prstGeom>
+          <a:noFill/>
+        </p:spPr>
+        <p:txBody>
+          <a:bodyPr wrap="square">
+            <a:spAutoFit/>
+          </a:bodyPr>
+          <a:lstStyle/>
+          <a:p>
+            <a:pPr algn="ctr">
+              <a:defRPr sz="1600" b="1">
                 <a:solidFill>
                   <a:srgbClr val="2D2D2D"/>
                 </a:solidFill>
                 <a:latin typeface="Calibri"/>
-              </a:rPr>
-              <a:t>Recalculated using verified numbers instead of the prompt's numbers</a:t>
-            </a:r>
-          </a:p>
-          <a:p>
-            <a:pPr>
-              <a:spcAft>
-                <a:spcPts val="600"/>
-              </a:spcAft>
-            </a:pPr>
-            <a:r>
-              <a:rPr sz="1800">
+              </a:defRPr>
+            </a:pPr>
+            <a:r>
+              <a:t>Cross-Referenced</a:t>
+            </a:r>
+          </a:p>
+        </p:txBody>
+      </p:sp>
+      <p:sp>
+        <p:nvSpPr>
+          <p:cNvPr id="16" name="Rounded Rectangle 15"/>
+          <p:cNvSpPr/>
+          <p:nvPr/>
+        </p:nvSpPr>
+        <p:spPr>
+          <a:xfrm>
+            <a:off x="5623560" y="2606040"/>
+            <a:ext cx="1280160" cy="365760"/>
+          </a:xfrm>
+          <a:prstGeom prst="roundRect">
+            <a:avLst/>
+          </a:prstGeom>
+          <a:solidFill>
+            <a:srgbClr val="F9A825"/>
+          </a:solidFill>
+          <a:ln>
+            <a:noFill/>
+          </a:ln>
+        </p:spPr>
+        <p:style>
+          <a:lnRef idx="1">
+            <a:schemeClr val="accent1"/>
+          </a:lnRef>
+          <a:fillRef idx="3">
+            <a:schemeClr val="accent1"/>
+          </a:fillRef>
+          <a:effectRef idx="2">
+            <a:schemeClr val="accent1"/>
+          </a:effectRef>
+          <a:fontRef idx="minor">
+            <a:schemeClr val="lt1"/>
+          </a:fontRef>
+        </p:style>
+        <p:txBody>
+          <a:bodyPr rtlCol="0" anchor="ctr"/>
+          <a:lstStyle/>
+          <a:p>
+            <a:pPr algn="ctr">
+              <a:defRPr sz="1400" b="1">
+                <a:solidFill>
+                  <a:srgbClr val="FFFFFF"/>
+                </a:solidFill>
+                <a:latin typeface="Calibri"/>
+              </a:defRPr>
+            </a:pPr>
+            <a:r>
+              <a:t>PARTIAL</a:t>
+            </a:r>
+          </a:p>
+        </p:txBody>
+      </p:sp>
+      <p:sp>
+        <p:nvSpPr>
+          <p:cNvPr id="17" name="TextBox 16"/>
+          <p:cNvSpPr txBox="1"/>
+          <p:nvPr/>
+        </p:nvSpPr>
+        <p:spPr>
+          <a:xfrm>
+            <a:off x="4754880" y="3108960"/>
+            <a:ext cx="3017520" cy="411480"/>
+          </a:xfrm>
+          <a:prstGeom prst="rect">
+            <a:avLst/>
+          </a:prstGeom>
+          <a:noFill/>
+        </p:spPr>
+        <p:txBody>
+          <a:bodyPr wrap="square">
+            <a:spAutoFit/>
+          </a:bodyPr>
+          <a:lstStyle/>
+          <a:p>
+            <a:pPr algn="l">
+              <a:defRPr sz="1200" b="0">
                 <a:solidFill>
                   <a:srgbClr val="2D2D2D"/>
                 </a:solidFill>
                 <a:latin typeface="Calibri"/>
-              </a:rPr>
-              <a:t>No other agent questioned the input</a:t>
-            </a:r>
-          </a:p>
-        </p:txBody>
-      </p:sp>
-      <p:sp>
-        <p:nvSpPr>
-          <p:cNvPr id="6" name="Rounded Rectangle 5"/>
+              </a:defRPr>
+            </a:pPr>
+            <a:r>
+              <a:t>Found: Both sources identified</a:t>
+            </a:r>
+          </a:p>
+        </p:txBody>
+      </p:sp>
+      <p:sp>
+        <p:nvSpPr>
+          <p:cNvPr id="18" name="TextBox 17"/>
+          <p:cNvSpPr txBox="1"/>
+          <p:nvPr/>
+        </p:nvSpPr>
+        <p:spPr>
+          <a:xfrm>
+            <a:off x="4754880" y="3520440"/>
+            <a:ext cx="3017520" cy="411480"/>
+          </a:xfrm>
+          <a:prstGeom prst="rect">
+            <a:avLst/>
+          </a:prstGeom>
+          <a:noFill/>
+        </p:spPr>
+        <p:txBody>
+          <a:bodyPr wrap="square">
+            <a:spAutoFit/>
+          </a:bodyPr>
+          <a:lstStyle/>
+          <a:p>
+            <a:pPr algn="l">
+              <a:defRPr sz="1200" b="1">
+                <a:solidFill>
+                  <a:srgbClr val="F9A825"/>
+                </a:solidFill>
+                <a:latin typeface="Calibri"/>
+              </a:defRPr>
+            </a:pPr>
+            <a:r>
+              <a:t>Missed: Specific nursing note detail</a:t>
+            </a:r>
+          </a:p>
+        </p:txBody>
+      </p:sp>
+      <p:sp>
+        <p:nvSpPr>
+          <p:cNvPr id="19" name="TextBox 18"/>
+          <p:cNvSpPr txBox="1"/>
+          <p:nvPr/>
+        </p:nvSpPr>
+        <p:spPr>
+          <a:xfrm>
+            <a:off x="4754880" y="4023360"/>
+            <a:ext cx="3017520" cy="1097280"/>
+          </a:xfrm>
+          <a:prstGeom prst="rect">
+            <a:avLst/>
+          </a:prstGeom>
+          <a:noFill/>
+        </p:spPr>
+        <p:txBody>
+          <a:bodyPr wrap="square">
+            <a:spAutoFit/>
+          </a:bodyPr>
+          <a:lstStyle/>
+          <a:p>
+            <a:pPr algn="l">
+              <a:defRPr sz="1100" b="0">
+                <a:solidFill>
+                  <a:srgbClr val="555555"/>
+                </a:solidFill>
+                <a:latin typeface="Calibri"/>
+              </a:defRPr>
+            </a:pPr>
+            <a:r>
+              <a:t>Cross-reference header points to</a:t>
+            </a:r>
+            <a:br/>
+            <a:r>
+              <a:t>Medical Records, but the agent</a:t>
+            </a:r>
+            <a:br/>
+            <a:r>
+              <a:t>still can't find nursing notes.</a:t>
+            </a:r>
+          </a:p>
+        </p:txBody>
+      </p:sp>
+      <p:sp>
+        <p:nvSpPr>
+          <p:cNvPr id="20" name="Rounded Rectangle 19"/>
           <p:cNvSpPr/>
           <p:nvPr/>
         </p:nvSpPr>
         <p:spPr>
           <a:xfrm>
-            <a:off x="1828800" y="4206240"/>
-            <a:ext cx="8503920" cy="1097280"/>
+            <a:off x="8321040" y="2057400"/>
+            <a:ext cx="3383280" cy="3383280"/>
+          </a:xfrm>
+          <a:prstGeom prst="roundRect">
+            <a:avLst/>
+          </a:prstGeom>
+          <a:solidFill>
+            <a:srgbClr val="E8F5E9"/>
+          </a:solidFill>
+          <a:ln>
+            <a:noFill/>
+          </a:ln>
+        </p:spPr>
+        <p:style>
+          <a:lnRef idx="1">
+            <a:schemeClr val="accent1"/>
+          </a:lnRef>
+          <a:fillRef idx="3">
+            <a:schemeClr val="accent1"/>
+          </a:fillRef>
+          <a:effectRef idx="2">
+            <a:schemeClr val="accent1"/>
+          </a:effectRef>
+          <a:fontRef idx="minor">
+            <a:schemeClr val="lt1"/>
+          </a:fontRef>
+        </p:style>
+        <p:txBody>
+          <a:bodyPr rtlCol="0" anchor="ctr"/>
+          <a:lstStyle/>
+          <a:p>
+            <a:pPr algn="ctr"/>
+          </a:p>
+        </p:txBody>
+      </p:sp>
+      <p:sp>
+        <p:nvSpPr>
+          <p:cNvPr id="21" name="Rectangle 20"/>
+          <p:cNvSpPr/>
+          <p:nvPr/>
+        </p:nvSpPr>
+        <p:spPr>
+          <a:xfrm>
+            <a:off x="8321040" y="2057400"/>
+            <a:ext cx="3383280" cy="109728"/>
+          </a:xfrm>
+          <a:prstGeom prst="rect">
+            <a:avLst/>
+          </a:prstGeom>
+          <a:solidFill>
+            <a:srgbClr val="4CAF50"/>
+          </a:solidFill>
+          <a:ln>
+            <a:noFill/>
+          </a:ln>
+        </p:spPr>
+        <p:style>
+          <a:lnRef idx="1">
+            <a:schemeClr val="accent1"/>
+          </a:lnRef>
+          <a:fillRef idx="3">
+            <a:schemeClr val="accent1"/>
+          </a:fillRef>
+          <a:effectRef idx="2">
+            <a:schemeClr val="accent1"/>
+          </a:effectRef>
+          <a:fontRef idx="minor">
+            <a:schemeClr val="lt1"/>
+          </a:fontRef>
+        </p:style>
+        <p:txBody>
+          <a:bodyPr rtlCol="0" anchor="ctr"/>
+          <a:lstStyle/>
+          <a:p>
+            <a:pPr algn="ctr"/>
+          </a:p>
+        </p:txBody>
+      </p:sp>
+      <p:sp>
+        <p:nvSpPr>
+          <p:cNvPr id="22" name="TextBox 21"/>
+          <p:cNvSpPr txBox="1"/>
+          <p:nvPr/>
+        </p:nvSpPr>
+        <p:spPr>
+          <a:xfrm>
+            <a:off x="8458200" y="2240280"/>
+            <a:ext cx="3108960" cy="320040"/>
+          </a:xfrm>
+          <a:prstGeom prst="rect">
+            <a:avLst/>
+          </a:prstGeom>
+          <a:noFill/>
+        </p:spPr>
+        <p:txBody>
+          <a:bodyPr wrap="square">
+            <a:spAutoFit/>
+          </a:bodyPr>
+          <a:lstStyle/>
+          <a:p>
+            <a:pPr algn="ctr">
+              <a:defRPr sz="1600" b="1">
+                <a:solidFill>
+                  <a:srgbClr val="2D2D2D"/>
+                </a:solidFill>
+                <a:latin typeface="Calibri"/>
+              </a:defRPr>
+            </a:pPr>
+            <a:r>
+              <a:t>Enriched + Metadata</a:t>
+            </a:r>
+          </a:p>
+        </p:txBody>
+      </p:sp>
+      <p:sp>
+        <p:nvSpPr>
+          <p:cNvPr id="23" name="Rounded Rectangle 22"/>
+          <p:cNvSpPr/>
+          <p:nvPr/>
+        </p:nvSpPr>
+        <p:spPr>
+          <a:xfrm>
+            <a:off x="9372600" y="2606040"/>
+            <a:ext cx="1280160" cy="365760"/>
+          </a:xfrm>
+          <a:prstGeom prst="roundRect">
+            <a:avLst/>
+          </a:prstGeom>
+          <a:solidFill>
+            <a:srgbClr val="4CAF50"/>
+          </a:solidFill>
+          <a:ln>
+            <a:noFill/>
+          </a:ln>
+        </p:spPr>
+        <p:style>
+          <a:lnRef idx="1">
+            <a:schemeClr val="accent1"/>
+          </a:lnRef>
+          <a:fillRef idx="3">
+            <a:schemeClr val="accent1"/>
+          </a:fillRef>
+          <a:effectRef idx="2">
+            <a:schemeClr val="accent1"/>
+          </a:effectRef>
+          <a:fontRef idx="minor">
+            <a:schemeClr val="lt1"/>
+          </a:fontRef>
+        </p:style>
+        <p:txBody>
+          <a:bodyPr rtlCol="0" anchor="ctr"/>
+          <a:lstStyle/>
+          <a:p>
+            <a:pPr algn="ctr">
+              <a:defRPr sz="1400" b="1">
+                <a:solidFill>
+                  <a:srgbClr val="FFFFFF"/>
+                </a:solidFill>
+                <a:latin typeface="Calibri"/>
+              </a:defRPr>
+            </a:pPr>
+            <a:r>
+              <a:t>PASS</a:t>
+            </a:r>
+          </a:p>
+        </p:txBody>
+      </p:sp>
+      <p:sp>
+        <p:nvSpPr>
+          <p:cNvPr id="24" name="TextBox 23"/>
+          <p:cNvSpPr txBox="1"/>
+          <p:nvPr/>
+        </p:nvSpPr>
+        <p:spPr>
+          <a:xfrm>
+            <a:off x="8503919" y="3108960"/>
+            <a:ext cx="3017520" cy="411480"/>
+          </a:xfrm>
+          <a:prstGeom prst="rect">
+            <a:avLst/>
+          </a:prstGeom>
+          <a:noFill/>
+        </p:spPr>
+        <p:txBody>
+          <a:bodyPr wrap="square">
+            <a:spAutoFit/>
+          </a:bodyPr>
+          <a:lstStyle/>
+          <a:p>
+            <a:pPr algn="l">
+              <a:defRPr sz="1200" b="0">
+                <a:solidFill>
+                  <a:srgbClr val="2D2D2D"/>
+                </a:solidFill>
+                <a:latin typeface="Calibri"/>
+              </a:defRPr>
+            </a:pPr>
+            <a:r>
+              <a:t>Found: Both statements, correct times</a:t>
+            </a:r>
+          </a:p>
+        </p:txBody>
+      </p:sp>
+      <p:sp>
+        <p:nvSpPr>
+          <p:cNvPr id="25" name="TextBox 24"/>
+          <p:cNvSpPr txBox="1"/>
+          <p:nvPr/>
+        </p:nvSpPr>
+        <p:spPr>
+          <a:xfrm>
+            <a:off x="8503919" y="3520440"/>
+            <a:ext cx="3017520" cy="411480"/>
+          </a:xfrm>
+          <a:prstGeom prst="rect">
+            <a:avLst/>
+          </a:prstGeom>
+          <a:noFill/>
+        </p:spPr>
+        <p:txBody>
+          <a:bodyPr wrap="square">
+            <a:spAutoFit/>
+          </a:bodyPr>
+          <a:lstStyle/>
+          <a:p>
+            <a:pPr algn="l">
+              <a:defRPr sz="1200" b="1">
+                <a:solidFill>
+                  <a:srgbClr val="4CAF50"/>
+                </a:solidFill>
+                <a:latin typeface="Calibri"/>
+              </a:defRPr>
+            </a:pPr>
+            <a:r>
+              <a:t>Missed: Nothing</a:t>
+            </a:r>
+          </a:p>
+        </p:txBody>
+      </p:sp>
+      <p:sp>
+        <p:nvSpPr>
+          <p:cNvPr id="26" name="TextBox 25"/>
+          <p:cNvSpPr txBox="1"/>
+          <p:nvPr/>
+        </p:nvSpPr>
+        <p:spPr>
+          <a:xfrm>
+            <a:off x="8503919" y="4023360"/>
+            <a:ext cx="3017520" cy="1097280"/>
+          </a:xfrm>
+          <a:prstGeom prst="rect">
+            <a:avLst/>
+          </a:prstGeom>
+          <a:noFill/>
+        </p:spPr>
+        <p:txBody>
+          <a:bodyPr wrap="square">
+            <a:spAutoFit/>
+          </a:bodyPr>
+          <a:lstStyle/>
+          <a:p>
+            <a:pPr algn="l">
+              <a:defRPr sz="1100" b="0">
+                <a:solidFill>
+                  <a:srgbClr val="555555"/>
+                </a:solidFill>
+                <a:latin typeface="Calibri"/>
+              </a:defRPr>
+            </a:pPr>
+            <a:r>
+              <a:t>SP metadata: "nursing interview,</a:t>
+            </a:r>
+            <a:br/>
+            <a:r>
+              <a:t>parent statements" on Medical</a:t>
+            </a:r>
+            <a:br/>
+            <a:r>
+              <a:t>Records enables retrieval.</a:t>
+            </a:r>
+          </a:p>
+        </p:txBody>
+      </p:sp>
+      <p:sp>
+        <p:nvSpPr>
+          <p:cNvPr id="27" name="Right Arrow 26"/>
+          <p:cNvSpPr/>
+          <p:nvPr/>
+        </p:nvSpPr>
+        <p:spPr>
+          <a:xfrm>
+            <a:off x="4160520" y="3383280"/>
+            <a:ext cx="457200" cy="320040"/>
+          </a:xfrm>
+          <a:prstGeom prst="rightArrow">
+            <a:avLst/>
+          </a:prstGeom>
+          <a:solidFill>
+            <a:srgbClr val="357ABD"/>
+          </a:solidFill>
+          <a:ln>
+            <a:noFill/>
+          </a:ln>
+        </p:spPr>
+        <p:style>
+          <a:lnRef idx="1">
+            <a:schemeClr val="accent1"/>
+          </a:lnRef>
+          <a:fillRef idx="3">
+            <a:schemeClr val="accent1"/>
+          </a:fillRef>
+          <a:effectRef idx="2">
+            <a:schemeClr val="accent1"/>
+          </a:effectRef>
+          <a:fontRef idx="minor">
+            <a:schemeClr val="lt1"/>
+          </a:fontRef>
+        </p:style>
+        <p:txBody>
+          <a:bodyPr rtlCol="0" anchor="ctr"/>
+          <a:lstStyle/>
+          <a:p>
+            <a:pPr algn="ctr"/>
+          </a:p>
+        </p:txBody>
+      </p:sp>
+      <p:sp>
+        <p:nvSpPr>
+          <p:cNvPr id="28" name="Right Arrow 27"/>
+          <p:cNvSpPr/>
+          <p:nvPr/>
+        </p:nvSpPr>
+        <p:spPr>
+          <a:xfrm>
+            <a:off x="7909559" y="3383280"/>
+            <a:ext cx="457200" cy="320040"/>
+          </a:xfrm>
+          <a:prstGeom prst="rightArrow">
+            <a:avLst/>
+          </a:prstGeom>
+          <a:solidFill>
+            <a:srgbClr val="357ABD"/>
+          </a:solidFill>
+          <a:ln>
+            <a:noFill/>
+          </a:ln>
+        </p:spPr>
+        <p:style>
+          <a:lnRef idx="1">
+            <a:schemeClr val="accent1"/>
+          </a:lnRef>
+          <a:fillRef idx="3">
+            <a:schemeClr val="accent1"/>
+          </a:fillRef>
+          <a:effectRef idx="2">
+            <a:schemeClr val="accent1"/>
+          </a:effectRef>
+          <a:fontRef idx="minor">
+            <a:schemeClr val="lt1"/>
+          </a:fontRef>
+        </p:style>
+        <p:txBody>
+          <a:bodyPr rtlCol="0" anchor="ctr"/>
+          <a:lstStyle/>
+          <a:p>
+            <a:pPr algn="ctr"/>
+          </a:p>
+        </p:txBody>
+      </p:sp>
+      <p:sp>
+        <p:nvSpPr>
+          <p:cNvPr id="29" name="Rounded Rectangle 28"/>
+          <p:cNvSpPr/>
+          <p:nvPr/>
+        </p:nvSpPr>
+        <p:spPr>
+          <a:xfrm>
+            <a:off x="1371600" y="5623560"/>
+            <a:ext cx="9418320" cy="502920"/>
           </a:xfrm>
           <a:prstGeom prst="roundRect">
             <a:avLst/>
@@ -17811,14 +18797,57 @@
       </p:sp>
       <p:sp>
         <p:nvSpPr>
-          <p:cNvPr id="7" name="TextBox 6"/>
+          <p:cNvPr id="30" name="Rectangle 29"/>
+          <p:cNvSpPr/>
+          <p:nvPr/>
+        </p:nvSpPr>
+        <p:spPr>
+          <a:xfrm>
+            <a:off x="1371600" y="5623560"/>
+            <a:ext cx="109728" cy="502920"/>
+          </a:xfrm>
+          <a:prstGeom prst="rect">
+            <a:avLst/>
+          </a:prstGeom>
+          <a:solidFill>
+            <a:srgbClr val="357ABD"/>
+          </a:solidFill>
+          <a:ln>
+            <a:noFill/>
+          </a:ln>
+        </p:spPr>
+        <p:style>
+          <a:lnRef idx="1">
+            <a:schemeClr val="accent1"/>
+          </a:lnRef>
+          <a:fillRef idx="3">
+            <a:schemeClr val="accent1"/>
+          </a:fillRef>
+          <a:effectRef idx="2">
+            <a:schemeClr val="accent1"/>
+          </a:effectRef>
+          <a:fontRef idx="minor">
+            <a:schemeClr val="lt1"/>
+          </a:fontRef>
+        </p:style>
+        <p:txBody>
+          <a:bodyPr rtlCol="0" anchor="ctr"/>
+          <a:lstStyle/>
+          <a:p>
+            <a:pPr algn="ctr"/>
+          </a:p>
+        </p:txBody>
+      </p:sp>
+      <p:sp>
+        <p:nvSpPr>
+          <p:cNvPr id="31" name="TextBox 30"/>
           <p:cNvSpPr txBox="1"/>
           <p:nvPr/>
         </p:nvSpPr>
         <p:spPr>
           <a:xfrm>
-            <a:off x="2011680" y="4251960"/>
-            <a:ext cx="8138160" cy="1005840"/>
+            <a:off x="1645920" y="5669280"/>
+            <a:ext cx="8961120" cy="411480"/>
           </a:xfrm>
           <a:prstGeom prst="rect">
             <a:avLst/>
@@ -17832,58 +18861,22 @@
           <a:lstStyle/>
           <a:p>
             <a:pPr algn="ctr">
-              <a:defRPr sz="1500" b="0">
-                <a:solidFill>
-                  <a:srgbClr val="2C5F8A"/>
-                </a:solidFill>
-                <a:latin typeface="Calibri"/>
-              </a:defRPr>
-            </a:pPr>
-            <a:r>
-              <a:t>"The assessment value in our records is $53,155, not $357,100 as stated in the question. Using the verified assessment value..."</a:t>
-            </a:r>
-          </a:p>
-        </p:txBody>
-      </p:sp>
-      <p:sp>
-        <p:nvSpPr>
-          <p:cNvPr id="8" name="TextBox 7"/>
-          <p:cNvSpPr txBox="1"/>
-          <p:nvPr/>
-        </p:nvSpPr>
-        <p:spPr>
-          <a:xfrm>
-            <a:off x="1097280" y="5486400"/>
-            <a:ext cx="9966960" cy="365760"/>
-          </a:xfrm>
-          <a:prstGeom prst="rect">
-            <a:avLst/>
-          </a:prstGeom>
-          <a:noFill/>
-        </p:spPr>
-        <p:txBody>
-          <a:bodyPr wrap="square">
-            <a:spAutoFit/>
-          </a:bodyPr>
-          <a:lstStyle/>
-          <a:p>
-            <a:pPr algn="ctr">
               <a:defRPr sz="1600" b="1">
                 <a:solidFill>
-                  <a:srgbClr val="555555"/>
-                </a:solidFill>
-                <a:latin typeface="Calibri"/>
-              </a:defRPr>
-            </a:pPr>
-            <a:r>
-              <a:t>This is what custom orchestration enables -- but only with iterative testing.</a:t>
-            </a:r>
-          </a:p>
-        </p:txBody>
-      </p:sp>
-      <p:sp>
-        <p:nvSpPr>
-          <p:cNvPr id="9" name="Rounded Rectangle 8"/>
+                  <a:srgbClr val="1B2A4A"/>
+                </a:solidFill>
+                <a:latin typeface="Calibri"/>
+              </a:defRPr>
+            </a:pPr>
+            <a:r>
+              <a:t>Cross-references fix reasoning errors. Metadata fixes retrieval errors. You need both.</a:t>
+            </a:r>
+          </a:p>
+        </p:txBody>
+      </p:sp>
+      <p:sp>
+        <p:nvSpPr>
+          <p:cNvPr id="32" name="Rounded Rectangle 31"/>
           <p:cNvSpPr/>
           <p:nvPr/>
         </p:nvSpPr>
@@ -17936,7 +18929,7 @@
       </p:sp>
       <p:sp>
         <p:nvSpPr>
-          <p:cNvPr id="10" name="Rounded Rectangle 9"/>
+          <p:cNvPr id="33" name="Rounded Rectangle 32"/>
           <p:cNvSpPr/>
           <p:nvPr/>
         </p:nvSpPr>
@@ -17989,7 +18982,7 @@
       </p:sp>
       <p:sp>
         <p:nvSpPr>
-          <p:cNvPr id="11" name="Rounded Rectangle 10"/>
+          <p:cNvPr id="34" name="Rounded Rectangle 33"/>
           <p:cNvSpPr/>
           <p:nvPr/>
         </p:nvSpPr>
@@ -18042,7 +19035,7 @@
       </p:sp>
       <p:sp>
         <p:nvSpPr>
-          <p:cNvPr id="12" name="Rounded Rectangle 11"/>
+          <p:cNvPr id="35" name="Rounded Rectangle 34"/>
           <p:cNvSpPr/>
           <p:nvPr/>
         </p:nvSpPr>
@@ -18095,7 +19088,7 @@
       </p:sp>
       <p:sp>
         <p:nvSpPr>
-          <p:cNvPr id="13" name="Rounded Rectangle 12"/>
+          <p:cNvPr id="36" name="Rounded Rectangle 35"/>
           <p:cNvSpPr/>
           <p:nvPr/>
         </p:nvSpPr>
@@ -18148,7 +19141,7 @@
       </p:sp>
       <p:sp>
         <p:nvSpPr>
-          <p:cNvPr id="14" name="TextBox 13"/>
+          <p:cNvPr id="37" name="TextBox 36"/>
           <p:cNvSpPr txBox="1"/>
           <p:nvPr/>
         </p:nvSpPr>
@@ -18239,7 +19232,7 @@
               </a:defRPr>
             </a:pPr>
             <a:r>
-              <a:t>Surprising Finding: False Negative</a:t>
+              <a:t>Surprising Finding: Agent Challenged Its Own Premise</a:t>
             </a:r>
           </a:p>
         </p:txBody>
@@ -18318,7 +19311,7 @@
               </a:defRPr>
             </a:pPr>
             <a:r>
-              <a:t>The model retrieved the answer and didn't recognize it</a:t>
+              <a:t>A pro-code agent questioned the question -- and was right</a:t>
             </a:r>
           </a:p>
         </p:txBody>
@@ -18332,7 +19325,7 @@
         <p:spPr>
           <a:xfrm>
             <a:off x="1097280" y="2103120"/>
-            <a:ext cx="9966960" cy="1828800"/>
+            <a:ext cx="9966960" cy="2286000"/>
           </a:xfrm>
           <a:prstGeom prst="rect">
             <a:avLst/>
@@ -18357,7 +19350,7 @@
                 </a:solidFill>
                 <a:latin typeface="Calibri"/>
               </a:rPr>
-              <a:t>Agent called the right tools</a:t>
+              <a:t>Asked about a $146,000 purchase vs a $357,100 assessment</a:t>
             </a:r>
           </a:p>
           <a:p>
@@ -18373,7 +19366,7 @@
                 </a:solidFill>
                 <a:latin typeface="Calibri"/>
               </a:rPr>
-              <a:t>Received data containing "two positive drug screens (fentanyl)"</a:t>
+              <a:t>Agent checked the source data: actual assessment was $53,155</a:t>
             </a:r>
           </a:p>
           <a:p>
@@ -18389,7 +19382,7 @@
                 </a:solidFill>
                 <a:latin typeface="Calibri"/>
               </a:rPr>
-              <a:t>Concluded: "no drug test results exist in the available data"</a:t>
+              <a:t>Recalculated using verified numbers instead of the prompt's numbers</a:t>
             </a:r>
           </a:p>
           <a:p>
@@ -18405,7 +19398,7 @@
                 </a:solidFill>
                 <a:latin typeface="Calibri"/>
               </a:rPr>
-              <a:t>Invisible to users: tool calls look correct, answer sounds confident</a:t>
+              <a:t>No other agent questioned the input</a:t>
             </a:r>
           </a:p>
         </p:txBody>
@@ -18418,14 +19411,14 @@
         </p:nvSpPr>
         <p:spPr>
           <a:xfrm>
-            <a:off x="1371600" y="4114800"/>
-            <a:ext cx="4572000" cy="1371600"/>
+            <a:off x="1828800" y="4206240"/>
+            <a:ext cx="8503920" cy="1097280"/>
           </a:xfrm>
           <a:prstGeom prst="roundRect">
             <a:avLst/>
           </a:prstGeom>
           <a:solidFill>
-            <a:srgbClr val="E8F5E9"/>
+            <a:srgbClr val="E3F2FD"/>
           </a:solidFill>
           <a:ln>
             <a:noFill/>
@@ -18461,8 +19454,8 @@
         </p:nvSpPr>
         <p:spPr>
           <a:xfrm>
-            <a:off x="1554480" y="4160520"/>
-            <a:ext cx="4206240" cy="320040"/>
+            <a:off x="2011680" y="4251960"/>
+            <a:ext cx="8138160" cy="1005840"/>
           </a:xfrm>
           <a:prstGeom prst="rect">
             <a:avLst/>
@@ -18476,15 +19469,15 @@
           <a:lstStyle/>
           <a:p>
             <a:pPr algn="ctr">
-              <a:defRPr sz="1300" b="1">
-                <a:solidFill>
-                  <a:srgbClr val="4CAF50"/>
-                </a:solidFill>
-                <a:latin typeface="Calibri"/>
-              </a:defRPr>
-            </a:pPr>
-            <a:r>
-              <a:t>Tool Output (correct)</a:t>
+              <a:defRPr sz="1500" b="0">
+                <a:solidFill>
+                  <a:srgbClr val="2C5F8A"/>
+                </a:solidFill>
+                <a:latin typeface="Calibri"/>
+              </a:defRPr>
+            </a:pPr>
+            <a:r>
+              <a:t>"The assessment value in our records is $53,155, not $357,100 as stated in the question. Using the verified assessment value..."</a:t>
             </a:r>
           </a:p>
         </p:txBody>
@@ -18497,8 +19490,8 @@
         </p:nvSpPr>
         <p:spPr>
           <a:xfrm>
-            <a:off x="1554480" y="4572000"/>
-            <a:ext cx="4206240" cy="731520"/>
+            <a:off x="1097280" y="5486400"/>
+            <a:ext cx="9966960" cy="365760"/>
           </a:xfrm>
           <a:prstGeom prst="rect">
             <a:avLst/>
@@ -18512,19 +19505,15 @@
           <a:lstStyle/>
           <a:p>
             <a:pPr algn="ctr">
-              <a:defRPr sz="1600" b="0">
-                <a:solidFill>
-                  <a:srgbClr val="2D2D2D"/>
-                </a:solidFill>
-                <a:latin typeface="Calibri"/>
-              </a:defRPr>
-            </a:pPr>
-            <a:r>
-              <a:t>"two positive drug screens</a:t>
-            </a:r>
-            <a:br/>
-            <a:r>
-              <a:t>(fentanyl)"</a:t>
+              <a:defRPr sz="1600" b="1">
+                <a:solidFill>
+                  <a:srgbClr val="555555"/>
+                </a:solidFill>
+                <a:latin typeface="Calibri"/>
+              </a:defRPr>
+            </a:pPr>
+            <a:r>
+              <a:t>This is what custom orchestration enables -- but only with iterative testing.</a:t>
             </a:r>
           </a:p>
         </p:txBody>
@@ -18532,161 +19521,6 @@
       <p:sp>
         <p:nvSpPr>
           <p:cNvPr id="9" name="Rounded Rectangle 8"/>
-          <p:cNvSpPr/>
-          <p:nvPr/>
-        </p:nvSpPr>
-        <p:spPr>
-          <a:xfrm>
-            <a:off x="6217920" y="4114800"/>
-            <a:ext cx="4572000" cy="1371600"/>
-          </a:xfrm>
-          <a:prstGeom prst="roundRect">
-            <a:avLst/>
-          </a:prstGeom>
-          <a:solidFill>
-            <a:srgbClr val="FFEBEE"/>
-          </a:solidFill>
-          <a:ln>
-            <a:noFill/>
-          </a:ln>
-        </p:spPr>
-        <p:style>
-          <a:lnRef idx="1">
-            <a:schemeClr val="accent1"/>
-          </a:lnRef>
-          <a:fillRef idx="3">
-            <a:schemeClr val="accent1"/>
-          </a:fillRef>
-          <a:effectRef idx="2">
-            <a:schemeClr val="accent1"/>
-          </a:effectRef>
-          <a:fontRef idx="minor">
-            <a:schemeClr val="lt1"/>
-          </a:fontRef>
-        </p:style>
-        <p:txBody>
-          <a:bodyPr rtlCol="0" anchor="ctr"/>
-          <a:lstStyle/>
-          <a:p>
-            <a:pPr algn="ctr"/>
-          </a:p>
-        </p:txBody>
-      </p:sp>
-      <p:sp>
-        <p:nvSpPr>
-          <p:cNvPr id="10" name="TextBox 9"/>
-          <p:cNvSpPr txBox="1"/>
-          <p:nvPr/>
-        </p:nvSpPr>
-        <p:spPr>
-          <a:xfrm>
-            <a:off x="6400800" y="4160520"/>
-            <a:ext cx="4206240" cy="320040"/>
-          </a:xfrm>
-          <a:prstGeom prst="rect">
-            <a:avLst/>
-          </a:prstGeom>
-          <a:noFill/>
-        </p:spPr>
-        <p:txBody>
-          <a:bodyPr wrap="square">
-            <a:spAutoFit/>
-          </a:bodyPr>
-          <a:lstStyle/>
-          <a:p>
-            <a:pPr algn="ctr">
-              <a:defRPr sz="1300" b="1">
-                <a:solidFill>
-                  <a:srgbClr val="E53935"/>
-                </a:solidFill>
-                <a:latin typeface="Calibri"/>
-              </a:defRPr>
-            </a:pPr>
-            <a:r>
-              <a:t>Agent Conclusion (wrong)</a:t>
-            </a:r>
-          </a:p>
-        </p:txBody>
-      </p:sp>
-      <p:sp>
-        <p:nvSpPr>
-          <p:cNvPr id="11" name="TextBox 10"/>
-          <p:cNvSpPr txBox="1"/>
-          <p:nvPr/>
-        </p:nvSpPr>
-        <p:spPr>
-          <a:xfrm>
-            <a:off x="6400800" y="4572000"/>
-            <a:ext cx="4206240" cy="731520"/>
-          </a:xfrm>
-          <a:prstGeom prst="rect">
-            <a:avLst/>
-          </a:prstGeom>
-          <a:noFill/>
-        </p:spPr>
-        <p:txBody>
-          <a:bodyPr wrap="square">
-            <a:spAutoFit/>
-          </a:bodyPr>
-          <a:lstStyle/>
-          <a:p>
-            <a:pPr algn="ctr">
-              <a:defRPr sz="1600" b="0">
-                <a:solidFill>
-                  <a:srgbClr val="2D2D2D"/>
-                </a:solidFill>
-                <a:latin typeface="Calibri"/>
-              </a:defRPr>
-            </a:pPr>
-            <a:r>
-              <a:t>"no drug test results exist</a:t>
-            </a:r>
-            <a:br/>
-            <a:r>
-              <a:t>in the available data"</a:t>
-            </a:r>
-          </a:p>
-        </p:txBody>
-      </p:sp>
-      <p:sp>
-        <p:nvSpPr>
-          <p:cNvPr id="12" name="TextBox 11"/>
-          <p:cNvSpPr txBox="1"/>
-          <p:nvPr/>
-        </p:nvSpPr>
-        <p:spPr>
-          <a:xfrm>
-            <a:off x="1097280" y="5669280"/>
-            <a:ext cx="9966960" cy="365760"/>
-          </a:xfrm>
-          <a:prstGeom prst="rect">
-            <a:avLst/>
-          </a:prstGeom>
-          <a:noFill/>
-        </p:spPr>
-        <p:txBody>
-          <a:bodyPr wrap="square">
-            <a:spAutoFit/>
-          </a:bodyPr>
-          <a:lstStyle/>
-          <a:p>
-            <a:pPr algn="ctr">
-              <a:defRPr sz="1600" b="1">
-                <a:solidFill>
-                  <a:srgbClr val="C62828"/>
-                </a:solidFill>
-                <a:latin typeface="Calibri"/>
-              </a:defRPr>
-            </a:pPr>
-            <a:r>
-              <a:t>This is why you need ground truth testing. You cannot catch this in production.</a:t>
-            </a:r>
-          </a:p>
-        </p:txBody>
-      </p:sp>
-      <p:sp>
-        <p:nvSpPr>
-          <p:cNvPr id="13" name="Rounded Rectangle 12"/>
           <p:cNvSpPr/>
           <p:nvPr/>
         </p:nvSpPr>
@@ -18739,7 +19573,7 @@
       </p:sp>
       <p:sp>
         <p:nvSpPr>
-          <p:cNvPr id="14" name="Rounded Rectangle 13"/>
+          <p:cNvPr id="10" name="Rounded Rectangle 9"/>
           <p:cNvSpPr/>
           <p:nvPr/>
         </p:nvSpPr>
@@ -18792,7 +19626,7 @@
       </p:sp>
       <p:sp>
         <p:nvSpPr>
-          <p:cNvPr id="15" name="Rounded Rectangle 14"/>
+          <p:cNvPr id="11" name="Rounded Rectangle 10"/>
           <p:cNvSpPr/>
           <p:nvPr/>
         </p:nvSpPr>
@@ -18845,7 +19679,7 @@
       </p:sp>
       <p:sp>
         <p:nvSpPr>
-          <p:cNvPr id="16" name="Rounded Rectangle 15"/>
+          <p:cNvPr id="12" name="Rounded Rectangle 11"/>
           <p:cNvSpPr/>
           <p:nvPr/>
         </p:nvSpPr>
@@ -18898,7 +19732,7 @@
       </p:sp>
       <p:sp>
         <p:nvSpPr>
-          <p:cNvPr id="17" name="Rounded Rectangle 16"/>
+          <p:cNvPr id="13" name="Rounded Rectangle 12"/>
           <p:cNvSpPr/>
           <p:nvPr/>
         </p:nvSpPr>
@@ -18951,7 +19785,7 @@
       </p:sp>
       <p:sp>
         <p:nvSpPr>
-          <p:cNvPr id="18" name="TextBox 17"/>
+          <p:cNvPr id="14" name="TextBox 13"/>
           <p:cNvSpPr txBox="1"/>
           <p:nvPr/>
         </p:nvSpPr>
@@ -19034,7 +19868,7 @@
           <a:lstStyle/>
           <a:p>
             <a:pPr algn="l">
-              <a:defRPr sz="3200" b="1">
+              <a:defRPr sz="2800" b="1">
                 <a:solidFill>
                   <a:srgbClr val="1B2A4A"/>
                 </a:solidFill>
@@ -19042,7 +19876,7 @@
               </a:defRPr>
             </a:pPr>
             <a:r>
-              <a:t>The Bottom Line</a:t>
+              <a:t>Surprising Finding: False Negative</a:t>
             </a:r>
           </a:p>
         </p:txBody>
@@ -19113,7 +19947,7 @@
           <a:lstStyle/>
           <a:p>
             <a:pPr algn="l">
-              <a:defRPr sz="2200" b="1">
+              <a:defRPr sz="2000" b="1">
                 <a:solidFill>
                   <a:srgbClr val="2D2D2D"/>
                 </a:solidFill>
@@ -19121,21 +19955,382 @@
               </a:defRPr>
             </a:pPr>
             <a:r>
-              <a:t>Three numbers to remember</a:t>
-            </a:r>
-          </a:p>
-        </p:txBody>
-      </p:sp>
-      <p:sp>
-        <p:nvSpPr>
-          <p:cNvPr id="5" name="Rounded Rectangle 4"/>
+              <a:t>The model retrieved the answer and didn't recognize it</a:t>
+            </a:r>
+          </a:p>
+        </p:txBody>
+      </p:sp>
+      <p:sp>
+        <p:nvSpPr>
+          <p:cNvPr id="5" name="TextBox 4"/>
+          <p:cNvSpPr txBox="1"/>
+          <p:nvPr/>
+        </p:nvSpPr>
+        <p:spPr>
+          <a:xfrm>
+            <a:off x="1097280" y="2103120"/>
+            <a:ext cx="9966960" cy="1828800"/>
+          </a:xfrm>
+          <a:prstGeom prst="rect">
+            <a:avLst/>
+          </a:prstGeom>
+          <a:noFill/>
+        </p:spPr>
+        <p:txBody>
+          <a:bodyPr wrap="square">
+            <a:spAutoFit/>
+          </a:bodyPr>
+          <a:lstStyle/>
+          <a:p>
+            <a:pPr>
+              <a:spcAft>
+                <a:spcPts val="600"/>
+              </a:spcAft>
+            </a:pPr>
+            <a:r>
+              <a:rPr sz="1800">
+                <a:solidFill>
+                  <a:srgbClr val="2D2D2D"/>
+                </a:solidFill>
+                <a:latin typeface="Calibri"/>
+              </a:rPr>
+              <a:t>Agent called the right tools</a:t>
+            </a:r>
+          </a:p>
+          <a:p>
+            <a:pPr>
+              <a:spcAft>
+                <a:spcPts val="600"/>
+              </a:spcAft>
+            </a:pPr>
+            <a:r>
+              <a:rPr sz="1800">
+                <a:solidFill>
+                  <a:srgbClr val="2D2D2D"/>
+                </a:solidFill>
+                <a:latin typeface="Calibri"/>
+              </a:rPr>
+              <a:t>Received data containing "two positive drug screens (fentanyl)"</a:t>
+            </a:r>
+          </a:p>
+          <a:p>
+            <a:pPr>
+              <a:spcAft>
+                <a:spcPts val="600"/>
+              </a:spcAft>
+            </a:pPr>
+            <a:r>
+              <a:rPr sz="1800">
+                <a:solidFill>
+                  <a:srgbClr val="2D2D2D"/>
+                </a:solidFill>
+                <a:latin typeface="Calibri"/>
+              </a:rPr>
+              <a:t>Concluded: "no drug test results exist in the available data"</a:t>
+            </a:r>
+          </a:p>
+          <a:p>
+            <a:pPr>
+              <a:spcAft>
+                <a:spcPts val="600"/>
+              </a:spcAft>
+            </a:pPr>
+            <a:r>
+              <a:rPr sz="1800">
+                <a:solidFill>
+                  <a:srgbClr val="2D2D2D"/>
+                </a:solidFill>
+                <a:latin typeface="Calibri"/>
+              </a:rPr>
+              <a:t>Invisible to users: tool calls look correct, answer sounds confident</a:t>
+            </a:r>
+          </a:p>
+        </p:txBody>
+      </p:sp>
+      <p:sp>
+        <p:nvSpPr>
+          <p:cNvPr id="6" name="Rounded Rectangle 5"/>
           <p:cNvSpPr/>
           <p:nvPr/>
         </p:nvSpPr>
         <p:spPr>
           <a:xfrm>
-            <a:off x="1097280" y="2103120"/>
-            <a:ext cx="3200400" cy="3200400"/>
+            <a:off x="1371600" y="4114800"/>
+            <a:ext cx="4572000" cy="1371600"/>
+          </a:xfrm>
+          <a:prstGeom prst="roundRect">
+            <a:avLst/>
+          </a:prstGeom>
+          <a:solidFill>
+            <a:srgbClr val="E8F5E9"/>
+          </a:solidFill>
+          <a:ln>
+            <a:noFill/>
+          </a:ln>
+        </p:spPr>
+        <p:style>
+          <a:lnRef idx="1">
+            <a:schemeClr val="accent1"/>
+          </a:lnRef>
+          <a:fillRef idx="3">
+            <a:schemeClr val="accent1"/>
+          </a:fillRef>
+          <a:effectRef idx="2">
+            <a:schemeClr val="accent1"/>
+          </a:effectRef>
+          <a:fontRef idx="minor">
+            <a:schemeClr val="lt1"/>
+          </a:fontRef>
+        </p:style>
+        <p:txBody>
+          <a:bodyPr rtlCol="0" anchor="ctr"/>
+          <a:lstStyle/>
+          <a:p>
+            <a:pPr algn="ctr"/>
+          </a:p>
+        </p:txBody>
+      </p:sp>
+      <p:sp>
+        <p:nvSpPr>
+          <p:cNvPr id="7" name="TextBox 6"/>
+          <p:cNvSpPr txBox="1"/>
+          <p:nvPr/>
+        </p:nvSpPr>
+        <p:spPr>
+          <a:xfrm>
+            <a:off x="1554480" y="4160520"/>
+            <a:ext cx="4206240" cy="320040"/>
+          </a:xfrm>
+          <a:prstGeom prst="rect">
+            <a:avLst/>
+          </a:prstGeom>
+          <a:noFill/>
+        </p:spPr>
+        <p:txBody>
+          <a:bodyPr wrap="square">
+            <a:spAutoFit/>
+          </a:bodyPr>
+          <a:lstStyle/>
+          <a:p>
+            <a:pPr algn="ctr">
+              <a:defRPr sz="1300" b="1">
+                <a:solidFill>
+                  <a:srgbClr val="4CAF50"/>
+                </a:solidFill>
+                <a:latin typeface="Calibri"/>
+              </a:defRPr>
+            </a:pPr>
+            <a:r>
+              <a:t>Tool Output (correct)</a:t>
+            </a:r>
+          </a:p>
+        </p:txBody>
+      </p:sp>
+      <p:sp>
+        <p:nvSpPr>
+          <p:cNvPr id="8" name="TextBox 7"/>
+          <p:cNvSpPr txBox="1"/>
+          <p:nvPr/>
+        </p:nvSpPr>
+        <p:spPr>
+          <a:xfrm>
+            <a:off x="1554480" y="4572000"/>
+            <a:ext cx="4206240" cy="731520"/>
+          </a:xfrm>
+          <a:prstGeom prst="rect">
+            <a:avLst/>
+          </a:prstGeom>
+          <a:noFill/>
+        </p:spPr>
+        <p:txBody>
+          <a:bodyPr wrap="square">
+            <a:spAutoFit/>
+          </a:bodyPr>
+          <a:lstStyle/>
+          <a:p>
+            <a:pPr algn="ctr">
+              <a:defRPr sz="1600" b="0">
+                <a:solidFill>
+                  <a:srgbClr val="2D2D2D"/>
+                </a:solidFill>
+                <a:latin typeface="Calibri"/>
+              </a:defRPr>
+            </a:pPr>
+            <a:r>
+              <a:t>"two positive drug screens</a:t>
+            </a:r>
+            <a:br/>
+            <a:r>
+              <a:t>(fentanyl)"</a:t>
+            </a:r>
+          </a:p>
+        </p:txBody>
+      </p:sp>
+      <p:sp>
+        <p:nvSpPr>
+          <p:cNvPr id="9" name="Rounded Rectangle 8"/>
+          <p:cNvSpPr/>
+          <p:nvPr/>
+        </p:nvSpPr>
+        <p:spPr>
+          <a:xfrm>
+            <a:off x="6217920" y="4114800"/>
+            <a:ext cx="4572000" cy="1371600"/>
+          </a:xfrm>
+          <a:prstGeom prst="roundRect">
+            <a:avLst/>
+          </a:prstGeom>
+          <a:solidFill>
+            <a:srgbClr val="FFEBEE"/>
+          </a:solidFill>
+          <a:ln>
+            <a:noFill/>
+          </a:ln>
+        </p:spPr>
+        <p:style>
+          <a:lnRef idx="1">
+            <a:schemeClr val="accent1"/>
+          </a:lnRef>
+          <a:fillRef idx="3">
+            <a:schemeClr val="accent1"/>
+          </a:fillRef>
+          <a:effectRef idx="2">
+            <a:schemeClr val="accent1"/>
+          </a:effectRef>
+          <a:fontRef idx="minor">
+            <a:schemeClr val="lt1"/>
+          </a:fontRef>
+        </p:style>
+        <p:txBody>
+          <a:bodyPr rtlCol="0" anchor="ctr"/>
+          <a:lstStyle/>
+          <a:p>
+            <a:pPr algn="ctr"/>
+          </a:p>
+        </p:txBody>
+      </p:sp>
+      <p:sp>
+        <p:nvSpPr>
+          <p:cNvPr id="10" name="TextBox 9"/>
+          <p:cNvSpPr txBox="1"/>
+          <p:nvPr/>
+        </p:nvSpPr>
+        <p:spPr>
+          <a:xfrm>
+            <a:off x="6400800" y="4160520"/>
+            <a:ext cx="4206240" cy="320040"/>
+          </a:xfrm>
+          <a:prstGeom prst="rect">
+            <a:avLst/>
+          </a:prstGeom>
+          <a:noFill/>
+        </p:spPr>
+        <p:txBody>
+          <a:bodyPr wrap="square">
+            <a:spAutoFit/>
+          </a:bodyPr>
+          <a:lstStyle/>
+          <a:p>
+            <a:pPr algn="ctr">
+              <a:defRPr sz="1300" b="1">
+                <a:solidFill>
+                  <a:srgbClr val="E53935"/>
+                </a:solidFill>
+                <a:latin typeface="Calibri"/>
+              </a:defRPr>
+            </a:pPr>
+            <a:r>
+              <a:t>Agent Conclusion (wrong)</a:t>
+            </a:r>
+          </a:p>
+        </p:txBody>
+      </p:sp>
+      <p:sp>
+        <p:nvSpPr>
+          <p:cNvPr id="11" name="TextBox 10"/>
+          <p:cNvSpPr txBox="1"/>
+          <p:nvPr/>
+        </p:nvSpPr>
+        <p:spPr>
+          <a:xfrm>
+            <a:off x="6400800" y="4572000"/>
+            <a:ext cx="4206240" cy="731520"/>
+          </a:xfrm>
+          <a:prstGeom prst="rect">
+            <a:avLst/>
+          </a:prstGeom>
+          <a:noFill/>
+        </p:spPr>
+        <p:txBody>
+          <a:bodyPr wrap="square">
+            <a:spAutoFit/>
+          </a:bodyPr>
+          <a:lstStyle/>
+          <a:p>
+            <a:pPr algn="ctr">
+              <a:defRPr sz="1600" b="0">
+                <a:solidFill>
+                  <a:srgbClr val="2D2D2D"/>
+                </a:solidFill>
+                <a:latin typeface="Calibri"/>
+              </a:defRPr>
+            </a:pPr>
+            <a:r>
+              <a:t>"no drug test results exist</a:t>
+            </a:r>
+            <a:br/>
+            <a:r>
+              <a:t>in the available data"</a:t>
+            </a:r>
+          </a:p>
+        </p:txBody>
+      </p:sp>
+      <p:sp>
+        <p:nvSpPr>
+          <p:cNvPr id="12" name="TextBox 11"/>
+          <p:cNvSpPr txBox="1"/>
+          <p:nvPr/>
+        </p:nvSpPr>
+        <p:spPr>
+          <a:xfrm>
+            <a:off x="1097280" y="5669280"/>
+            <a:ext cx="9966960" cy="365760"/>
+          </a:xfrm>
+          <a:prstGeom prst="rect">
+            <a:avLst/>
+          </a:prstGeom>
+          <a:noFill/>
+        </p:spPr>
+        <p:txBody>
+          <a:bodyPr wrap="square">
+            <a:spAutoFit/>
+          </a:bodyPr>
+          <a:lstStyle/>
+          <a:p>
+            <a:pPr algn="ctr">
+              <a:defRPr sz="1600" b="1">
+                <a:solidFill>
+                  <a:srgbClr val="C62828"/>
+                </a:solidFill>
+                <a:latin typeface="Calibri"/>
+              </a:defRPr>
+            </a:pPr>
+            <a:r>
+              <a:t>This is why you need ground truth testing. You cannot catch this in production.</a:t>
+            </a:r>
+          </a:p>
+        </p:txBody>
+      </p:sp>
+      <p:sp>
+        <p:nvSpPr>
+          <p:cNvPr id="13" name="Rounded Rectangle 12"/>
+          <p:cNvSpPr/>
+          <p:nvPr/>
+        </p:nvSpPr>
+        <p:spPr>
+          <a:xfrm>
+            <a:off x="792327" y="6035040"/>
+            <a:ext cx="2011680" cy="411480"/>
           </a:xfrm>
           <a:prstGeom prst="roundRect">
             <a:avLst/>
@@ -19162,37 +20357,11 @@
           </a:fontRef>
         </p:style>
         <p:txBody>
-          <a:bodyPr rtlCol="0" anchor="ctr"/>
-          <a:lstStyle/>
-          <a:p>
-            <a:pPr algn="ctr"/>
-          </a:p>
-        </p:txBody>
-      </p:sp>
-      <p:sp>
-        <p:nvSpPr>
-          <p:cNvPr id="6" name="TextBox 5"/>
-          <p:cNvSpPr txBox="1"/>
-          <p:nvPr/>
-        </p:nvSpPr>
-        <p:spPr>
-          <a:xfrm>
-            <a:off x="1188720" y="2286000"/>
-            <a:ext cx="3017520" cy="1097280"/>
-          </a:xfrm>
-          <a:prstGeom prst="rect">
-            <a:avLst/>
-          </a:prstGeom>
-          <a:noFill/>
-        </p:spPr>
-        <p:txBody>
-          <a:bodyPr wrap="square">
-            <a:spAutoFit/>
-          </a:bodyPr>
+          <a:bodyPr rtlCol="0" anchor="ctr" wrap="none"/>
           <a:lstStyle/>
           <a:p>
             <a:pPr algn="ctr">
-              <a:defRPr sz="4000" b="1">
+              <a:defRPr sz="1200" b="1">
                 <a:solidFill>
                   <a:srgbClr val="FFFFFF"/>
                 </a:solidFill>
@@ -19200,103 +20369,27 @@
               </a:defRPr>
             </a:pPr>
             <a:r>
-              <a:t>8/10</a:t>
-            </a:r>
-          </a:p>
-        </p:txBody>
-      </p:sp>
-      <p:sp>
-        <p:nvSpPr>
-          <p:cNvPr id="7" name="TextBox 6"/>
-          <p:cNvSpPr txBox="1"/>
-          <p:nvPr/>
-        </p:nvSpPr>
-        <p:spPr>
-          <a:xfrm>
-            <a:off x="1188720" y="3474720"/>
-            <a:ext cx="3017520" cy="914400"/>
-          </a:xfrm>
-          <a:prstGeom prst="rect">
-            <a:avLst/>
-          </a:prstGeom>
-          <a:noFill/>
-        </p:spPr>
-        <p:txBody>
-          <a:bodyPr wrap="square">
-            <a:spAutoFit/>
-          </a:bodyPr>
-          <a:lstStyle/>
-          <a:p>
-            <a:pPr algn="ctr">
-              <a:defRPr sz="1500" b="0">
-                <a:solidFill>
-                  <a:srgbClr val="FFFFFF"/>
-                </a:solidFill>
-                <a:latin typeface="Calibri"/>
-              </a:defRPr>
-            </a:pPr>
-            <a:r>
-              <a:t>What you get with</a:t>
-            </a:r>
-            <a:br/>
-            <a:r>
-              <a:t>zero engineering</a:t>
-            </a:r>
-          </a:p>
-        </p:txBody>
-      </p:sp>
-      <p:sp>
-        <p:nvSpPr>
-          <p:cNvPr id="8" name="TextBox 7"/>
-          <p:cNvSpPr txBox="1"/>
-          <p:nvPr/>
-        </p:nvSpPr>
-        <p:spPr>
-          <a:xfrm>
-            <a:off x="1188720" y="4572000"/>
-            <a:ext cx="3017520" cy="457200"/>
-          </a:xfrm>
-          <a:prstGeom prst="rect">
-            <a:avLst/>
-          </a:prstGeom>
-          <a:noFill/>
-        </p:spPr>
-        <p:txBody>
-          <a:bodyPr wrap="square">
-            <a:spAutoFit/>
-          </a:bodyPr>
-          <a:lstStyle/>
-          <a:p>
-            <a:pPr algn="ctr">
-              <a:defRPr sz="1300" b="0">
-                <a:solidFill>
-                  <a:srgbClr val="DDEEFF"/>
-                </a:solidFill>
-                <a:latin typeface="Calibri"/>
-              </a:defRPr>
-            </a:pPr>
-            <a:r>
-              <a:t>Levels 1-2</a:t>
-            </a:r>
-          </a:p>
-        </p:txBody>
-      </p:sp>
-      <p:sp>
-        <p:nvSpPr>
-          <p:cNvPr id="9" name="Rounded Rectangle 8"/>
+              <a:t>L1: Discovery</a:t>
+            </a:r>
+          </a:p>
+        </p:txBody>
+      </p:sp>
+      <p:sp>
+        <p:nvSpPr>
+          <p:cNvPr id="14" name="Rounded Rectangle 13"/>
           <p:cNvSpPr/>
           <p:nvPr/>
         </p:nvSpPr>
         <p:spPr>
           <a:xfrm>
-            <a:off x="4663440" y="2103120"/>
-            <a:ext cx="3200400" cy="3200400"/>
+            <a:off x="2941167" y="6035040"/>
+            <a:ext cx="2011680" cy="411480"/>
           </a:xfrm>
           <a:prstGeom prst="roundRect">
             <a:avLst/>
           </a:prstGeom>
           <a:solidFill>
-            <a:srgbClr val="357ABD"/>
+            <a:srgbClr val="8BC34A"/>
           </a:solidFill>
           <a:ln>
             <a:noFill/>
@@ -19317,37 +20410,11 @@
           </a:fontRef>
         </p:style>
         <p:txBody>
-          <a:bodyPr rtlCol="0" anchor="ctr"/>
-          <a:lstStyle/>
-          <a:p>
-            <a:pPr algn="ctr"/>
-          </a:p>
-        </p:txBody>
-      </p:sp>
-      <p:sp>
-        <p:nvSpPr>
-          <p:cNvPr id="10" name="TextBox 9"/>
-          <p:cNvSpPr txBox="1"/>
-          <p:nvPr/>
-        </p:nvSpPr>
-        <p:spPr>
-          <a:xfrm>
-            <a:off x="4754879" y="2286000"/>
-            <a:ext cx="3017520" cy="1097280"/>
-          </a:xfrm>
-          <a:prstGeom prst="rect">
-            <a:avLst/>
-          </a:prstGeom>
-          <a:noFill/>
-        </p:spPr>
-        <p:txBody>
-          <a:bodyPr wrap="square">
-            <a:spAutoFit/>
-          </a:bodyPr>
+          <a:bodyPr rtlCol="0" anchor="ctr" wrap="none"/>
           <a:lstStyle/>
           <a:p>
             <a:pPr algn="ctr">
-              <a:defRPr sz="4000" b="1">
+              <a:defRPr sz="1200" b="1">
                 <a:solidFill>
                   <a:srgbClr val="FFFFFF"/>
                 </a:solidFill>
@@ -19355,35 +20422,52 @@
               </a:defRPr>
             </a:pPr>
             <a:r>
-              <a:t>9.5/10</a:t>
-            </a:r>
-          </a:p>
-        </p:txBody>
-      </p:sp>
-      <p:sp>
-        <p:nvSpPr>
-          <p:cNvPr id="11" name="TextBox 10"/>
-          <p:cNvSpPr txBox="1"/>
-          <p:nvPr/>
-        </p:nvSpPr>
-        <p:spPr>
-          <a:xfrm>
-            <a:off x="4754879" y="3474720"/>
-            <a:ext cx="3017520" cy="914400"/>
-          </a:xfrm>
-          <a:prstGeom prst="rect">
-            <a:avLst/>
-          </a:prstGeom>
-          <a:noFill/>
-        </p:spPr>
-        <p:txBody>
-          <a:bodyPr wrap="square">
-            <a:spAutoFit/>
-          </a:bodyPr>
+              <a:t>L2: Summarization</a:t>
+            </a:r>
+          </a:p>
+        </p:txBody>
+      </p:sp>
+      <p:sp>
+        <p:nvSpPr>
+          <p:cNvPr id="15" name="Rounded Rectangle 14"/>
+          <p:cNvSpPr/>
+          <p:nvPr/>
+        </p:nvSpPr>
+        <p:spPr>
+          <a:xfrm>
+            <a:off x="5090007" y="6035040"/>
+            <a:ext cx="2011680" cy="411480"/>
+          </a:xfrm>
+          <a:prstGeom prst="roundRect">
+            <a:avLst/>
+          </a:prstGeom>
+          <a:solidFill>
+            <a:srgbClr val="FF9800"/>
+          </a:solidFill>
+          <a:ln>
+            <a:noFill/>
+          </a:ln>
+        </p:spPr>
+        <p:style>
+          <a:lnRef idx="1">
+            <a:schemeClr val="accent1"/>
+          </a:lnRef>
+          <a:fillRef idx="3">
+            <a:schemeClr val="accent1"/>
+          </a:fillRef>
+          <a:effectRef idx="2">
+            <a:schemeClr val="accent1"/>
+          </a:effectRef>
+          <a:fontRef idx="minor">
+            <a:schemeClr val="lt1"/>
+          </a:fontRef>
+        </p:style>
+        <p:txBody>
+          <a:bodyPr rtlCol="0" anchor="ctr" wrap="none"/>
           <a:lstStyle/>
           <a:p>
             <a:pPr algn="ctr">
-              <a:defRPr sz="1500" b="0">
+              <a:defRPr sz="1200" b="1">
                 <a:solidFill>
                   <a:srgbClr val="FFFFFF"/>
                 </a:solidFill>
@@ -19391,61 +20475,74 @@
               </a:defRPr>
             </a:pPr>
             <a:r>
-              <a:t>What you get with</a:t>
-            </a:r>
-            <a:br/>
-            <a:r>
-              <a:t>purpose-built tools + GPT-4.1</a:t>
-            </a:r>
-          </a:p>
-        </p:txBody>
-      </p:sp>
-      <p:sp>
-        <p:nvSpPr>
-          <p:cNvPr id="12" name="TextBox 11"/>
-          <p:cNvSpPr txBox="1"/>
-          <p:nvPr/>
-        </p:nvSpPr>
-        <p:spPr>
-          <a:xfrm>
-            <a:off x="4754879" y="4572000"/>
-            <a:ext cx="3017520" cy="457200"/>
-          </a:xfrm>
-          <a:prstGeom prst="rect">
-            <a:avLst/>
-          </a:prstGeom>
-          <a:noFill/>
-        </p:spPr>
-        <p:txBody>
-          <a:bodyPr wrap="square">
-            <a:spAutoFit/>
-          </a:bodyPr>
+              <a:t>L3: Operational</a:t>
+            </a:r>
+          </a:p>
+        </p:txBody>
+      </p:sp>
+      <p:sp>
+        <p:nvSpPr>
+          <p:cNvPr id="16" name="Rounded Rectangle 15"/>
+          <p:cNvSpPr/>
+          <p:nvPr/>
+        </p:nvSpPr>
+        <p:spPr>
+          <a:xfrm>
+            <a:off x="7238847" y="6035040"/>
+            <a:ext cx="2011680" cy="411480"/>
+          </a:xfrm>
+          <a:prstGeom prst="roundRect">
+            <a:avLst/>
+          </a:prstGeom>
+          <a:solidFill>
+            <a:srgbClr val="F4511E"/>
+          </a:solidFill>
+          <a:ln>
+            <a:noFill/>
+          </a:ln>
+        </p:spPr>
+        <p:style>
+          <a:lnRef idx="1">
+            <a:schemeClr val="accent1"/>
+          </a:lnRef>
+          <a:fillRef idx="3">
+            <a:schemeClr val="accent1"/>
+          </a:fillRef>
+          <a:effectRef idx="2">
+            <a:schemeClr val="accent1"/>
+          </a:effectRef>
+          <a:fontRef idx="minor">
+            <a:schemeClr val="lt1"/>
+          </a:fontRef>
+        </p:style>
+        <p:txBody>
+          <a:bodyPr rtlCol="0" anchor="ctr" wrap="none"/>
           <a:lstStyle/>
           <a:p>
             <a:pPr algn="ctr">
-              <a:defRPr sz="1300" b="0">
-                <a:solidFill>
-                  <a:srgbClr val="DDEEFF"/>
-                </a:solidFill>
-                <a:latin typeface="Calibri"/>
-              </a:defRPr>
-            </a:pPr>
-            <a:r>
-              <a:t>Levels 3-4</a:t>
-            </a:r>
-          </a:p>
-        </p:txBody>
-      </p:sp>
-      <p:sp>
-        <p:nvSpPr>
-          <p:cNvPr id="13" name="Rounded Rectangle 12"/>
+              <a:defRPr sz="1200" b="1">
+                <a:solidFill>
+                  <a:srgbClr val="FFFFFF"/>
+                </a:solidFill>
+                <a:latin typeface="Calibri"/>
+              </a:defRPr>
+            </a:pPr>
+            <a:r>
+              <a:t>L4: Investigative</a:t>
+            </a:r>
+          </a:p>
+        </p:txBody>
+      </p:sp>
+      <p:sp>
+        <p:nvSpPr>
+          <p:cNvPr id="17" name="Rounded Rectangle 16"/>
           <p:cNvSpPr/>
           <p:nvPr/>
         </p:nvSpPr>
         <p:spPr>
           <a:xfrm>
-            <a:off x="8229600" y="2103120"/>
-            <a:ext cx="3200400" cy="3200400"/>
+            <a:off x="9387687" y="6035040"/>
+            <a:ext cx="2011680" cy="411480"/>
           </a:xfrm>
           <a:prstGeom prst="roundRect">
             <a:avLst/>
@@ -19472,201 +20569,6 @@
           </a:fontRef>
         </p:style>
         <p:txBody>
-          <a:bodyPr rtlCol="0" anchor="ctr"/>
-          <a:lstStyle/>
-          <a:p>
-            <a:pPr algn="ctr"/>
-          </a:p>
-        </p:txBody>
-      </p:sp>
-      <p:sp>
-        <p:nvSpPr>
-          <p:cNvPr id="14" name="TextBox 13"/>
-          <p:cNvSpPr txBox="1"/>
-          <p:nvPr/>
-        </p:nvSpPr>
-        <p:spPr>
-          <a:xfrm>
-            <a:off x="8321040" y="2286000"/>
-            <a:ext cx="3017520" cy="1097280"/>
-          </a:xfrm>
-          <a:prstGeom prst="rect">
-            <a:avLst/>
-          </a:prstGeom>
-          <a:noFill/>
-        </p:spPr>
-        <p:txBody>
-          <a:bodyPr wrap="square">
-            <a:spAutoFit/>
-          </a:bodyPr>
-          <a:lstStyle/>
-          <a:p>
-            <a:pPr algn="ctr">
-              <a:defRPr sz="4000" b="1">
-                <a:solidFill>
-                  <a:srgbClr val="FFFFFF"/>
-                </a:solidFill>
-                <a:latin typeface="Calibri"/>
-              </a:defRPr>
-            </a:pPr>
-            <a:r>
-              <a:t>Trust</a:t>
-            </a:r>
-            <a:br/>
-            <a:r>
-              <a:t>But Verify</a:t>
-            </a:r>
-          </a:p>
-        </p:txBody>
-      </p:sp>
-      <p:sp>
-        <p:nvSpPr>
-          <p:cNvPr id="15" name="TextBox 14"/>
-          <p:cNvSpPr txBox="1"/>
-          <p:nvPr/>
-        </p:nvSpPr>
-        <p:spPr>
-          <a:xfrm>
-            <a:off x="8321040" y="3474720"/>
-            <a:ext cx="3017520" cy="914400"/>
-          </a:xfrm>
-          <a:prstGeom prst="rect">
-            <a:avLst/>
-          </a:prstGeom>
-          <a:noFill/>
-        </p:spPr>
-        <p:txBody>
-          <a:bodyPr wrap="square">
-            <a:spAutoFit/>
-          </a:bodyPr>
-          <a:lstStyle/>
-          <a:p>
-            <a:pPr algn="ctr">
-              <a:defRPr sz="1500" b="0">
-                <a:solidFill>
-                  <a:srgbClr val="FFFFFF"/>
-                </a:solidFill>
-                <a:latin typeface="Calibri"/>
-              </a:defRPr>
-            </a:pPr>
-            <a:r>
-              <a:t>No score is high enough</a:t>
-            </a:r>
-            <a:br/>
-            <a:r>
-              <a:t>to skip human review</a:t>
-            </a:r>
-          </a:p>
-        </p:txBody>
-      </p:sp>
-      <p:sp>
-        <p:nvSpPr>
-          <p:cNvPr id="16" name="TextBox 15"/>
-          <p:cNvSpPr txBox="1"/>
-          <p:nvPr/>
-        </p:nvSpPr>
-        <p:spPr>
-          <a:xfrm>
-            <a:off x="8321040" y="4572000"/>
-            <a:ext cx="3017520" cy="457200"/>
-          </a:xfrm>
-          <a:prstGeom prst="rect">
-            <a:avLst/>
-          </a:prstGeom>
-          <a:noFill/>
-        </p:spPr>
-        <p:txBody>
-          <a:bodyPr wrap="square">
-            <a:spAutoFit/>
-          </a:bodyPr>
-          <a:lstStyle/>
-          <a:p>
-            <a:pPr algn="ctr">
-              <a:defRPr sz="1300" b="0">
-                <a:solidFill>
-                  <a:srgbClr val="DDEEFF"/>
-                </a:solidFill>
-                <a:latin typeface="Calibri"/>
-              </a:defRPr>
-            </a:pPr>
-            <a:r>
-              <a:t>Level 5</a:t>
-            </a:r>
-          </a:p>
-        </p:txBody>
-      </p:sp>
-      <p:sp>
-        <p:nvSpPr>
-          <p:cNvPr id="17" name="TextBox 16"/>
-          <p:cNvSpPr txBox="1"/>
-          <p:nvPr/>
-        </p:nvSpPr>
-        <p:spPr>
-          <a:xfrm>
-            <a:off x="1097280" y="5486400"/>
-            <a:ext cx="9966960" cy="457200"/>
-          </a:xfrm>
-          <a:prstGeom prst="rect">
-            <a:avLst/>
-          </a:prstGeom>
-          <a:noFill/>
-        </p:spPr>
-        <p:txBody>
-          <a:bodyPr wrap="square">
-            <a:spAutoFit/>
-          </a:bodyPr>
-          <a:lstStyle/>
-          <a:p>
-            <a:pPr algn="ctr">
-              <a:defRPr sz="1500" b="1">
-                <a:solidFill>
-                  <a:srgbClr val="555555"/>
-                </a:solidFill>
-                <a:latin typeface="Calibri"/>
-              </a:defRPr>
-            </a:pPr>
-            <a:r>
-              <a:t>"The question is not 'should we deploy AI?' The question is 'which level are we operating at, and have we invested accordingly?'"</a:t>
-            </a:r>
-          </a:p>
-        </p:txBody>
-      </p:sp>
-      <p:sp>
-        <p:nvSpPr>
-          <p:cNvPr id="18" name="Rounded Rectangle 17"/>
-          <p:cNvSpPr/>
-          <p:nvPr/>
-        </p:nvSpPr>
-        <p:spPr>
-          <a:xfrm>
-            <a:off x="792327" y="6035040"/>
-            <a:ext cx="2011680" cy="411480"/>
-          </a:xfrm>
-          <a:prstGeom prst="roundRect">
-            <a:avLst/>
-          </a:prstGeom>
-          <a:solidFill>
-            <a:srgbClr val="4CAF50"/>
-          </a:solidFill>
-          <a:ln>
-            <a:noFill/>
-          </a:ln>
-        </p:spPr>
-        <p:style>
-          <a:lnRef idx="1">
-            <a:schemeClr val="accent1"/>
-          </a:lnRef>
-          <a:fillRef idx="3">
-            <a:schemeClr val="accent1"/>
-          </a:fillRef>
-          <a:effectRef idx="2">
-            <a:schemeClr val="accent1"/>
-          </a:effectRef>
-          <a:fontRef idx="minor">
-            <a:schemeClr val="lt1"/>
-          </a:fontRef>
-        </p:style>
-        <p:txBody>
           <a:bodyPr rtlCol="0" anchor="ctr" wrap="none"/>
           <a:lstStyle/>
           <a:p>
@@ -19679,218 +20581,6 @@
               </a:defRPr>
             </a:pPr>
             <a:r>
-              <a:t>L1: Discovery</a:t>
-            </a:r>
-          </a:p>
-        </p:txBody>
-      </p:sp>
-      <p:sp>
-        <p:nvSpPr>
-          <p:cNvPr id="19" name="Rounded Rectangle 18"/>
-          <p:cNvSpPr/>
-          <p:nvPr/>
-        </p:nvSpPr>
-        <p:spPr>
-          <a:xfrm>
-            <a:off x="2941167" y="6035040"/>
-            <a:ext cx="2011680" cy="411480"/>
-          </a:xfrm>
-          <a:prstGeom prst="roundRect">
-            <a:avLst/>
-          </a:prstGeom>
-          <a:solidFill>
-            <a:srgbClr val="8BC34A"/>
-          </a:solidFill>
-          <a:ln>
-            <a:noFill/>
-          </a:ln>
-        </p:spPr>
-        <p:style>
-          <a:lnRef idx="1">
-            <a:schemeClr val="accent1"/>
-          </a:lnRef>
-          <a:fillRef idx="3">
-            <a:schemeClr val="accent1"/>
-          </a:fillRef>
-          <a:effectRef idx="2">
-            <a:schemeClr val="accent1"/>
-          </a:effectRef>
-          <a:fontRef idx="minor">
-            <a:schemeClr val="lt1"/>
-          </a:fontRef>
-        </p:style>
-        <p:txBody>
-          <a:bodyPr rtlCol="0" anchor="ctr" wrap="none"/>
-          <a:lstStyle/>
-          <a:p>
-            <a:pPr algn="ctr">
-              <a:defRPr sz="1200" b="1">
-                <a:solidFill>
-                  <a:srgbClr val="FFFFFF"/>
-                </a:solidFill>
-                <a:latin typeface="Calibri"/>
-              </a:defRPr>
-            </a:pPr>
-            <a:r>
-              <a:t>L2: Summarization</a:t>
-            </a:r>
-          </a:p>
-        </p:txBody>
-      </p:sp>
-      <p:sp>
-        <p:nvSpPr>
-          <p:cNvPr id="20" name="Rounded Rectangle 19"/>
-          <p:cNvSpPr/>
-          <p:nvPr/>
-        </p:nvSpPr>
-        <p:spPr>
-          <a:xfrm>
-            <a:off x="5090007" y="6035040"/>
-            <a:ext cx="2011680" cy="411480"/>
-          </a:xfrm>
-          <a:prstGeom prst="roundRect">
-            <a:avLst/>
-          </a:prstGeom>
-          <a:solidFill>
-            <a:srgbClr val="FF9800"/>
-          </a:solidFill>
-          <a:ln>
-            <a:noFill/>
-          </a:ln>
-        </p:spPr>
-        <p:style>
-          <a:lnRef idx="1">
-            <a:schemeClr val="accent1"/>
-          </a:lnRef>
-          <a:fillRef idx="3">
-            <a:schemeClr val="accent1"/>
-          </a:fillRef>
-          <a:effectRef idx="2">
-            <a:schemeClr val="accent1"/>
-          </a:effectRef>
-          <a:fontRef idx="minor">
-            <a:schemeClr val="lt1"/>
-          </a:fontRef>
-        </p:style>
-        <p:txBody>
-          <a:bodyPr rtlCol="0" anchor="ctr" wrap="none"/>
-          <a:lstStyle/>
-          <a:p>
-            <a:pPr algn="ctr">
-              <a:defRPr sz="1200" b="1">
-                <a:solidFill>
-                  <a:srgbClr val="FFFFFF"/>
-                </a:solidFill>
-                <a:latin typeface="Calibri"/>
-              </a:defRPr>
-            </a:pPr>
-            <a:r>
-              <a:t>L3: Operational</a:t>
-            </a:r>
-          </a:p>
-        </p:txBody>
-      </p:sp>
-      <p:sp>
-        <p:nvSpPr>
-          <p:cNvPr id="21" name="Rounded Rectangle 20"/>
-          <p:cNvSpPr/>
-          <p:nvPr/>
-        </p:nvSpPr>
-        <p:spPr>
-          <a:xfrm>
-            <a:off x="7238847" y="6035040"/>
-            <a:ext cx="2011680" cy="411480"/>
-          </a:xfrm>
-          <a:prstGeom prst="roundRect">
-            <a:avLst/>
-          </a:prstGeom>
-          <a:solidFill>
-            <a:srgbClr val="F4511E"/>
-          </a:solidFill>
-          <a:ln>
-            <a:noFill/>
-          </a:ln>
-        </p:spPr>
-        <p:style>
-          <a:lnRef idx="1">
-            <a:schemeClr val="accent1"/>
-          </a:lnRef>
-          <a:fillRef idx="3">
-            <a:schemeClr val="accent1"/>
-          </a:fillRef>
-          <a:effectRef idx="2">
-            <a:schemeClr val="accent1"/>
-          </a:effectRef>
-          <a:fontRef idx="minor">
-            <a:schemeClr val="lt1"/>
-          </a:fontRef>
-        </p:style>
-        <p:txBody>
-          <a:bodyPr rtlCol="0" anchor="ctr" wrap="none"/>
-          <a:lstStyle/>
-          <a:p>
-            <a:pPr algn="ctr">
-              <a:defRPr sz="1200" b="1">
-                <a:solidFill>
-                  <a:srgbClr val="FFFFFF"/>
-                </a:solidFill>
-                <a:latin typeface="Calibri"/>
-              </a:defRPr>
-            </a:pPr>
-            <a:r>
-              <a:t>L4: Investigative</a:t>
-            </a:r>
-          </a:p>
-        </p:txBody>
-      </p:sp>
-      <p:sp>
-        <p:nvSpPr>
-          <p:cNvPr id="22" name="Rounded Rectangle 21"/>
-          <p:cNvSpPr/>
-          <p:nvPr/>
-        </p:nvSpPr>
-        <p:spPr>
-          <a:xfrm>
-            <a:off x="9387687" y="6035040"/>
-            <a:ext cx="2011680" cy="411480"/>
-          </a:xfrm>
-          <a:prstGeom prst="roundRect">
-            <a:avLst/>
-          </a:prstGeom>
-          <a:solidFill>
-            <a:srgbClr val="E53935"/>
-          </a:solidFill>
-          <a:ln>
-            <a:noFill/>
-          </a:ln>
-        </p:spPr>
-        <p:style>
-          <a:lnRef idx="1">
-            <a:schemeClr val="accent1"/>
-          </a:lnRef>
-          <a:fillRef idx="3">
-            <a:schemeClr val="accent1"/>
-          </a:fillRef>
-          <a:effectRef idx="2">
-            <a:schemeClr val="accent1"/>
-          </a:effectRef>
-          <a:fontRef idx="minor">
-            <a:schemeClr val="lt1"/>
-          </a:fontRef>
-        </p:style>
-        <p:txBody>
-          <a:bodyPr rtlCol="0" anchor="ctr" wrap="none"/>
-          <a:lstStyle/>
-          <a:p>
-            <a:pPr algn="ctr">
-              <a:defRPr sz="1200" b="1">
-                <a:solidFill>
-                  <a:srgbClr val="FFFFFF"/>
-                </a:solidFill>
-                <a:latin typeface="Calibri"/>
-              </a:defRPr>
-            </a:pPr>
-            <a:r>
               <a:t>L5: Adjudicative</a:t>
             </a:r>
           </a:p>
@@ -19898,7 +20588,7 @@
       </p:sp>
       <p:sp>
         <p:nvSpPr>
-          <p:cNvPr id="23" name="TextBox 22"/>
+          <p:cNvPr id="18" name="TextBox 17"/>
           <p:cNvSpPr txBox="1"/>
           <p:nvPr/>
         </p:nvSpPr>
@@ -19941,6 +20631,953 @@
 </file>
 
 <file path=ppt/slides/slide25.xml><?xml version="1.0" encoding="utf-8"?>
+<p:sld xmlns:a="http://schemas.openxmlformats.org/drawingml/2006/main" xmlns:p="http://schemas.openxmlformats.org/presentationml/2006/main" xmlns:r="http://schemas.openxmlformats.org/officeDocument/2006/relationships">
+  <p:cSld>
+    <p:bg>
+      <p:bgPr>
+        <a:solidFill>
+          <a:srgbClr val="FFFFFF"/>
+        </a:solidFill>
+        <a:effectLst/>
+      </p:bgPr>
+    </p:bg>
+    <p:spTree>
+      <p:nvGrpSpPr>
+        <p:cNvPr id="1" name=""/>
+        <p:cNvGrpSpPr/>
+        <p:nvPr/>
+      </p:nvGrpSpPr>
+      <p:grpSpPr/>
+      <p:sp>
+        <p:nvSpPr>
+          <p:cNvPr id="2" name="TextBox 1"/>
+          <p:cNvSpPr txBox="1"/>
+          <p:nvPr/>
+        </p:nvSpPr>
+        <p:spPr>
+          <a:xfrm>
+            <a:off x="731520" y="365760"/>
+            <a:ext cx="10698480" cy="640080"/>
+          </a:xfrm>
+          <a:prstGeom prst="rect">
+            <a:avLst/>
+          </a:prstGeom>
+          <a:noFill/>
+        </p:spPr>
+        <p:txBody>
+          <a:bodyPr wrap="square">
+            <a:spAutoFit/>
+          </a:bodyPr>
+          <a:lstStyle/>
+          <a:p>
+            <a:pPr algn="l">
+              <a:defRPr sz="3200" b="1">
+                <a:solidFill>
+                  <a:srgbClr val="1B2A4A"/>
+                </a:solidFill>
+                <a:latin typeface="Calibri"/>
+              </a:defRPr>
+            </a:pPr>
+            <a:r>
+              <a:t>The Bottom Line</a:t>
+            </a:r>
+          </a:p>
+        </p:txBody>
+      </p:sp>
+      <p:sp>
+        <p:nvSpPr>
+          <p:cNvPr id="3" name="Rectangle 2"/>
+          <p:cNvSpPr/>
+          <p:nvPr/>
+        </p:nvSpPr>
+        <p:spPr>
+          <a:xfrm>
+            <a:off x="731520" y="1005840"/>
+            <a:ext cx="1828800" cy="54864"/>
+          </a:xfrm>
+          <a:prstGeom prst="rect">
+            <a:avLst/>
+          </a:prstGeom>
+          <a:solidFill>
+            <a:srgbClr val="357ABD"/>
+          </a:solidFill>
+          <a:ln>
+            <a:noFill/>
+          </a:ln>
+        </p:spPr>
+        <p:style>
+          <a:lnRef idx="1">
+            <a:schemeClr val="accent1"/>
+          </a:lnRef>
+          <a:fillRef idx="3">
+            <a:schemeClr val="accent1"/>
+          </a:fillRef>
+          <a:effectRef idx="2">
+            <a:schemeClr val="accent1"/>
+          </a:effectRef>
+          <a:fontRef idx="minor">
+            <a:schemeClr val="lt1"/>
+          </a:fontRef>
+        </p:style>
+        <p:txBody>
+          <a:bodyPr rtlCol="0" anchor="ctr"/>
+          <a:lstStyle/>
+          <a:p>
+            <a:pPr algn="ctr"/>
+          </a:p>
+        </p:txBody>
+      </p:sp>
+      <p:sp>
+        <p:nvSpPr>
+          <p:cNvPr id="4" name="TextBox 3"/>
+          <p:cNvSpPr txBox="1"/>
+          <p:nvPr/>
+        </p:nvSpPr>
+        <p:spPr>
+          <a:xfrm>
+            <a:off x="1097280" y="1371600"/>
+            <a:ext cx="9966960" cy="457200"/>
+          </a:xfrm>
+          <a:prstGeom prst="rect">
+            <a:avLst/>
+          </a:prstGeom>
+          <a:noFill/>
+        </p:spPr>
+        <p:txBody>
+          <a:bodyPr wrap="square">
+            <a:spAutoFit/>
+          </a:bodyPr>
+          <a:lstStyle/>
+          <a:p>
+            <a:pPr algn="l">
+              <a:defRPr sz="2200" b="1">
+                <a:solidFill>
+                  <a:srgbClr val="2D2D2D"/>
+                </a:solidFill>
+                <a:latin typeface="Calibri"/>
+              </a:defRPr>
+            </a:pPr>
+            <a:r>
+              <a:t>Three numbers to remember</a:t>
+            </a:r>
+          </a:p>
+        </p:txBody>
+      </p:sp>
+      <p:sp>
+        <p:nvSpPr>
+          <p:cNvPr id="5" name="Rounded Rectangle 4"/>
+          <p:cNvSpPr/>
+          <p:nvPr/>
+        </p:nvSpPr>
+        <p:spPr>
+          <a:xfrm>
+            <a:off x="1097280" y="2103120"/>
+            <a:ext cx="3200400" cy="3200400"/>
+          </a:xfrm>
+          <a:prstGeom prst="roundRect">
+            <a:avLst/>
+          </a:prstGeom>
+          <a:solidFill>
+            <a:srgbClr val="4CAF50"/>
+          </a:solidFill>
+          <a:ln>
+            <a:noFill/>
+          </a:ln>
+        </p:spPr>
+        <p:style>
+          <a:lnRef idx="1">
+            <a:schemeClr val="accent1"/>
+          </a:lnRef>
+          <a:fillRef idx="3">
+            <a:schemeClr val="accent1"/>
+          </a:fillRef>
+          <a:effectRef idx="2">
+            <a:schemeClr val="accent1"/>
+          </a:effectRef>
+          <a:fontRef idx="minor">
+            <a:schemeClr val="lt1"/>
+          </a:fontRef>
+        </p:style>
+        <p:txBody>
+          <a:bodyPr rtlCol="0" anchor="ctr"/>
+          <a:lstStyle/>
+          <a:p>
+            <a:pPr algn="ctr"/>
+          </a:p>
+        </p:txBody>
+      </p:sp>
+      <p:sp>
+        <p:nvSpPr>
+          <p:cNvPr id="6" name="TextBox 5"/>
+          <p:cNvSpPr txBox="1"/>
+          <p:nvPr/>
+        </p:nvSpPr>
+        <p:spPr>
+          <a:xfrm>
+            <a:off x="1188720" y="2286000"/>
+            <a:ext cx="3017520" cy="1097280"/>
+          </a:xfrm>
+          <a:prstGeom prst="rect">
+            <a:avLst/>
+          </a:prstGeom>
+          <a:noFill/>
+        </p:spPr>
+        <p:txBody>
+          <a:bodyPr wrap="square">
+            <a:spAutoFit/>
+          </a:bodyPr>
+          <a:lstStyle/>
+          <a:p>
+            <a:pPr algn="ctr">
+              <a:defRPr sz="4000" b="1">
+                <a:solidFill>
+                  <a:srgbClr val="FFFFFF"/>
+                </a:solidFill>
+                <a:latin typeface="Calibri"/>
+              </a:defRPr>
+            </a:pPr>
+            <a:r>
+              <a:t>8/10</a:t>
+            </a:r>
+          </a:p>
+        </p:txBody>
+      </p:sp>
+      <p:sp>
+        <p:nvSpPr>
+          <p:cNvPr id="7" name="TextBox 6"/>
+          <p:cNvSpPr txBox="1"/>
+          <p:nvPr/>
+        </p:nvSpPr>
+        <p:spPr>
+          <a:xfrm>
+            <a:off x="1188720" y="3474720"/>
+            <a:ext cx="3017520" cy="914400"/>
+          </a:xfrm>
+          <a:prstGeom prst="rect">
+            <a:avLst/>
+          </a:prstGeom>
+          <a:noFill/>
+        </p:spPr>
+        <p:txBody>
+          <a:bodyPr wrap="square">
+            <a:spAutoFit/>
+          </a:bodyPr>
+          <a:lstStyle/>
+          <a:p>
+            <a:pPr algn="ctr">
+              <a:defRPr sz="1500" b="0">
+                <a:solidFill>
+                  <a:srgbClr val="FFFFFF"/>
+                </a:solidFill>
+                <a:latin typeface="Calibri"/>
+              </a:defRPr>
+            </a:pPr>
+            <a:r>
+              <a:t>What you get with</a:t>
+            </a:r>
+            <a:br/>
+            <a:r>
+              <a:t>zero engineering</a:t>
+            </a:r>
+          </a:p>
+        </p:txBody>
+      </p:sp>
+      <p:sp>
+        <p:nvSpPr>
+          <p:cNvPr id="8" name="TextBox 7"/>
+          <p:cNvSpPr txBox="1"/>
+          <p:nvPr/>
+        </p:nvSpPr>
+        <p:spPr>
+          <a:xfrm>
+            <a:off x="1188720" y="4572000"/>
+            <a:ext cx="3017520" cy="457200"/>
+          </a:xfrm>
+          <a:prstGeom prst="rect">
+            <a:avLst/>
+          </a:prstGeom>
+          <a:noFill/>
+        </p:spPr>
+        <p:txBody>
+          <a:bodyPr wrap="square">
+            <a:spAutoFit/>
+          </a:bodyPr>
+          <a:lstStyle/>
+          <a:p>
+            <a:pPr algn="ctr">
+              <a:defRPr sz="1300" b="0">
+                <a:solidFill>
+                  <a:srgbClr val="DDEEFF"/>
+                </a:solidFill>
+                <a:latin typeface="Calibri"/>
+              </a:defRPr>
+            </a:pPr>
+            <a:r>
+              <a:t>Levels 1-2</a:t>
+            </a:r>
+          </a:p>
+        </p:txBody>
+      </p:sp>
+      <p:sp>
+        <p:nvSpPr>
+          <p:cNvPr id="9" name="Rounded Rectangle 8"/>
+          <p:cNvSpPr/>
+          <p:nvPr/>
+        </p:nvSpPr>
+        <p:spPr>
+          <a:xfrm>
+            <a:off x="4663440" y="2103120"/>
+            <a:ext cx="3200400" cy="3200400"/>
+          </a:xfrm>
+          <a:prstGeom prst="roundRect">
+            <a:avLst/>
+          </a:prstGeom>
+          <a:solidFill>
+            <a:srgbClr val="357ABD"/>
+          </a:solidFill>
+          <a:ln>
+            <a:noFill/>
+          </a:ln>
+        </p:spPr>
+        <p:style>
+          <a:lnRef idx="1">
+            <a:schemeClr val="accent1"/>
+          </a:lnRef>
+          <a:fillRef idx="3">
+            <a:schemeClr val="accent1"/>
+          </a:fillRef>
+          <a:effectRef idx="2">
+            <a:schemeClr val="accent1"/>
+          </a:effectRef>
+          <a:fontRef idx="minor">
+            <a:schemeClr val="lt1"/>
+          </a:fontRef>
+        </p:style>
+        <p:txBody>
+          <a:bodyPr rtlCol="0" anchor="ctr"/>
+          <a:lstStyle/>
+          <a:p>
+            <a:pPr algn="ctr"/>
+          </a:p>
+        </p:txBody>
+      </p:sp>
+      <p:sp>
+        <p:nvSpPr>
+          <p:cNvPr id="10" name="TextBox 9"/>
+          <p:cNvSpPr txBox="1"/>
+          <p:nvPr/>
+        </p:nvSpPr>
+        <p:spPr>
+          <a:xfrm>
+            <a:off x="4754879" y="2286000"/>
+            <a:ext cx="3017520" cy="1097280"/>
+          </a:xfrm>
+          <a:prstGeom prst="rect">
+            <a:avLst/>
+          </a:prstGeom>
+          <a:noFill/>
+        </p:spPr>
+        <p:txBody>
+          <a:bodyPr wrap="square">
+            <a:spAutoFit/>
+          </a:bodyPr>
+          <a:lstStyle/>
+          <a:p>
+            <a:pPr algn="ctr">
+              <a:defRPr sz="4000" b="1">
+                <a:solidFill>
+                  <a:srgbClr val="FFFFFF"/>
+                </a:solidFill>
+                <a:latin typeface="Calibri"/>
+              </a:defRPr>
+            </a:pPr>
+            <a:r>
+              <a:t>9.5/10</a:t>
+            </a:r>
+          </a:p>
+        </p:txBody>
+      </p:sp>
+      <p:sp>
+        <p:nvSpPr>
+          <p:cNvPr id="11" name="TextBox 10"/>
+          <p:cNvSpPr txBox="1"/>
+          <p:nvPr/>
+        </p:nvSpPr>
+        <p:spPr>
+          <a:xfrm>
+            <a:off x="4754879" y="3474720"/>
+            <a:ext cx="3017520" cy="914400"/>
+          </a:xfrm>
+          <a:prstGeom prst="rect">
+            <a:avLst/>
+          </a:prstGeom>
+          <a:noFill/>
+        </p:spPr>
+        <p:txBody>
+          <a:bodyPr wrap="square">
+            <a:spAutoFit/>
+          </a:bodyPr>
+          <a:lstStyle/>
+          <a:p>
+            <a:pPr algn="ctr">
+              <a:defRPr sz="1500" b="0">
+                <a:solidFill>
+                  <a:srgbClr val="FFFFFF"/>
+                </a:solidFill>
+                <a:latin typeface="Calibri"/>
+              </a:defRPr>
+            </a:pPr>
+            <a:r>
+              <a:t>What you get with</a:t>
+            </a:r>
+            <a:br/>
+            <a:r>
+              <a:t>purpose-built tools + GPT-4.1</a:t>
+            </a:r>
+          </a:p>
+        </p:txBody>
+      </p:sp>
+      <p:sp>
+        <p:nvSpPr>
+          <p:cNvPr id="12" name="TextBox 11"/>
+          <p:cNvSpPr txBox="1"/>
+          <p:nvPr/>
+        </p:nvSpPr>
+        <p:spPr>
+          <a:xfrm>
+            <a:off x="4754879" y="4572000"/>
+            <a:ext cx="3017520" cy="457200"/>
+          </a:xfrm>
+          <a:prstGeom prst="rect">
+            <a:avLst/>
+          </a:prstGeom>
+          <a:noFill/>
+        </p:spPr>
+        <p:txBody>
+          <a:bodyPr wrap="square">
+            <a:spAutoFit/>
+          </a:bodyPr>
+          <a:lstStyle/>
+          <a:p>
+            <a:pPr algn="ctr">
+              <a:defRPr sz="1300" b="0">
+                <a:solidFill>
+                  <a:srgbClr val="DDEEFF"/>
+                </a:solidFill>
+                <a:latin typeface="Calibri"/>
+              </a:defRPr>
+            </a:pPr>
+            <a:r>
+              <a:t>Levels 3-4</a:t>
+            </a:r>
+          </a:p>
+        </p:txBody>
+      </p:sp>
+      <p:sp>
+        <p:nvSpPr>
+          <p:cNvPr id="13" name="Rounded Rectangle 12"/>
+          <p:cNvSpPr/>
+          <p:nvPr/>
+        </p:nvSpPr>
+        <p:spPr>
+          <a:xfrm>
+            <a:off x="8229600" y="2103120"/>
+            <a:ext cx="3200400" cy="3200400"/>
+          </a:xfrm>
+          <a:prstGeom prst="roundRect">
+            <a:avLst/>
+          </a:prstGeom>
+          <a:solidFill>
+            <a:srgbClr val="E53935"/>
+          </a:solidFill>
+          <a:ln>
+            <a:noFill/>
+          </a:ln>
+        </p:spPr>
+        <p:style>
+          <a:lnRef idx="1">
+            <a:schemeClr val="accent1"/>
+          </a:lnRef>
+          <a:fillRef idx="3">
+            <a:schemeClr val="accent1"/>
+          </a:fillRef>
+          <a:effectRef idx="2">
+            <a:schemeClr val="accent1"/>
+          </a:effectRef>
+          <a:fontRef idx="minor">
+            <a:schemeClr val="lt1"/>
+          </a:fontRef>
+        </p:style>
+        <p:txBody>
+          <a:bodyPr rtlCol="0" anchor="ctr"/>
+          <a:lstStyle/>
+          <a:p>
+            <a:pPr algn="ctr"/>
+          </a:p>
+        </p:txBody>
+      </p:sp>
+      <p:sp>
+        <p:nvSpPr>
+          <p:cNvPr id="14" name="TextBox 13"/>
+          <p:cNvSpPr txBox="1"/>
+          <p:nvPr/>
+        </p:nvSpPr>
+        <p:spPr>
+          <a:xfrm>
+            <a:off x="8321040" y="2286000"/>
+            <a:ext cx="3017520" cy="1097280"/>
+          </a:xfrm>
+          <a:prstGeom prst="rect">
+            <a:avLst/>
+          </a:prstGeom>
+          <a:noFill/>
+        </p:spPr>
+        <p:txBody>
+          <a:bodyPr wrap="square">
+            <a:spAutoFit/>
+          </a:bodyPr>
+          <a:lstStyle/>
+          <a:p>
+            <a:pPr algn="ctr">
+              <a:defRPr sz="4000" b="1">
+                <a:solidFill>
+                  <a:srgbClr val="FFFFFF"/>
+                </a:solidFill>
+                <a:latin typeface="Calibri"/>
+              </a:defRPr>
+            </a:pPr>
+            <a:r>
+              <a:t>Trust</a:t>
+            </a:r>
+            <a:br/>
+            <a:r>
+              <a:t>But Verify</a:t>
+            </a:r>
+          </a:p>
+        </p:txBody>
+      </p:sp>
+      <p:sp>
+        <p:nvSpPr>
+          <p:cNvPr id="15" name="TextBox 14"/>
+          <p:cNvSpPr txBox="1"/>
+          <p:nvPr/>
+        </p:nvSpPr>
+        <p:spPr>
+          <a:xfrm>
+            <a:off x="8321040" y="3474720"/>
+            <a:ext cx="3017520" cy="914400"/>
+          </a:xfrm>
+          <a:prstGeom prst="rect">
+            <a:avLst/>
+          </a:prstGeom>
+          <a:noFill/>
+        </p:spPr>
+        <p:txBody>
+          <a:bodyPr wrap="square">
+            <a:spAutoFit/>
+          </a:bodyPr>
+          <a:lstStyle/>
+          <a:p>
+            <a:pPr algn="ctr">
+              <a:defRPr sz="1500" b="0">
+                <a:solidFill>
+                  <a:srgbClr val="FFFFFF"/>
+                </a:solidFill>
+                <a:latin typeface="Calibri"/>
+              </a:defRPr>
+            </a:pPr>
+            <a:r>
+              <a:t>No score is high enough</a:t>
+            </a:r>
+            <a:br/>
+            <a:r>
+              <a:t>to skip human review</a:t>
+            </a:r>
+          </a:p>
+        </p:txBody>
+      </p:sp>
+      <p:sp>
+        <p:nvSpPr>
+          <p:cNvPr id="16" name="TextBox 15"/>
+          <p:cNvSpPr txBox="1"/>
+          <p:nvPr/>
+        </p:nvSpPr>
+        <p:spPr>
+          <a:xfrm>
+            <a:off x="8321040" y="4572000"/>
+            <a:ext cx="3017520" cy="457200"/>
+          </a:xfrm>
+          <a:prstGeom prst="rect">
+            <a:avLst/>
+          </a:prstGeom>
+          <a:noFill/>
+        </p:spPr>
+        <p:txBody>
+          <a:bodyPr wrap="square">
+            <a:spAutoFit/>
+          </a:bodyPr>
+          <a:lstStyle/>
+          <a:p>
+            <a:pPr algn="ctr">
+              <a:defRPr sz="1300" b="0">
+                <a:solidFill>
+                  <a:srgbClr val="DDEEFF"/>
+                </a:solidFill>
+                <a:latin typeface="Calibri"/>
+              </a:defRPr>
+            </a:pPr>
+            <a:r>
+              <a:t>Level 5</a:t>
+            </a:r>
+          </a:p>
+        </p:txBody>
+      </p:sp>
+      <p:sp>
+        <p:nvSpPr>
+          <p:cNvPr id="17" name="TextBox 16"/>
+          <p:cNvSpPr txBox="1"/>
+          <p:nvPr/>
+        </p:nvSpPr>
+        <p:spPr>
+          <a:xfrm>
+            <a:off x="1097280" y="5486400"/>
+            <a:ext cx="9966960" cy="457200"/>
+          </a:xfrm>
+          <a:prstGeom prst="rect">
+            <a:avLst/>
+          </a:prstGeom>
+          <a:noFill/>
+        </p:spPr>
+        <p:txBody>
+          <a:bodyPr wrap="square">
+            <a:spAutoFit/>
+          </a:bodyPr>
+          <a:lstStyle/>
+          <a:p>
+            <a:pPr algn="ctr">
+              <a:defRPr sz="1500" b="1">
+                <a:solidFill>
+                  <a:srgbClr val="555555"/>
+                </a:solidFill>
+                <a:latin typeface="Calibri"/>
+              </a:defRPr>
+            </a:pPr>
+            <a:r>
+              <a:t>"The question is not 'should we deploy AI?' The question is 'which level are we operating at, and have we invested accordingly?'"</a:t>
+            </a:r>
+          </a:p>
+        </p:txBody>
+      </p:sp>
+      <p:sp>
+        <p:nvSpPr>
+          <p:cNvPr id="18" name="Rounded Rectangle 17"/>
+          <p:cNvSpPr/>
+          <p:nvPr/>
+        </p:nvSpPr>
+        <p:spPr>
+          <a:xfrm>
+            <a:off x="792327" y="6035040"/>
+            <a:ext cx="2011680" cy="411480"/>
+          </a:xfrm>
+          <a:prstGeom prst="roundRect">
+            <a:avLst/>
+          </a:prstGeom>
+          <a:solidFill>
+            <a:srgbClr val="4CAF50"/>
+          </a:solidFill>
+          <a:ln>
+            <a:noFill/>
+          </a:ln>
+        </p:spPr>
+        <p:style>
+          <a:lnRef idx="1">
+            <a:schemeClr val="accent1"/>
+          </a:lnRef>
+          <a:fillRef idx="3">
+            <a:schemeClr val="accent1"/>
+          </a:fillRef>
+          <a:effectRef idx="2">
+            <a:schemeClr val="accent1"/>
+          </a:effectRef>
+          <a:fontRef idx="minor">
+            <a:schemeClr val="lt1"/>
+          </a:fontRef>
+        </p:style>
+        <p:txBody>
+          <a:bodyPr rtlCol="0" anchor="ctr" wrap="none"/>
+          <a:lstStyle/>
+          <a:p>
+            <a:pPr algn="ctr">
+              <a:defRPr sz="1200" b="1">
+                <a:solidFill>
+                  <a:srgbClr val="FFFFFF"/>
+                </a:solidFill>
+                <a:latin typeface="Calibri"/>
+              </a:defRPr>
+            </a:pPr>
+            <a:r>
+              <a:t>L1: Discovery</a:t>
+            </a:r>
+          </a:p>
+        </p:txBody>
+      </p:sp>
+      <p:sp>
+        <p:nvSpPr>
+          <p:cNvPr id="19" name="Rounded Rectangle 18"/>
+          <p:cNvSpPr/>
+          <p:nvPr/>
+        </p:nvSpPr>
+        <p:spPr>
+          <a:xfrm>
+            <a:off x="2941167" y="6035040"/>
+            <a:ext cx="2011680" cy="411480"/>
+          </a:xfrm>
+          <a:prstGeom prst="roundRect">
+            <a:avLst/>
+          </a:prstGeom>
+          <a:solidFill>
+            <a:srgbClr val="8BC34A"/>
+          </a:solidFill>
+          <a:ln>
+            <a:noFill/>
+          </a:ln>
+        </p:spPr>
+        <p:style>
+          <a:lnRef idx="1">
+            <a:schemeClr val="accent1"/>
+          </a:lnRef>
+          <a:fillRef idx="3">
+            <a:schemeClr val="accent1"/>
+          </a:fillRef>
+          <a:effectRef idx="2">
+            <a:schemeClr val="accent1"/>
+          </a:effectRef>
+          <a:fontRef idx="minor">
+            <a:schemeClr val="lt1"/>
+          </a:fontRef>
+        </p:style>
+        <p:txBody>
+          <a:bodyPr rtlCol="0" anchor="ctr" wrap="none"/>
+          <a:lstStyle/>
+          <a:p>
+            <a:pPr algn="ctr">
+              <a:defRPr sz="1200" b="1">
+                <a:solidFill>
+                  <a:srgbClr val="FFFFFF"/>
+                </a:solidFill>
+                <a:latin typeface="Calibri"/>
+              </a:defRPr>
+            </a:pPr>
+            <a:r>
+              <a:t>L2: Summarization</a:t>
+            </a:r>
+          </a:p>
+        </p:txBody>
+      </p:sp>
+      <p:sp>
+        <p:nvSpPr>
+          <p:cNvPr id="20" name="Rounded Rectangle 19"/>
+          <p:cNvSpPr/>
+          <p:nvPr/>
+        </p:nvSpPr>
+        <p:spPr>
+          <a:xfrm>
+            <a:off x="5090007" y="6035040"/>
+            <a:ext cx="2011680" cy="411480"/>
+          </a:xfrm>
+          <a:prstGeom prst="roundRect">
+            <a:avLst/>
+          </a:prstGeom>
+          <a:solidFill>
+            <a:srgbClr val="FF9800"/>
+          </a:solidFill>
+          <a:ln>
+            <a:noFill/>
+          </a:ln>
+        </p:spPr>
+        <p:style>
+          <a:lnRef idx="1">
+            <a:schemeClr val="accent1"/>
+          </a:lnRef>
+          <a:fillRef idx="3">
+            <a:schemeClr val="accent1"/>
+          </a:fillRef>
+          <a:effectRef idx="2">
+            <a:schemeClr val="accent1"/>
+          </a:effectRef>
+          <a:fontRef idx="minor">
+            <a:schemeClr val="lt1"/>
+          </a:fontRef>
+        </p:style>
+        <p:txBody>
+          <a:bodyPr rtlCol="0" anchor="ctr" wrap="none"/>
+          <a:lstStyle/>
+          <a:p>
+            <a:pPr algn="ctr">
+              <a:defRPr sz="1200" b="1">
+                <a:solidFill>
+                  <a:srgbClr val="FFFFFF"/>
+                </a:solidFill>
+                <a:latin typeface="Calibri"/>
+              </a:defRPr>
+            </a:pPr>
+            <a:r>
+              <a:t>L3: Operational</a:t>
+            </a:r>
+          </a:p>
+        </p:txBody>
+      </p:sp>
+      <p:sp>
+        <p:nvSpPr>
+          <p:cNvPr id="21" name="Rounded Rectangle 20"/>
+          <p:cNvSpPr/>
+          <p:nvPr/>
+        </p:nvSpPr>
+        <p:spPr>
+          <a:xfrm>
+            <a:off x="7238847" y="6035040"/>
+            <a:ext cx="2011680" cy="411480"/>
+          </a:xfrm>
+          <a:prstGeom prst="roundRect">
+            <a:avLst/>
+          </a:prstGeom>
+          <a:solidFill>
+            <a:srgbClr val="F4511E"/>
+          </a:solidFill>
+          <a:ln>
+            <a:noFill/>
+          </a:ln>
+        </p:spPr>
+        <p:style>
+          <a:lnRef idx="1">
+            <a:schemeClr val="accent1"/>
+          </a:lnRef>
+          <a:fillRef idx="3">
+            <a:schemeClr val="accent1"/>
+          </a:fillRef>
+          <a:effectRef idx="2">
+            <a:schemeClr val="accent1"/>
+          </a:effectRef>
+          <a:fontRef idx="minor">
+            <a:schemeClr val="lt1"/>
+          </a:fontRef>
+        </p:style>
+        <p:txBody>
+          <a:bodyPr rtlCol="0" anchor="ctr" wrap="none"/>
+          <a:lstStyle/>
+          <a:p>
+            <a:pPr algn="ctr">
+              <a:defRPr sz="1200" b="1">
+                <a:solidFill>
+                  <a:srgbClr val="FFFFFF"/>
+                </a:solidFill>
+                <a:latin typeface="Calibri"/>
+              </a:defRPr>
+            </a:pPr>
+            <a:r>
+              <a:t>L4: Investigative</a:t>
+            </a:r>
+          </a:p>
+        </p:txBody>
+      </p:sp>
+      <p:sp>
+        <p:nvSpPr>
+          <p:cNvPr id="22" name="Rounded Rectangle 21"/>
+          <p:cNvSpPr/>
+          <p:nvPr/>
+        </p:nvSpPr>
+        <p:spPr>
+          <a:xfrm>
+            <a:off x="9387687" y="6035040"/>
+            <a:ext cx="2011680" cy="411480"/>
+          </a:xfrm>
+          <a:prstGeom prst="roundRect">
+            <a:avLst/>
+          </a:prstGeom>
+          <a:solidFill>
+            <a:srgbClr val="E53935"/>
+          </a:solidFill>
+          <a:ln>
+            <a:noFill/>
+          </a:ln>
+        </p:spPr>
+        <p:style>
+          <a:lnRef idx="1">
+            <a:schemeClr val="accent1"/>
+          </a:lnRef>
+          <a:fillRef idx="3">
+            <a:schemeClr val="accent1"/>
+          </a:fillRef>
+          <a:effectRef idx="2">
+            <a:schemeClr val="accent1"/>
+          </a:effectRef>
+          <a:fontRef idx="minor">
+            <a:schemeClr val="lt1"/>
+          </a:fontRef>
+        </p:style>
+        <p:txBody>
+          <a:bodyPr rtlCol="0" anchor="ctr" wrap="none"/>
+          <a:lstStyle/>
+          <a:p>
+            <a:pPr algn="ctr">
+              <a:defRPr sz="1200" b="1">
+                <a:solidFill>
+                  <a:srgbClr val="FFFFFF"/>
+                </a:solidFill>
+                <a:latin typeface="Calibri"/>
+              </a:defRPr>
+            </a:pPr>
+            <a:r>
+              <a:t>L5: Adjudicative</a:t>
+            </a:r>
+          </a:p>
+        </p:txBody>
+      </p:sp>
+      <p:sp>
+        <p:nvSpPr>
+          <p:cNvPr id="23" name="TextBox 22"/>
+          <p:cNvSpPr txBox="1"/>
+          <p:nvPr/>
+        </p:nvSpPr>
+        <p:spPr>
+          <a:xfrm>
+            <a:off x="457200" y="6446520"/>
+            <a:ext cx="2743200" cy="320040"/>
+          </a:xfrm>
+          <a:prstGeom prst="rect">
+            <a:avLst/>
+          </a:prstGeom>
+          <a:noFill/>
+        </p:spPr>
+        <p:txBody>
+          <a:bodyPr wrap="square">
+            <a:spAutoFit/>
+          </a:bodyPr>
+          <a:lstStyle/>
+          <a:p>
+            <a:pPr algn="l">
+              <a:defRPr sz="1000" b="0">
+                <a:solidFill>
+                  <a:srgbClr val="555555"/>
+                </a:solidFill>
+                <a:latin typeface="Calibri"/>
+              </a:defRPr>
+            </a:pPr>
+            <a:r>
+              <a:t>Confidential  |  March 2026</a:t>
+            </a:r>
+          </a:p>
+        </p:txBody>
+      </p:sp>
+    </p:spTree>
+  </p:cSld>
+  <p:clrMapOvr>
+    <a:masterClrMapping/>
+  </p:clrMapOvr>
+</p:sld>
+</file>
+
+<file path=ppt/slides/slide26.xml><?xml version="1.0" encoding="utf-8"?>
 <p:sld xmlns:a="http://schemas.openxmlformats.org/drawingml/2006/main" xmlns:p="http://schemas.openxmlformats.org/presentationml/2006/main" xmlns:r="http://schemas.openxmlformats.org/officeDocument/2006/relationships">
   <p:cSld>
     <p:bg>
@@ -22129,7 +23766,7 @@
 </p:sld>
 </file>
 
-<file path=ppt/slides/slide26.xml><?xml version="1.0" encoding="utf-8"?>
+<file path=ppt/slides/slide27.xml><?xml version="1.0" encoding="utf-8"?>
 <p:sld xmlns:a="http://schemas.openxmlformats.org/drawingml/2006/main" xmlns:p="http://schemas.openxmlformats.org/presentationml/2006/main" xmlns:r="http://schemas.openxmlformats.org/officeDocument/2006/relationships">
   <p:cSld>
     <p:bg>

</xml_diff>

<commit_message>
docs: GPT-5 Reasoning 10/11 results, 5-model Dataverse MCP comparison
Add GPT-5 Reasoning to all model comparison tables and narrative.
Five models tested on identical Dataverse MCP infrastructure:
GPT-4o 1/11, GPT-5 Auto 4/11, GPT-4.1 6/11, GPT-5 Reasoning 10/11,
Sonnet 4.6 11/11. Q10 (TPR abbreviation) confirmed as connector-level
bug. GCC language softened to "currently defaults to GPT-4o." Model
count (6) added to all stats lines.

Co-Authored-By: Claude Opus 4.6 <noreply@anthropic.com>
</commit_message>
<xml_diff>
--- a/decks/agent-fidelity-spectrum.pptx
+++ b/decks/agent-fidelity-spectrum.pptx
@@ -4454,7 +4454,7 @@
               </a:defRPr>
             </a:pPr>
             <a:r>
-              <a:t>Findings from 462 Test Runs Across 21 Agent Configurations</a:t>
+              <a:t>Findings from 462 Test Runs Across 21 Agent Configurations and 6 Models</a:t>
             </a:r>
           </a:p>
         </p:txBody>
@@ -4791,7 +4791,7 @@
               </a:defRPr>
             </a:pPr>
             <a:r>
-              <a:t>462 test runs  |  21 agents  |  27 slides  |  2 use cases</a:t>
+              <a:t>462 test runs  |  21 agents  |  6 models  |  27 slides  |  2 use cases</a:t>
             </a:r>
           </a:p>
         </p:txBody>
@@ -6187,7 +6187,7 @@
                 </a:solidFill>
                 <a:latin typeface="Calibri"/>
               </a:rPr>
-              <a:t>Government Cloud Copilot Studio currently defaults to GPT-4o</a:t>
+              <a:t>Government Cloud currently defaults to GPT-4o; expanded model availability on the roadmap</a:t>
             </a:r>
           </a:p>
           <a:p>
@@ -14026,7 +14026,7 @@
               </a:defRPr>
             </a:pPr>
             <a:r>
-              <a:t>462 test runs across 21 agent configurations, 2 government use cases, and 7 testing rounds. Three gaps emerged at the higher levels: tools, data, and model. Every gap was fixable, and none required AI expertise.</a:t>
+              <a:t>462 test runs across 21 agent configurations and 6 models, 2 government use cases, and 7 testing rounds. Three gaps emerged at the higher levels: tools, data, and model. Every gap was fixable, and none required AI expertise.</a:t>
             </a:r>
           </a:p>
         </p:txBody>
@@ -21705,7 +21705,7 @@
               </a:defRPr>
             </a:pPr>
             <a:r>
-              <a:t>462 test runs, 21 agent configurations, 2 use cases</a:t>
+              <a:t>462 test runs, 21 agent configurations, 6 models, 2 use cases</a:t>
             </a:r>
           </a:p>
         </p:txBody>
@@ -21741,7 +21741,7 @@
               </a:defRPr>
             </a:pPr>
             <a:r>
-              <a:t>Use Case 1: Legal Case Analysis (15 agents)</a:t>
+              <a:t>Use Case 1: Legal Case Analysis (16 agents)</a:t>
             </a:r>
           </a:p>
         </p:txBody>
@@ -21756,7 +21756,7 @@
         </p:nvGraphicFramePr>
         <p:xfrm>
           <a:off x="731520" y="2057400"/>
-          <a:ext cx="4297680" cy="6583680"/>
+          <a:ext cx="4297680" cy="6995160"/>
         </p:xfrm>
         <a:graphic>
           <a:graphicData uri="http://schemas.openxmlformats.org/drawingml/2006/table">
@@ -22228,7 +22228,7 @@
                         </a:defRPr>
                       </a:pPr>
                       <a:r>
-                        <a:t>CS SP/DOCX/Com</a:t>
+                        <a:t>CS DV/Com</a:t>
                       </a:r>
                     </a:p>
                   </a:txBody>
@@ -22252,7 +22252,155 @@
                         </a:defRPr>
                       </a:pPr>
                       <a:r>
+                        <a:t>GPT-5 Reasoning</a:t>
+                      </a:r>
+                    </a:p>
+                  </a:txBody>
+                  <a:tcPr anchor="ctr">
+                    <a:solidFill>
+                      <a:srgbClr val="E8F0F8"/>
+                    </a:solidFill>
+                  </a:tcPr>
+                </a:tc>
+                <a:tc>
+                  <a:txBody>
+                    <a:bodyPr/>
+                    <a:lstStyle/>
+                    <a:p>
+                      <a:pPr algn="ctr">
+                        <a:defRPr sz="900">
+                          <a:solidFill>
+                            <a:srgbClr val="2D2D2D"/>
+                          </a:solidFill>
+                          <a:latin typeface="Calibri"/>
+                        </a:defRPr>
+                      </a:pPr>
+                      <a:r>
+                        <a:t>10/10</a:t>
+                      </a:r>
+                    </a:p>
+                  </a:txBody>
+                  <a:tcPr anchor="ctr">
+                    <a:solidFill>
+                      <a:srgbClr val="E8F0F8"/>
+                    </a:solidFill>
+                  </a:tcPr>
+                </a:tc>
+              </a:tr>
+              <a:tr h="411480">
+                <a:tc>
+                  <a:txBody>
+                    <a:bodyPr/>
+                    <a:lstStyle/>
+                    <a:p>
+                      <a:pPr algn="ctr">
+                        <a:defRPr sz="900">
+                          <a:solidFill>
+                            <a:srgbClr val="2D2D2D"/>
+                          </a:solidFill>
+                          <a:latin typeface="Calibri"/>
+                        </a:defRPr>
+                      </a:pPr>
+                      <a:r>
+                        <a:t>CS SP/DOCX/Com</a:t>
+                      </a:r>
+                    </a:p>
+                  </a:txBody>
+                  <a:tcPr anchor="ctr">
+                    <a:solidFill>
+                      <a:srgbClr val="FFFFFF"/>
+                    </a:solidFill>
+                  </a:tcPr>
+                </a:tc>
+                <a:tc>
+                  <a:txBody>
+                    <a:bodyPr/>
+                    <a:lstStyle/>
+                    <a:p>
+                      <a:pPr algn="ctr">
+                        <a:defRPr sz="900">
+                          <a:solidFill>
+                            <a:srgbClr val="2D2D2D"/>
+                          </a:solidFill>
+                          <a:latin typeface="Calibri"/>
+                        </a:defRPr>
+                      </a:pPr>
+                      <a:r>
                         <a:t>GPT-4.1</a:t>
+                      </a:r>
+                    </a:p>
+                  </a:txBody>
+                  <a:tcPr anchor="ctr">
+                    <a:solidFill>
+                      <a:srgbClr val="FFFFFF"/>
+                    </a:solidFill>
+                  </a:tcPr>
+                </a:tc>
+                <a:tc>
+                  <a:txBody>
+                    <a:bodyPr/>
+                    <a:lstStyle/>
+                    <a:p>
+                      <a:pPr algn="ctr">
+                        <a:defRPr sz="900">
+                          <a:solidFill>
+                            <a:srgbClr val="2D2D2D"/>
+                          </a:solidFill>
+                          <a:latin typeface="Calibri"/>
+                        </a:defRPr>
+                      </a:pPr>
+                      <a:r>
+                        <a:t>9/10</a:t>
+                      </a:r>
+                    </a:p>
+                  </a:txBody>
+                  <a:tcPr anchor="ctr">
+                    <a:solidFill>
+                      <a:srgbClr val="FFFFFF"/>
+                    </a:solidFill>
+                  </a:tcPr>
+                </a:tc>
+              </a:tr>
+              <a:tr h="411480">
+                <a:tc>
+                  <a:txBody>
+                    <a:bodyPr/>
+                    <a:lstStyle/>
+                    <a:p>
+                      <a:pPr algn="ctr">
+                        <a:defRPr sz="900">
+                          <a:solidFill>
+                            <a:srgbClr val="2D2D2D"/>
+                          </a:solidFill>
+                          <a:latin typeface="Calibri"/>
+                        </a:defRPr>
+                      </a:pPr>
+                      <a:r>
+                        <a:t>CS MCP/GCC</a:t>
+                      </a:r>
+                    </a:p>
+                  </a:txBody>
+                  <a:tcPr anchor="ctr">
+                    <a:solidFill>
+                      <a:srgbClr val="E8F0F8"/>
+                    </a:solidFill>
+                  </a:tcPr>
+                </a:tc>
+                <a:tc>
+                  <a:txBody>
+                    <a:bodyPr/>
+                    <a:lstStyle/>
+                    <a:p>
+                      <a:pPr algn="ctr">
+                        <a:defRPr sz="900">
+                          <a:solidFill>
+                            <a:srgbClr val="2D2D2D"/>
+                          </a:solidFill>
+                          <a:latin typeface="Calibri"/>
+                        </a:defRPr>
+                      </a:pPr>
+                      <a:r>
+                        <a:t>GPT-4o</a:t>
                       </a:r>
                     </a:p>
                   </a:txBody>
@@ -22302,7 +22450,7 @@
                         </a:defRPr>
                       </a:pPr>
                       <a:r>
-                        <a:t>CS MCP/GCC</a:t>
+                        <a:t>CS SP/PDF/GCC</a:t>
                       </a:r>
                     </a:p>
                   </a:txBody>
@@ -22376,7 +22524,7 @@
                         </a:defRPr>
                       </a:pPr>
                       <a:r>
-                        <a:t>CS SP/PDF/GCC</a:t>
+                        <a:t>CS KB/PDF/GCC</a:t>
                       </a:r>
                     </a:p>
                   </a:txBody>
@@ -22450,7 +22598,7 @@
                         </a:defRPr>
                       </a:pPr>
                       <a:r>
-                        <a:t>CS KB/PDF/GCC</a:t>
+                        <a:t>CS KB/PDF/Com</a:t>
                       </a:r>
                     </a:p>
                   </a:txBody>
@@ -22474,7 +22622,7 @@
                         </a:defRPr>
                       </a:pPr>
                       <a:r>
-                        <a:t>GPT-4o</a:t>
+                        <a:t>GPT-4.1</a:t>
                       </a:r>
                     </a:p>
                   </a:txBody>
@@ -22498,7 +22646,7 @@
                         </a:defRPr>
                       </a:pPr>
                       <a:r>
-                        <a:t>9/10</a:t>
+                        <a:t>8/10</a:t>
                       </a:r>
                     </a:p>
                   </a:txBody>
@@ -22524,7 +22672,7 @@
                         </a:defRPr>
                       </a:pPr>
                       <a:r>
-                        <a:t>CS KB/PDF/Com</a:t>
+                        <a:t>CS KB/DOCX/GCC</a:t>
                       </a:r>
                     </a:p>
                   </a:txBody>
@@ -22548,7 +22696,7 @@
                         </a:defRPr>
                       </a:pPr>
                       <a:r>
-                        <a:t>GPT-4.1</a:t>
+                        <a:t>GPT-4o</a:t>
                       </a:r>
                     </a:p>
                   </a:txBody>
@@ -22598,7 +22746,7 @@
                         </a:defRPr>
                       </a:pPr>
                       <a:r>
-                        <a:t>CS KB/DOCX/GCC</a:t>
+                        <a:t>CS SP/DOCX/GCC</a:t>
                       </a:r>
                     </a:p>
                   </a:txBody>
@@ -22646,7 +22794,7 @@
                         </a:defRPr>
                       </a:pPr>
                       <a:r>
-                        <a:t>8/10</a:t>
+                        <a:t>7/10</a:t>
                       </a:r>
                     </a:p>
                   </a:txBody>
@@ -22672,7 +22820,7 @@
                         </a:defRPr>
                       </a:pPr>
                       <a:r>
-                        <a:t>CS SP/DOCX/GCC</a:t>
+                        <a:t>CS DV/Com</a:t>
                       </a:r>
                     </a:p>
                   </a:txBody>
@@ -22696,7 +22844,7 @@
                         </a:defRPr>
                       </a:pPr>
                       <a:r>
-                        <a:t>GPT-4o</a:t>
+                        <a:t>GPT-4.1</a:t>
                       </a:r>
                     </a:p>
                   </a:txBody>
@@ -22720,7 +22868,7 @@
                         </a:defRPr>
                       </a:pPr>
                       <a:r>
-                        <a:t>7/10</a:t>
+                        <a:t>6/10</a:t>
                       </a:r>
                     </a:p>
                   </a:txBody>
@@ -22770,7 +22918,7 @@
                         </a:defRPr>
                       </a:pPr>
                       <a:r>
-                        <a:t>GPT-4.1</a:t>
+                        <a:t>GPT-5 Auto</a:t>
                       </a:r>
                     </a:p>
                   </a:txBody>
@@ -22794,7 +22942,7 @@
                         </a:defRPr>
                       </a:pPr>
                       <a:r>
-                        <a:t>6/10</a:t>
+                        <a:t>4/10</a:t>
                       </a:r>
                     </a:p>
                   </a:txBody>
@@ -22820,7 +22968,7 @@
                         </a:defRPr>
                       </a:pPr>
                       <a:r>
-                        <a:t>CS DV/Com</a:t>
+                        <a:t>CS DV/GCC</a:t>
                       </a:r>
                     </a:p>
                   </a:txBody>
@@ -22844,7 +22992,7 @@
                         </a:defRPr>
                       </a:pPr>
                       <a:r>
-                        <a:t>GPT-5 Auto</a:t>
+                        <a:t>GPT-4o</a:t>
                       </a:r>
                     </a:p>
                   </a:txBody>
@@ -22868,87 +23016,13 @@
                         </a:defRPr>
                       </a:pPr>
                       <a:r>
-                        <a:t>4/10</a:t>
+                        <a:t>2/10</a:t>
                       </a:r>
                     </a:p>
                   </a:txBody>
                   <a:tcPr anchor="ctr">
                     <a:solidFill>
                       <a:srgbClr val="E8F0F8"/>
-                    </a:solidFill>
-                  </a:tcPr>
-                </a:tc>
-              </a:tr>
-              <a:tr h="411480">
-                <a:tc>
-                  <a:txBody>
-                    <a:bodyPr/>
-                    <a:lstStyle/>
-                    <a:p>
-                      <a:pPr algn="ctr">
-                        <a:defRPr sz="900">
-                          <a:solidFill>
-                            <a:srgbClr val="2D2D2D"/>
-                          </a:solidFill>
-                          <a:latin typeface="Calibri"/>
-                        </a:defRPr>
-                      </a:pPr>
-                      <a:r>
-                        <a:t>CS DV/GCC</a:t>
-                      </a:r>
-                    </a:p>
-                  </a:txBody>
-                  <a:tcPr anchor="ctr">
-                    <a:solidFill>
-                      <a:srgbClr val="FFFFFF"/>
-                    </a:solidFill>
-                  </a:tcPr>
-                </a:tc>
-                <a:tc>
-                  <a:txBody>
-                    <a:bodyPr/>
-                    <a:lstStyle/>
-                    <a:p>
-                      <a:pPr algn="ctr">
-                        <a:defRPr sz="900">
-                          <a:solidFill>
-                            <a:srgbClr val="2D2D2D"/>
-                          </a:solidFill>
-                          <a:latin typeface="Calibri"/>
-                        </a:defRPr>
-                      </a:pPr>
-                      <a:r>
-                        <a:t>GPT-4o</a:t>
-                      </a:r>
-                    </a:p>
-                  </a:txBody>
-                  <a:tcPr anchor="ctr">
-                    <a:solidFill>
-                      <a:srgbClr val="FFFFFF"/>
-                    </a:solidFill>
-                  </a:tcPr>
-                </a:tc>
-                <a:tc>
-                  <a:txBody>
-                    <a:bodyPr/>
-                    <a:lstStyle/>
-                    <a:p>
-                      <a:pPr algn="ctr">
-                        <a:defRPr sz="900">
-                          <a:solidFill>
-                            <a:srgbClr val="2D2D2D"/>
-                          </a:solidFill>
-                          <a:latin typeface="Calibri"/>
-                        </a:defRPr>
-                      </a:pPr>
-                      <a:r>
-                        <a:t>2/10</a:t>
-                      </a:r>
-                    </a:p>
-                  </a:txBody>
-                  <a:tcPr anchor="ctr">
-                    <a:solidFill>
-                      <a:srgbClr val="FFFFFF"/>
                     </a:solidFill>
                   </a:tcPr>
                 </a:tc>
@@ -23717,7 +23791,7 @@
               </a:defRPr>
             </a:pPr>
             <a:r>
-              <a:t>Dataverse MCP: Sonnet 4.6 (10/10), GPT-4.1 (6/10), GPT-5 Auto (4/10), GPT-4o (2/10). Newer models are not always better.</a:t>
+              <a:t>Dataverse MCP (5 models): Sonnet 4.6 (10/10), GPT-5 Reasoning (10/10), GPT-4.1 (6/10), GPT-5 Auto (4/10), GPT-4o (2/10). Reasoning models close the gap.</a:t>
             </a:r>
           </a:p>
         </p:txBody>
@@ -25609,7 +25683,11 @@
             </a:r>
             <a:br/>
             <a:r>
-              <a:t>configurations, scored by hand.</a:t>
+              <a:t>configurations and 6 models,</a:t>
+            </a:r>
+            <a:br/>
+            <a:r>
+              <a:t>scored by hand.</a:t>
             </a:r>
             <a:br/>
             <a:r>

</xml_diff>

<commit_message>
docs: Demo Day Test Run 1 — GCC DV MCP R4 (3.2/10), SP agent validation, score updates
- Add demo-day-test-run-1.md with Part 1 (doc quality), Part 2 (model selection), GCC DV MCP R4 results
- GCC Dataverse MCP R4: 3.2/10 (best of 5 rounds) — P7 LE statements and P9 TPR recovered to 10
- Update all score tables: DV/GCC 2/10→3.2/10, GPT-4o 1/11→3.2/11, tables verified score-ranked
- Add R4 section + narrative to dataverse-mcp-server-testing.md
- Regenerate all PDFs, slide deck, cheat sheet

Co-Authored-By: Claude Opus 4.6 <noreply@anthropic.com>
</commit_message>
<xml_diff>
--- a/decks/agent-fidelity-spectrum.pptx
+++ b/decks/agent-fidelity-spectrum.pptx
@@ -17568,7 +17568,7 @@
               </a:defRPr>
             </a:pPr>
             <a:r>
-              <a:t>Full battery: 1/11 -&gt; 6/11 -&gt; 11/11</a:t>
+              <a:t>Full battery: 3.2/11 -&gt; 6/11 -&gt; 11/11</a:t>
             </a:r>
           </a:p>
         </p:txBody>
@@ -23016,7 +23016,7 @@
                         </a:defRPr>
                       </a:pPr>
                       <a:r>
-                        <a:t>2/10</a:t>
+                        <a:t>3.2/10</a:t>
                       </a:r>
                     </a:p>
                   </a:txBody>
@@ -23791,7 +23791,7 @@
               </a:defRPr>
             </a:pPr>
             <a:r>
-              <a:t>Dataverse MCP (5 models): Sonnet 4.6 (10/10), GPT-5 Reasoning (10/10), GPT-4.1 (6/10), GPT-5 Auto (4/10), GPT-4o (2/10). Reasoning models close the gap.</a:t>
+              <a:t>Dataverse MCP (5 models): Sonnet 4.6 (10/10), GPT-5 Reasoning (10/10), GPT-4.1 (6/10), GPT-5 Auto (4/10), GPT-4o (3.2/10). Reasoning models close the gap.</a:t>
             </a:r>
           </a:p>
         </p:txBody>

</xml_diff>

<commit_message>
docs: Update scoring slide to 0-10 continuous scale with anchors
Replaced 3-tier Pass/Partial/Fail rubric with 5-row 0-10 scale table
(10, 8-9, 5, 1-4, 0) with meanings and examples. Added "one run per
agent, per-prompt scores averaged" to explain how totals are derived.

Co-Authored-By: Claude Opus 4.6 <noreply@anthropic.com>
</commit_message>
<xml_diff>
--- a/decks/agent-fidelity-spectrum.pptx
+++ b/decks/agent-fidelity-spectrum.pptx
@@ -599,7 +599,7 @@
           <a:lstStyle/>
           <a:p>
             <a:r>
-              <a:t>All 50 cases are synthetic -- we control the ground truth for every prompt. During the live demo, I paste agent responses into Claude Code and it grades them against the ground truth in real time. This is not opinion-based scoring.</a:t>
+              <a:t>All 50 cases are synthetic -- we control the ground truth for every prompt. The 0-10 scale distinguishes between an agent that found the right case but missed one detail (8-9) versus one that got half the answer (5) versus one that confidently gave the wrong answer (0). During the live demo, I paste agent responses into Claude Code and it grades them in real time.</a:t>
             </a:r>
           </a:p>
         </p:txBody>
@@ -17107,7 +17107,7 @@
         </p:nvGraphicFramePr>
         <p:xfrm>
           <a:off x="1097280" y="2011680"/>
-          <a:ext cx="5303520" cy="1645920"/>
+          <a:ext cx="5303520" cy="2468880"/>
         </p:xfrm>
         <a:graphic>
           <a:graphicData uri="http://schemas.openxmlformats.org/drawingml/2006/table">
@@ -17116,8 +17116,9 @@
                 <a:tableStyleId>{5C22544A-7EE6-4342-B048-85BDC9FD1C3A}</a:tableStyleId>
               </a:tblPr>
               <a:tblGrid>
-                <a:gridCol w="1188720"/>
-                <a:gridCol w="4114800"/>
+                <a:gridCol w="640080"/>
+                <a:gridCol w="2286000"/>
+                <a:gridCol w="2377440"/>
               </a:tblGrid>
               <a:tr h="411480">
                 <a:tc>
@@ -17126,7 +17127,7 @@
                     <a:lstStyle/>
                     <a:p>
                       <a:pPr algn="ctr">
-                        <a:defRPr sz="1300" b="1">
+                        <a:defRPr sz="1200" b="1">
                           <a:solidFill>
                             <a:srgbClr val="FFFFFF"/>
                           </a:solidFill>
@@ -17134,7 +17135,7 @@
                         </a:defRPr>
                       </a:pPr>
                       <a:r>
-                        <a:t>Grade</a:t>
+                        <a:t>Score</a:t>
                       </a:r>
                     </a:p>
                   </a:txBody>
@@ -17150,7 +17151,7 @@
                     <a:lstStyle/>
                     <a:p>
                       <a:pPr algn="ctr">
-                        <a:defRPr sz="1300" b="1">
+                        <a:defRPr sz="1200" b="1">
                           <a:solidFill>
                             <a:srgbClr val="FFFFFF"/>
                           </a:solidFill>
@@ -17158,7 +17159,31 @@
                         </a:defRPr>
                       </a:pPr>
                       <a:r>
-                        <a:t>Criteria</a:t>
+                        <a:t>Meaning</a:t>
+                      </a:r>
+                    </a:p>
+                  </a:txBody>
+                  <a:tcPr anchor="ctr">
+                    <a:solidFill>
+                      <a:srgbClr val="2C5F8A"/>
+                    </a:solidFill>
+                  </a:tcPr>
+                </a:tc>
+                <a:tc>
+                  <a:txBody>
+                    <a:bodyPr/>
+                    <a:lstStyle/>
+                    <a:p>
+                      <a:pPr algn="ctr">
+                        <a:defRPr sz="1200" b="1">
+                          <a:solidFill>
+                            <a:srgbClr val="FFFFFF"/>
+                          </a:solidFill>
+                          <a:latin typeface="Calibri"/>
+                        </a:defRPr>
+                      </a:pPr>
+                      <a:r>
+                        <a:t>Example</a:t>
                       </a:r>
                     </a:p>
                   </a:txBody>
@@ -17176,7 +17201,7 @@
                     <a:lstStyle/>
                     <a:p>
                       <a:pPr algn="ctr">
-                        <a:defRPr sz="1300">
+                        <a:defRPr sz="1200">
                           <a:solidFill>
                             <a:srgbClr val="2D2D2D"/>
                           </a:solidFill>
@@ -17184,7 +17209,7 @@
                         </a:defRPr>
                       </a:pPr>
                       <a:r>
-                        <a:t>Pass (10)</a:t>
+                        <a:t>10</a:t>
                       </a:r>
                     </a:p>
                   </a:txBody>
@@ -17200,7 +17225,7 @@
                     <a:lstStyle/>
                     <a:p>
                       <a:pPr algn="ctr">
-                        <a:defRPr sz="1300">
+                        <a:defRPr sz="1200">
                           <a:solidFill>
                             <a:srgbClr val="2D2D2D"/>
                           </a:solidFill>
@@ -17208,7 +17233,31 @@
                         </a:defRPr>
                       </a:pPr>
                       <a:r>
-                        <a:t>Correct, complete, properly sourced. No hallucinations.</a:t>
+                        <a:t>Fully correct, complete, sourced</a:t>
+                      </a:r>
+                    </a:p>
+                  </a:txBody>
+                  <a:tcPr anchor="ctr">
+                    <a:solidFill>
+                      <a:srgbClr val="FFFFFF"/>
+                    </a:solidFill>
+                  </a:tcPr>
+                </a:tc>
+                <a:tc>
+                  <a:txBody>
+                    <a:bodyPr/>
+                    <a:lstStyle/>
+                    <a:p>
+                      <a:pPr algn="ctr">
+                        <a:defRPr sz="1200">
+                          <a:solidFill>
+                            <a:srgbClr val="2D2D2D"/>
+                          </a:solidFill>
+                          <a:latin typeface="Calibri"/>
+                        </a:defRPr>
+                      </a:pPr>
+                      <a:r>
+                        <a:t>All facts match, sources cited</a:t>
                       </a:r>
                     </a:p>
                   </a:txBody>
@@ -17226,7 +17275,7 @@
                     <a:lstStyle/>
                     <a:p>
                       <a:pPr algn="ctr">
-                        <a:defRPr sz="1300">
+                        <a:defRPr sz="1200">
                           <a:solidFill>
                             <a:srgbClr val="2D2D2D"/>
                           </a:solidFill>
@@ -17234,7 +17283,7 @@
                         </a:defRPr>
                       </a:pPr>
                       <a:r>
-                        <a:t>Partial (5)</a:t>
+                        <a:t>8-9</a:t>
                       </a:r>
                     </a:p>
                   </a:txBody>
@@ -17250,7 +17299,7 @@
                     <a:lstStyle/>
                     <a:p>
                       <a:pPr algn="ctr">
-                        <a:defRPr sz="1300">
+                        <a:defRPr sz="1200">
                           <a:solidFill>
                             <a:srgbClr val="2D2D2D"/>
                           </a:solidFill>
@@ -17258,7 +17307,31 @@
                         </a:defRPr>
                       </a:pPr>
                       <a:r>
-                        <a:t>Key facts present but incomplete, or minor errors.</a:t>
+                        <a:t>Correct, one minor detail missing</a:t>
+                      </a:r>
+                    </a:p>
+                  </a:txBody>
+                  <a:tcPr anchor="ctr">
+                    <a:solidFill>
+                      <a:srgbClr val="E8F0F8"/>
+                    </a:solidFill>
+                  </a:tcPr>
+                </a:tc>
+                <a:tc>
+                  <a:txBody>
+                    <a:bodyPr/>
+                    <a:lstStyle/>
+                    <a:p>
+                      <a:pPr algn="ctr">
+                        <a:defRPr sz="1200">
+                          <a:solidFill>
+                            <a:srgbClr val="2D2D2D"/>
+                          </a:solidFill>
+                          <a:latin typeface="Calibri"/>
+                        </a:defRPr>
+                      </a:pPr>
+                      <a:r>
+                        <a:t>All statements found, missed one page ref</a:t>
                       </a:r>
                     </a:p>
                   </a:txBody>
@@ -17276,7 +17349,7 @@
                     <a:lstStyle/>
                     <a:p>
                       <a:pPr algn="ctr">
-                        <a:defRPr sz="1300">
+                        <a:defRPr sz="1200">
                           <a:solidFill>
                             <a:srgbClr val="2D2D2D"/>
                           </a:solidFill>
@@ -17284,7 +17357,7 @@
                         </a:defRPr>
                       </a:pPr>
                       <a:r>
-                        <a:t>Fail (0)</a:t>
+                        <a:t>5</a:t>
                       </a:r>
                     </a:p>
                   </a:txBody>
@@ -17300,7 +17373,7 @@
                     <a:lstStyle/>
                     <a:p>
                       <a:pPr algn="ctr">
-                        <a:defRPr sz="1300">
+                        <a:defRPr sz="1200">
                           <a:solidFill>
                             <a:srgbClr val="2D2D2D"/>
                           </a:solidFill>
@@ -17308,7 +17381,179 @@
                         </a:defRPr>
                       </a:pPr>
                       <a:r>
-                        <a:t>Wrong answer, hallucination, or confident critical omission.</a:t>
+                        <a:t>Partially correct or incomplete</a:t>
+                      </a:r>
+                    </a:p>
+                  </a:txBody>
+                  <a:tcPr anchor="ctr">
+                    <a:solidFill>
+                      <a:srgbClr val="FFFFFF"/>
+                    </a:solidFill>
+                  </a:tcPr>
+                </a:tc>
+                <a:tc>
+                  <a:txBody>
+                    <a:bodyPr/>
+                    <a:lstStyle/>
+                    <a:p>
+                      <a:pPr algn="ctr">
+                        <a:defRPr sz="1200">
+                          <a:solidFill>
+                            <a:srgbClr val="2D2D2D"/>
+                          </a:solidFill>
+                          <a:latin typeface="Calibri"/>
+                        </a:defRPr>
+                      </a:pPr>
+                      <a:r>
+                        <a:t>Found one of two sources, or wrong time</a:t>
+                      </a:r>
+                    </a:p>
+                  </a:txBody>
+                  <a:tcPr anchor="ctr">
+                    <a:solidFill>
+                      <a:srgbClr val="FFFFFF"/>
+                    </a:solidFill>
+                  </a:tcPr>
+                </a:tc>
+              </a:tr>
+              <a:tr h="411480">
+                <a:tc>
+                  <a:txBody>
+                    <a:bodyPr/>
+                    <a:lstStyle/>
+                    <a:p>
+                      <a:pPr algn="ctr">
+                        <a:defRPr sz="1200">
+                          <a:solidFill>
+                            <a:srgbClr val="2D2D2D"/>
+                          </a:solidFill>
+                          <a:latin typeface="Calibri"/>
+                        </a:defRPr>
+                      </a:pPr>
+                      <a:r>
+                        <a:t>1-4</a:t>
+                      </a:r>
+                    </a:p>
+                  </a:txBody>
+                  <a:tcPr anchor="ctr">
+                    <a:solidFill>
+                      <a:srgbClr val="E8F0F8"/>
+                    </a:solidFill>
+                  </a:tcPr>
+                </a:tc>
+                <a:tc>
+                  <a:txBody>
+                    <a:bodyPr/>
+                    <a:lstStyle/>
+                    <a:p>
+                      <a:pPr algn="ctr">
+                        <a:defRPr sz="1200">
+                          <a:solidFill>
+                            <a:srgbClr val="2D2D2D"/>
+                          </a:solidFill>
+                          <a:latin typeface="Calibri"/>
+                        </a:defRPr>
+                      </a:pPr>
+                      <a:r>
+                        <a:t>Significant gaps</a:t>
+                      </a:r>
+                    </a:p>
+                  </a:txBody>
+                  <a:tcPr anchor="ctr">
+                    <a:solidFill>
+                      <a:srgbClr val="E8F0F8"/>
+                    </a:solidFill>
+                  </a:tcPr>
+                </a:tc>
+                <a:tc>
+                  <a:txBody>
+                    <a:bodyPr/>
+                    <a:lstStyle/>
+                    <a:p>
+                      <a:pPr algn="ctr">
+                        <a:defRPr sz="1200">
+                          <a:solidFill>
+                            <a:srgbClr val="2D2D2D"/>
+                          </a:solidFill>
+                          <a:latin typeface="Calibri"/>
+                        </a:defRPr>
+                      </a:pPr>
+                      <a:r>
+                        <a:t>Right case, missed key facts</a:t>
+                      </a:r>
+                    </a:p>
+                  </a:txBody>
+                  <a:tcPr anchor="ctr">
+                    <a:solidFill>
+                      <a:srgbClr val="E8F0F8"/>
+                    </a:solidFill>
+                  </a:tcPr>
+                </a:tc>
+              </a:tr>
+              <a:tr h="411480">
+                <a:tc>
+                  <a:txBody>
+                    <a:bodyPr/>
+                    <a:lstStyle/>
+                    <a:p>
+                      <a:pPr algn="ctr">
+                        <a:defRPr sz="1200">
+                          <a:solidFill>
+                            <a:srgbClr val="2D2D2D"/>
+                          </a:solidFill>
+                          <a:latin typeface="Calibri"/>
+                        </a:defRPr>
+                      </a:pPr>
+                      <a:r>
+                        <a:t>0</a:t>
+                      </a:r>
+                    </a:p>
+                  </a:txBody>
+                  <a:tcPr anchor="ctr">
+                    <a:solidFill>
+                      <a:srgbClr val="FFFFFF"/>
+                    </a:solidFill>
+                  </a:tcPr>
+                </a:tc>
+                <a:tc>
+                  <a:txBody>
+                    <a:bodyPr/>
+                    <a:lstStyle/>
+                    <a:p>
+                      <a:pPr algn="ctr">
+                        <a:defRPr sz="1200">
+                          <a:solidFill>
+                            <a:srgbClr val="2D2D2D"/>
+                          </a:solidFill>
+                          <a:latin typeface="Calibri"/>
+                        </a:defRPr>
+                      </a:pPr>
+                      <a:r>
+                        <a:t>Wrong or dangerously confident</a:t>
+                      </a:r>
+                    </a:p>
+                  </a:txBody>
+                  <a:tcPr anchor="ctr">
+                    <a:solidFill>
+                      <a:srgbClr val="FFFFFF"/>
+                    </a:solidFill>
+                  </a:tcPr>
+                </a:tc>
+                <a:tc>
+                  <a:txBody>
+                    <a:bodyPr/>
+                    <a:lstStyle/>
+                    <a:p>
+                      <a:pPr algn="ctr">
+                        <a:defRPr sz="1200">
+                          <a:solidFill>
+                            <a:srgbClr val="2D2D2D"/>
+                          </a:solidFill>
+                          <a:latin typeface="Calibri"/>
+                        </a:defRPr>
+                      </a:pPr>
+                      <a:r>
+                        <a:t>Real citation, wrong conclusion</a:t>
                       </a:r>
                     </a:p>
                   </a:txBody>
@@ -17411,7 +17656,7 @@
         <p:spPr>
           <a:xfrm>
             <a:off x="6858000" y="2560320"/>
-            <a:ext cx="4572000" cy="2286000"/>
+            <a:ext cx="4572000" cy="2560320"/>
           </a:xfrm>
           <a:prstGeom prst="rect">
             <a:avLst/>
@@ -17426,27 +17671,43 @@
           <a:p>
             <a:pPr>
               <a:spcAft>
-                <a:spcPts val="1000"/>
+                <a:spcPts val="800"/>
               </a:spcAft>
             </a:pPr>
             <a:r>
-              <a:rPr sz="1500">
+              <a:rPr sz="1400">
                 <a:solidFill>
                   <a:srgbClr val="2D2D2D"/>
                 </a:solidFill>
                 <a:latin typeface="Calibri"/>
               </a:rPr>
-              <a:t>10 prompts with known ground truth answers</a:t>
+              <a:t>Each prompt scored 0-10 against ground truth</a:t>
             </a:r>
           </a:p>
           <a:p>
             <a:pPr>
               <a:spcAft>
-                <a:spcPts val="1000"/>
+                <a:spcPts val="800"/>
               </a:spcAft>
             </a:pPr>
             <a:r>
-              <a:rPr sz="1500">
+              <a:rPr sz="1400">
+                <a:solidFill>
+                  <a:srgbClr val="2D2D2D"/>
+                </a:solidFill>
+                <a:latin typeface="Calibri"/>
+              </a:rPr>
+              <a:t>One run per agent, per-prompt scores averaged</a:t>
+            </a:r>
+          </a:p>
+          <a:p>
+            <a:pPr>
+              <a:spcAft>
+                <a:spcPts val="800"/>
+              </a:spcAft>
+            </a:pPr>
+            <a:r>
+              <a:rPr sz="1400">
                 <a:solidFill>
                   <a:srgbClr val="2D2D2D"/>
                 </a:solidFill>
@@ -17458,11 +17719,11 @@
           <a:p>
             <a:pPr>
               <a:spcAft>
-                <a:spcPts val="1000"/>
+                <a:spcPts val="800"/>
               </a:spcAft>
             </a:pPr>
             <a:r>
-              <a:rPr sz="1500">
+              <a:rPr sz="1400">
                 <a:solidFill>
                   <a:srgbClr val="2D2D2D"/>
                 </a:solidFill>
@@ -17474,11 +17735,11 @@
           <a:p>
             <a:pPr>
               <a:spcAft>
-                <a:spcPts val="1000"/>
+                <a:spcPts val="800"/>
               </a:spcAft>
             </a:pPr>
             <a:r>
-              <a:rPr sz="1500">
+              <a:rPr sz="1400">
                 <a:solidFill>
                   <a:srgbClr val="2D2D2D"/>
                 </a:solidFill>
@@ -17497,8 +17758,8 @@
         </p:nvSpPr>
         <p:spPr>
           <a:xfrm>
-            <a:off x="1097280" y="4572000"/>
-            <a:ext cx="9966960" cy="1097280"/>
+            <a:off x="1097280" y="4937760"/>
+            <a:ext cx="9966960" cy="914400"/>
           </a:xfrm>
           <a:prstGeom prst="roundRect">
             <a:avLst/>
@@ -17540,8 +17801,8 @@
         </p:nvSpPr>
         <p:spPr>
           <a:xfrm>
-            <a:off x="1097280" y="4572000"/>
-            <a:ext cx="137160" cy="1097280"/>
+            <a:off x="1097280" y="4937760"/>
+            <a:ext cx="137160" cy="914400"/>
           </a:xfrm>
           <a:prstGeom prst="rect">
             <a:avLst/>
@@ -17583,8 +17844,8 @@
         </p:nvSpPr>
         <p:spPr>
           <a:xfrm>
-            <a:off x="1463040" y="4663440"/>
-            <a:ext cx="9326880" cy="914400"/>
+            <a:off x="1463040" y="5029200"/>
+            <a:ext cx="9326880" cy="731520"/>
           </a:xfrm>
           <a:prstGeom prst="rect">
             <a:avLst/>

</xml_diff>

<commit_message>
docs: Soften GCC slide -- Copilot Studio works at every level
Replaced "adequate for Levels 1-3 / deploy pro-code for 4-5" framing
with three-tier layout: L1-3 (any config), L4 docs (9/10 proven in
GCC with GPT-4o), L4-5 structured data (model selection matters).
GCC gap callout notes document quality as the lever available today.

Co-Authored-By: Claude Opus 4.6 <noreply@anthropic.com>
</commit_message>
<xml_diff>
--- a/decks/agent-fidelity-spectrum.pptx
+++ b/decks/agent-fidelity-spectrum.pptx
@@ -1369,7 +1369,7 @@
           <a:lstStyle/>
           <a:p>
             <a:r>
-              <a:t>Know what works today. Plan for what's coming.</a:t>
+              <a:t>Copilot Studio is not just for Levels 1-3. We proved 9/10 at Level 4 with document agents in GCC using GPT-4o -- no code, just better documents. The gap is only for structured data queries where model selection matters. Know what works today. Plan for what's coming.</a:t>
             </a:r>
           </a:p>
         </p:txBody>
@@ -16093,98 +16093,27 @@
               </a:defRPr>
             </a:pPr>
             <a:r>
-              <a:t>The GCC reality today</a:t>
-            </a:r>
-          </a:p>
-        </p:txBody>
-      </p:sp>
-      <p:sp>
-        <p:nvSpPr>
-          <p:cNvPr id="5" name="TextBox 4"/>
-          <p:cNvSpPr txBox="1"/>
-          <p:nvPr/>
-        </p:nvSpPr>
-        <p:spPr>
-          <a:xfrm>
-            <a:off x="1097280" y="2011680"/>
-            <a:ext cx="9966960" cy="1371600"/>
-          </a:xfrm>
-          <a:prstGeom prst="rect">
-            <a:avLst/>
-          </a:prstGeom>
-          <a:noFill/>
-        </p:spPr>
-        <p:txBody>
-          <a:bodyPr wrap="square">
-            <a:spAutoFit/>
-          </a:bodyPr>
-          <a:lstStyle/>
-          <a:p>
-            <a:pPr>
-              <a:spcAft>
-                <a:spcPts val="600"/>
-              </a:spcAft>
-            </a:pPr>
-            <a:r>
-              <a:rPr sz="1700">
-                <a:solidFill>
-                  <a:srgbClr val="2D2D2D"/>
-                </a:solidFill>
-                <a:latin typeface="Calibri"/>
-              </a:rPr>
-              <a:t>Copilot Studio defaults to GPT-4o (adequate for Levels 1-3)</a:t>
-            </a:r>
-          </a:p>
-          <a:p>
-            <a:pPr>
-              <a:spcAft>
-                <a:spcPts val="600"/>
-              </a:spcAft>
-            </a:pPr>
-            <a:r>
-              <a:rPr sz="1700">
-                <a:solidFill>
-                  <a:srgbClr val="2D2D2D"/>
-                </a:solidFill>
-                <a:latin typeface="Calibri"/>
-              </a:rPr>
-              <a:t>Pro-code agents can use GPT-4.1 via Azure OpenAI (Levels 4-5)</a:t>
-            </a:r>
-          </a:p>
-          <a:p>
-            <a:pPr>
-              <a:spcAft>
-                <a:spcPts val="600"/>
-              </a:spcAft>
-            </a:pPr>
-            <a:r>
-              <a:rPr sz="1700">
-                <a:solidFill>
-                  <a:srgbClr val="2D2D2D"/>
-                </a:solidFill>
-                <a:latin typeface="Calibri"/>
-              </a:rPr>
-              <a:t>Monitor model updates -- GCC parity will improve over time</a:t>
-            </a:r>
-          </a:p>
-        </p:txBody>
-      </p:sp>
-      <p:sp>
-        <p:nvSpPr>
-          <p:cNvPr id="6" name="Rounded Rectangle 5"/>
+              <a:t>Copilot Studio works at every level -- the levers differ</a:t>
+            </a:r>
+          </a:p>
+        </p:txBody>
+      </p:sp>
+      <p:sp>
+        <p:nvSpPr>
+          <p:cNvPr id="5" name="Rounded Rectangle 4"/>
           <p:cNvSpPr/>
           <p:nvPr/>
         </p:nvSpPr>
         <p:spPr>
           <a:xfrm>
-            <a:off x="1097280" y="3657600"/>
-            <a:ext cx="3200400" cy="914400"/>
+            <a:off x="1097280" y="2103120"/>
+            <a:ext cx="3200400" cy="2011680"/>
           </a:xfrm>
           <a:prstGeom prst="roundRect">
             <a:avLst/>
           </a:prstGeom>
           <a:solidFill>
-            <a:srgbClr val="F2F2F2"/>
+            <a:srgbClr val="F1F8E9"/>
           </a:solidFill>
           <a:ln>
             <a:noFill/>
@@ -16214,14 +16143,57 @@
       </p:sp>
       <p:sp>
         <p:nvSpPr>
+          <p:cNvPr id="6" name="Rectangle 5"/>
+          <p:cNvSpPr/>
+          <p:nvPr/>
+        </p:nvSpPr>
+        <p:spPr>
+          <a:xfrm>
+            <a:off x="1097280" y="2103120"/>
+            <a:ext cx="137160" cy="2011680"/>
+          </a:xfrm>
+          <a:prstGeom prst="rect">
+            <a:avLst/>
+          </a:prstGeom>
+          <a:solidFill>
+            <a:srgbClr val="8BC34A"/>
+          </a:solidFill>
+          <a:ln>
+            <a:noFill/>
+          </a:ln>
+        </p:spPr>
+        <p:style>
+          <a:lnRef idx="1">
+            <a:schemeClr val="accent1"/>
+          </a:lnRef>
+          <a:fillRef idx="3">
+            <a:schemeClr val="accent1"/>
+          </a:fillRef>
+          <a:effectRef idx="2">
+            <a:schemeClr val="accent1"/>
+          </a:effectRef>
+          <a:fontRef idx="minor">
+            <a:schemeClr val="lt1"/>
+          </a:fontRef>
+        </p:style>
+        <p:txBody>
+          <a:bodyPr rtlCol="0" anchor="ctr"/>
+          <a:lstStyle/>
+          <a:p>
+            <a:pPr algn="ctr"/>
+          </a:p>
+        </p:txBody>
+      </p:sp>
+      <p:sp>
+        <p:nvSpPr>
           <p:cNvPr id="7" name="TextBox 6"/>
           <p:cNvSpPr txBox="1"/>
           <p:nvPr/>
         </p:nvSpPr>
         <p:spPr>
           <a:xfrm>
-            <a:off x="1234439" y="3657600"/>
-            <a:ext cx="2926080" cy="914400"/>
+            <a:off x="1371600" y="2194560"/>
+            <a:ext cx="2743200" cy="365760"/>
           </a:xfrm>
           <a:prstGeom prst="rect">
             <a:avLst/>
@@ -16234,30 +16206,595 @@
           </a:bodyPr>
           <a:lstStyle/>
           <a:p>
-            <a:pPr algn="ctr">
+            <a:pPr algn="l">
               <a:defRPr sz="1400" b="1">
                 <a:solidFill>
+                  <a:srgbClr val="8BC34A"/>
+                </a:solidFill>
+                <a:latin typeface="Calibri"/>
+              </a:defRPr>
+            </a:pPr>
+            <a:r>
+              <a:t>Levels 1-3</a:t>
+            </a:r>
+          </a:p>
+        </p:txBody>
+      </p:sp>
+      <p:sp>
+        <p:nvSpPr>
+          <p:cNvPr id="8" name="TextBox 7"/>
+          <p:cNvSpPr txBox="1"/>
+          <p:nvPr/>
+        </p:nvSpPr>
+        <p:spPr>
+          <a:xfrm>
+            <a:off x="1371600" y="2606040"/>
+            <a:ext cx="2743200" cy="1371600"/>
+          </a:xfrm>
+          <a:prstGeom prst="rect">
+            <a:avLst/>
+          </a:prstGeom>
+          <a:noFill/>
+        </p:spPr>
+        <p:txBody>
+          <a:bodyPr wrap="square">
+            <a:spAutoFit/>
+          </a:bodyPr>
+          <a:lstStyle/>
+          <a:p>
+            <a:pPr algn="l">
+              <a:defRPr sz="1400" b="0">
+                <a:solidFill>
                   <a:srgbClr val="2D2D2D"/>
                 </a:solidFill>
                 <a:latin typeface="Calibri"/>
               </a:defRPr>
             </a:pPr>
             <a:r>
-              <a:t>Is your use case Level 1-3?</a:t>
-            </a:r>
-          </a:p>
-        </p:txBody>
-      </p:sp>
-      <p:sp>
-        <p:nvSpPr>
-          <p:cNvPr id="8" name="Rounded Rectangle 7"/>
+              <a:t>Copilot Studio,</a:t>
+            </a:r>
+            <a:br/>
+            <a:r>
+              <a:t>any configuration</a:t>
+            </a:r>
+          </a:p>
+        </p:txBody>
+      </p:sp>
+      <p:sp>
+        <p:nvSpPr>
+          <p:cNvPr id="9" name="Rounded Rectangle 8"/>
           <p:cNvSpPr/>
           <p:nvPr/>
         </p:nvSpPr>
         <p:spPr>
           <a:xfrm>
-            <a:off x="1097280" y="4754880"/>
-            <a:ext cx="3200400" cy="914400"/>
+            <a:off x="4663440" y="2103120"/>
+            <a:ext cx="3200400" cy="2011680"/>
+          </a:xfrm>
+          <a:prstGeom prst="roundRect">
+            <a:avLst/>
+          </a:prstGeom>
+          <a:solidFill>
+            <a:srgbClr val="FBE9E7"/>
+          </a:solidFill>
+          <a:ln>
+            <a:noFill/>
+          </a:ln>
+        </p:spPr>
+        <p:style>
+          <a:lnRef idx="1">
+            <a:schemeClr val="accent1"/>
+          </a:lnRef>
+          <a:fillRef idx="3">
+            <a:schemeClr val="accent1"/>
+          </a:fillRef>
+          <a:effectRef idx="2">
+            <a:schemeClr val="accent1"/>
+          </a:effectRef>
+          <a:fontRef idx="minor">
+            <a:schemeClr val="lt1"/>
+          </a:fontRef>
+        </p:style>
+        <p:txBody>
+          <a:bodyPr rtlCol="0" anchor="ctr"/>
+          <a:lstStyle/>
+          <a:p>
+            <a:pPr algn="ctr"/>
+          </a:p>
+        </p:txBody>
+      </p:sp>
+      <p:sp>
+        <p:nvSpPr>
+          <p:cNvPr id="10" name="Rectangle 9"/>
+          <p:cNvSpPr/>
+          <p:nvPr/>
+        </p:nvSpPr>
+        <p:spPr>
+          <a:xfrm>
+            <a:off x="4663440" y="2103120"/>
+            <a:ext cx="137160" cy="2011680"/>
+          </a:xfrm>
+          <a:prstGeom prst="rect">
+            <a:avLst/>
+          </a:prstGeom>
+          <a:solidFill>
+            <a:srgbClr val="F4511E"/>
+          </a:solidFill>
+          <a:ln>
+            <a:noFill/>
+          </a:ln>
+        </p:spPr>
+        <p:style>
+          <a:lnRef idx="1">
+            <a:schemeClr val="accent1"/>
+          </a:lnRef>
+          <a:fillRef idx="3">
+            <a:schemeClr val="accent1"/>
+          </a:fillRef>
+          <a:effectRef idx="2">
+            <a:schemeClr val="accent1"/>
+          </a:effectRef>
+          <a:fontRef idx="minor">
+            <a:schemeClr val="lt1"/>
+          </a:fontRef>
+        </p:style>
+        <p:txBody>
+          <a:bodyPr rtlCol="0" anchor="ctr"/>
+          <a:lstStyle/>
+          <a:p>
+            <a:pPr algn="ctr"/>
+          </a:p>
+        </p:txBody>
+      </p:sp>
+      <p:sp>
+        <p:nvSpPr>
+          <p:cNvPr id="11" name="TextBox 10"/>
+          <p:cNvSpPr txBox="1"/>
+          <p:nvPr/>
+        </p:nvSpPr>
+        <p:spPr>
+          <a:xfrm>
+            <a:off x="4937759" y="2194560"/>
+            <a:ext cx="2743200" cy="365760"/>
+          </a:xfrm>
+          <a:prstGeom prst="rect">
+            <a:avLst/>
+          </a:prstGeom>
+          <a:noFill/>
+        </p:spPr>
+        <p:txBody>
+          <a:bodyPr wrap="square">
+            <a:spAutoFit/>
+          </a:bodyPr>
+          <a:lstStyle/>
+          <a:p>
+            <a:pPr algn="l">
+              <a:defRPr sz="1400" b="1">
+                <a:solidFill>
+                  <a:srgbClr val="F4511E"/>
+                </a:solidFill>
+                <a:latin typeface="Calibri"/>
+              </a:defRPr>
+            </a:pPr>
+            <a:r>
+              <a:t>Level 4 (Documents)</a:t>
+            </a:r>
+          </a:p>
+        </p:txBody>
+      </p:sp>
+      <p:sp>
+        <p:nvSpPr>
+          <p:cNvPr id="12" name="TextBox 11"/>
+          <p:cNvSpPr txBox="1"/>
+          <p:nvPr/>
+        </p:nvSpPr>
+        <p:spPr>
+          <a:xfrm>
+            <a:off x="4937759" y="2606040"/>
+            <a:ext cx="2743200" cy="1371600"/>
+          </a:xfrm>
+          <a:prstGeom prst="rect">
+            <a:avLst/>
+          </a:prstGeom>
+          <a:noFill/>
+        </p:spPr>
+        <p:txBody>
+          <a:bodyPr wrap="square">
+            <a:spAutoFit/>
+          </a:bodyPr>
+          <a:lstStyle/>
+          <a:p>
+            <a:pPr algn="l">
+              <a:defRPr sz="1400" b="0">
+                <a:solidFill>
+                  <a:srgbClr val="2D2D2D"/>
+                </a:solidFill>
+                <a:latin typeface="Calibri"/>
+              </a:defRPr>
+            </a:pPr>
+            <a:r>
+              <a:t>Copilot Studio +</a:t>
+            </a:r>
+            <a:br/>
+            <a:r>
+              <a:t>good document hygiene</a:t>
+            </a:r>
+            <a:br/>
+            <a:r>
+              <a:t>(9/10 proven, GPT-4o, GCC)</a:t>
+            </a:r>
+          </a:p>
+        </p:txBody>
+      </p:sp>
+      <p:sp>
+        <p:nvSpPr>
+          <p:cNvPr id="13" name="Rounded Rectangle 12"/>
+          <p:cNvSpPr/>
+          <p:nvPr/>
+        </p:nvSpPr>
+        <p:spPr>
+          <a:xfrm>
+            <a:off x="8229600" y="2103120"/>
+            <a:ext cx="3200400" cy="2011680"/>
+          </a:xfrm>
+          <a:prstGeom prst="roundRect">
+            <a:avLst/>
+          </a:prstGeom>
+          <a:solidFill>
+            <a:srgbClr val="E8F0F8"/>
+          </a:solidFill>
+          <a:ln>
+            <a:noFill/>
+          </a:ln>
+        </p:spPr>
+        <p:style>
+          <a:lnRef idx="1">
+            <a:schemeClr val="accent1"/>
+          </a:lnRef>
+          <a:fillRef idx="3">
+            <a:schemeClr val="accent1"/>
+          </a:fillRef>
+          <a:effectRef idx="2">
+            <a:schemeClr val="accent1"/>
+          </a:effectRef>
+          <a:fontRef idx="minor">
+            <a:schemeClr val="lt1"/>
+          </a:fontRef>
+        </p:style>
+        <p:txBody>
+          <a:bodyPr rtlCol="0" anchor="ctr"/>
+          <a:lstStyle/>
+          <a:p>
+            <a:pPr algn="ctr"/>
+          </a:p>
+        </p:txBody>
+      </p:sp>
+      <p:sp>
+        <p:nvSpPr>
+          <p:cNvPr id="14" name="Rectangle 13"/>
+          <p:cNvSpPr/>
+          <p:nvPr/>
+        </p:nvSpPr>
+        <p:spPr>
+          <a:xfrm>
+            <a:off x="8229600" y="2103120"/>
+            <a:ext cx="137160" cy="2011680"/>
+          </a:xfrm>
+          <a:prstGeom prst="rect">
+            <a:avLst/>
+          </a:prstGeom>
+          <a:solidFill>
+            <a:srgbClr val="2C5F8A"/>
+          </a:solidFill>
+          <a:ln>
+            <a:noFill/>
+          </a:ln>
+        </p:spPr>
+        <p:style>
+          <a:lnRef idx="1">
+            <a:schemeClr val="accent1"/>
+          </a:lnRef>
+          <a:fillRef idx="3">
+            <a:schemeClr val="accent1"/>
+          </a:fillRef>
+          <a:effectRef idx="2">
+            <a:schemeClr val="accent1"/>
+          </a:effectRef>
+          <a:fontRef idx="minor">
+            <a:schemeClr val="lt1"/>
+          </a:fontRef>
+        </p:style>
+        <p:txBody>
+          <a:bodyPr rtlCol="0" anchor="ctr"/>
+          <a:lstStyle/>
+          <a:p>
+            <a:pPr algn="ctr"/>
+          </a:p>
+        </p:txBody>
+      </p:sp>
+      <p:sp>
+        <p:nvSpPr>
+          <p:cNvPr id="15" name="TextBox 14"/>
+          <p:cNvSpPr txBox="1"/>
+          <p:nvPr/>
+        </p:nvSpPr>
+        <p:spPr>
+          <a:xfrm>
+            <a:off x="8503920" y="2194560"/>
+            <a:ext cx="2743200" cy="365760"/>
+          </a:xfrm>
+          <a:prstGeom prst="rect">
+            <a:avLst/>
+          </a:prstGeom>
+          <a:noFill/>
+        </p:spPr>
+        <p:txBody>
+          <a:bodyPr wrap="square">
+            <a:spAutoFit/>
+          </a:bodyPr>
+          <a:lstStyle/>
+          <a:p>
+            <a:pPr algn="l">
+              <a:defRPr sz="1400" b="1">
+                <a:solidFill>
+                  <a:srgbClr val="2C5F8A"/>
+                </a:solidFill>
+                <a:latin typeface="Calibri"/>
+              </a:defRPr>
+            </a:pPr>
+            <a:r>
+              <a:t>Level 4-5 (Structured Data)</a:t>
+            </a:r>
+          </a:p>
+        </p:txBody>
+      </p:sp>
+      <p:sp>
+        <p:nvSpPr>
+          <p:cNvPr id="16" name="TextBox 15"/>
+          <p:cNvSpPr txBox="1"/>
+          <p:nvPr/>
+        </p:nvSpPr>
+        <p:spPr>
+          <a:xfrm>
+            <a:off x="8503920" y="2606040"/>
+            <a:ext cx="2743200" cy="1371600"/>
+          </a:xfrm>
+          <a:prstGeom prst="rect">
+            <a:avLst/>
+          </a:prstGeom>
+          <a:noFill/>
+        </p:spPr>
+        <p:txBody>
+          <a:bodyPr wrap="square">
+            <a:spAutoFit/>
+          </a:bodyPr>
+          <a:lstStyle/>
+          <a:p>
+            <a:pPr algn="l">
+              <a:defRPr sz="1400" b="0">
+                <a:solidFill>
+                  <a:srgbClr val="2D2D2D"/>
+                </a:solidFill>
+                <a:latin typeface="Calibri"/>
+              </a:defRPr>
+            </a:pPr>
+            <a:r>
+              <a:t>Model selection matters</a:t>
+            </a:r>
+            <a:br/>
+            <a:r>
+              <a:t>Sonnet 4.6 = 11/11 (Commercial)</a:t>
+            </a:r>
+            <a:br/>
+            <a:r>
+              <a:t>GPT-4.1 via Azure OpenAI (GCC)</a:t>
+            </a:r>
+          </a:p>
+        </p:txBody>
+      </p:sp>
+      <p:sp>
+        <p:nvSpPr>
+          <p:cNvPr id="17" name="Rounded Rectangle 16"/>
+          <p:cNvSpPr/>
+          <p:nvPr/>
+        </p:nvSpPr>
+        <p:spPr>
+          <a:xfrm>
+            <a:off x="1097280" y="4389120"/>
+            <a:ext cx="9966960" cy="1371600"/>
+          </a:xfrm>
+          <a:prstGeom prst="roundRect">
+            <a:avLst/>
+          </a:prstGeom>
+          <a:solidFill>
+            <a:srgbClr val="F5F5F5"/>
+          </a:solidFill>
+          <a:ln>
+            <a:noFill/>
+          </a:ln>
+        </p:spPr>
+        <p:style>
+          <a:lnRef idx="1">
+            <a:schemeClr val="accent1"/>
+          </a:lnRef>
+          <a:fillRef idx="3">
+            <a:schemeClr val="accent1"/>
+          </a:fillRef>
+          <a:effectRef idx="2">
+            <a:schemeClr val="accent1"/>
+          </a:effectRef>
+          <a:fontRef idx="minor">
+            <a:schemeClr val="lt1"/>
+          </a:fontRef>
+        </p:style>
+        <p:txBody>
+          <a:bodyPr rtlCol="0" anchor="ctr"/>
+          <a:lstStyle/>
+          <a:p>
+            <a:pPr algn="ctr"/>
+          </a:p>
+        </p:txBody>
+      </p:sp>
+      <p:sp>
+        <p:nvSpPr>
+          <p:cNvPr id="18" name="Rectangle 17"/>
+          <p:cNvSpPr/>
+          <p:nvPr/>
+        </p:nvSpPr>
+        <p:spPr>
+          <a:xfrm>
+            <a:off x="1097280" y="4389120"/>
+            <a:ext cx="137160" cy="1371600"/>
+          </a:xfrm>
+          <a:prstGeom prst="rect">
+            <a:avLst/>
+          </a:prstGeom>
+          <a:solidFill>
+            <a:srgbClr val="357ABD"/>
+          </a:solidFill>
+          <a:ln>
+            <a:noFill/>
+          </a:ln>
+        </p:spPr>
+        <p:style>
+          <a:lnRef idx="1">
+            <a:schemeClr val="accent1"/>
+          </a:lnRef>
+          <a:fillRef idx="3">
+            <a:schemeClr val="accent1"/>
+          </a:fillRef>
+          <a:effectRef idx="2">
+            <a:schemeClr val="accent1"/>
+          </a:effectRef>
+          <a:fontRef idx="minor">
+            <a:schemeClr val="lt1"/>
+          </a:fontRef>
+        </p:style>
+        <p:txBody>
+          <a:bodyPr rtlCol="0" anchor="ctr"/>
+          <a:lstStyle/>
+          <a:p>
+            <a:pPr algn="ctr"/>
+          </a:p>
+        </p:txBody>
+      </p:sp>
+      <p:sp>
+        <p:nvSpPr>
+          <p:cNvPr id="19" name="TextBox 18"/>
+          <p:cNvSpPr txBox="1"/>
+          <p:nvPr/>
+        </p:nvSpPr>
+        <p:spPr>
+          <a:xfrm>
+            <a:off x="1463040" y="4434840"/>
+            <a:ext cx="2743200" cy="320040"/>
+          </a:xfrm>
+          <a:prstGeom prst="rect">
+            <a:avLst/>
+          </a:prstGeom>
+          <a:noFill/>
+        </p:spPr>
+        <p:txBody>
+          <a:bodyPr wrap="square">
+            <a:spAutoFit/>
+          </a:bodyPr>
+          <a:lstStyle/>
+          <a:p>
+            <a:pPr algn="l">
+              <a:defRPr sz="1600" b="1">
+                <a:solidFill>
+                  <a:srgbClr val="1B2A4A"/>
+                </a:solidFill>
+                <a:latin typeface="Calibri"/>
+              </a:defRPr>
+            </a:pPr>
+            <a:r>
+              <a:t>The GCC Gap</a:t>
+            </a:r>
+          </a:p>
+        </p:txBody>
+      </p:sp>
+      <p:sp>
+        <p:nvSpPr>
+          <p:cNvPr id="20" name="TextBox 19"/>
+          <p:cNvSpPr txBox="1"/>
+          <p:nvPr/>
+        </p:nvSpPr>
+        <p:spPr>
+          <a:xfrm>
+            <a:off x="1463040" y="4754880"/>
+            <a:ext cx="8961120" cy="914400"/>
+          </a:xfrm>
+          <a:prstGeom prst="rect">
+            <a:avLst/>
+          </a:prstGeom>
+          <a:noFill/>
+        </p:spPr>
+        <p:txBody>
+          <a:bodyPr wrap="square">
+            <a:spAutoFit/>
+          </a:bodyPr>
+          <a:lstStyle/>
+          <a:p>
+            <a:pPr>
+              <a:spcAft>
+                <a:spcPts val="400"/>
+              </a:spcAft>
+            </a:pPr>
+            <a:r>
+              <a:rPr sz="1300">
+                <a:solidFill>
+                  <a:srgbClr val="2D2D2D"/>
+                </a:solidFill>
+                <a:latin typeface="Calibri"/>
+              </a:rPr>
+              <a:t>Model selection not yet available in GCC Copilot Studio -- document quality is your lever today</a:t>
+            </a:r>
+          </a:p>
+          <a:p>
+            <a:pPr>
+              <a:spcAft>
+                <a:spcPts val="400"/>
+              </a:spcAft>
+            </a:pPr>
+            <a:r>
+              <a:rPr sz="1300">
+                <a:solidFill>
+                  <a:srgbClr val="2D2D2D"/>
+                </a:solidFill>
+                <a:latin typeface="Calibri"/>
+              </a:rPr>
+              <a:t>When expanded model availability arrives, every agent improves overnight with zero changes</a:t>
+            </a:r>
+          </a:p>
+          <a:p>
+            <a:pPr>
+              <a:spcAft>
+                <a:spcPts val="400"/>
+              </a:spcAft>
+            </a:pPr>
+            <a:r>
+              <a:rPr sz="1300">
+                <a:solidFill>
+                  <a:srgbClr val="2D2D2D"/>
+                </a:solidFill>
+                <a:latin typeface="Calibri"/>
+              </a:rPr>
+              <a:t>Start building ground truth test suites now so you are ready to measure the improvement</a:t>
+            </a:r>
+          </a:p>
+        </p:txBody>
+      </p:sp>
+      <p:sp>
+        <p:nvSpPr>
+          <p:cNvPr id="21" name="Rounded Rectangle 20"/>
+          <p:cNvSpPr/>
+          <p:nvPr/>
+        </p:nvSpPr>
+        <p:spPr>
+          <a:xfrm>
+            <a:off x="792327" y="6035040"/>
+            <a:ext cx="2011680" cy="411480"/>
           </a:xfrm>
           <a:prstGeom prst="roundRect">
             <a:avLst/>
@@ -16284,37 +16821,11 @@
           </a:fontRef>
         </p:style>
         <p:txBody>
-          <a:bodyPr rtlCol="0" anchor="ctr"/>
-          <a:lstStyle/>
-          <a:p>
-            <a:pPr algn="ctr"/>
-          </a:p>
-        </p:txBody>
-      </p:sp>
-      <p:sp>
-        <p:nvSpPr>
-          <p:cNvPr id="9" name="TextBox 8"/>
-          <p:cNvSpPr txBox="1"/>
-          <p:nvPr/>
-        </p:nvSpPr>
-        <p:spPr>
-          <a:xfrm>
-            <a:off x="1234439" y="4754880"/>
-            <a:ext cx="2926080" cy="914400"/>
-          </a:xfrm>
-          <a:prstGeom prst="rect">
-            <a:avLst/>
-          </a:prstGeom>
-          <a:noFill/>
-        </p:spPr>
-        <p:txBody>
-          <a:bodyPr wrap="square">
-            <a:spAutoFit/>
-          </a:bodyPr>
+          <a:bodyPr rtlCol="0" anchor="ctr" wrap="none"/>
           <a:lstStyle/>
           <a:p>
             <a:pPr algn="ctr">
-              <a:defRPr sz="1400" b="1">
+              <a:defRPr sz="1200" b="1">
                 <a:solidFill>
                   <a:srgbClr val="FFFFFF"/>
                 </a:solidFill>
@@ -16322,27 +16833,27 @@
               </a:defRPr>
             </a:pPr>
             <a:r>
-              <a:t>Use Copilot Studio today.</a:t>
-            </a:r>
-          </a:p>
-        </p:txBody>
-      </p:sp>
-      <p:sp>
-        <p:nvSpPr>
-          <p:cNvPr id="10" name="Rounded Rectangle 9"/>
+              <a:t>L1: Discovery</a:t>
+            </a:r>
+          </a:p>
+        </p:txBody>
+      </p:sp>
+      <p:sp>
+        <p:nvSpPr>
+          <p:cNvPr id="22" name="Rounded Rectangle 21"/>
           <p:cNvSpPr/>
           <p:nvPr/>
         </p:nvSpPr>
         <p:spPr>
           <a:xfrm>
-            <a:off x="4663440" y="3657600"/>
-            <a:ext cx="3200400" cy="914400"/>
+            <a:off x="2941167" y="6035040"/>
+            <a:ext cx="2011680" cy="411480"/>
           </a:xfrm>
           <a:prstGeom prst="roundRect">
             <a:avLst/>
           </a:prstGeom>
           <a:solidFill>
-            <a:srgbClr val="F2F2F2"/>
+            <a:srgbClr val="8BC34A"/>
           </a:solidFill>
           <a:ln>
             <a:noFill/>
@@ -16363,59 +16874,86 @@
           </a:fontRef>
         </p:style>
         <p:txBody>
-          <a:bodyPr rtlCol="0" anchor="ctr"/>
-          <a:lstStyle/>
-          <a:p>
-            <a:pPr algn="ctr"/>
-          </a:p>
-        </p:txBody>
-      </p:sp>
-      <p:sp>
-        <p:nvSpPr>
-          <p:cNvPr id="11" name="TextBox 10"/>
-          <p:cNvSpPr txBox="1"/>
-          <p:nvPr/>
-        </p:nvSpPr>
-        <p:spPr>
-          <a:xfrm>
-            <a:off x="4800600" y="3657600"/>
-            <a:ext cx="2926080" cy="914400"/>
-          </a:xfrm>
-          <a:prstGeom prst="rect">
-            <a:avLst/>
-          </a:prstGeom>
-          <a:noFill/>
-        </p:spPr>
-        <p:txBody>
-          <a:bodyPr wrap="square">
-            <a:spAutoFit/>
-          </a:bodyPr>
+          <a:bodyPr rtlCol="0" anchor="ctr" wrap="none"/>
           <a:lstStyle/>
           <a:p>
             <a:pPr algn="ctr">
-              <a:defRPr sz="1400" b="1">
-                <a:solidFill>
-                  <a:srgbClr val="2D2D2D"/>
-                </a:solidFill>
-                <a:latin typeface="Calibri"/>
-              </a:defRPr>
-            </a:pPr>
-            <a:r>
-              <a:t>Is your use case Level 4-5?</a:t>
-            </a:r>
-          </a:p>
-        </p:txBody>
-      </p:sp>
-      <p:sp>
-        <p:nvSpPr>
-          <p:cNvPr id="12" name="Rounded Rectangle 11"/>
+              <a:defRPr sz="1200" b="1">
+                <a:solidFill>
+                  <a:srgbClr val="FFFFFF"/>
+                </a:solidFill>
+                <a:latin typeface="Calibri"/>
+              </a:defRPr>
+            </a:pPr>
+            <a:r>
+              <a:t>L2: Summarization</a:t>
+            </a:r>
+          </a:p>
+        </p:txBody>
+      </p:sp>
+      <p:sp>
+        <p:nvSpPr>
+          <p:cNvPr id="23" name="Rounded Rectangle 22"/>
           <p:cNvSpPr/>
           <p:nvPr/>
         </p:nvSpPr>
         <p:spPr>
           <a:xfrm>
-            <a:off x="4663440" y="4754880"/>
-            <a:ext cx="3200400" cy="914400"/>
+            <a:off x="5090007" y="6035040"/>
+            <a:ext cx="2011680" cy="411480"/>
+          </a:xfrm>
+          <a:prstGeom prst="roundRect">
+            <a:avLst/>
+          </a:prstGeom>
+          <a:solidFill>
+            <a:srgbClr val="FF9800"/>
+          </a:solidFill>
+          <a:ln>
+            <a:noFill/>
+          </a:ln>
+        </p:spPr>
+        <p:style>
+          <a:lnRef idx="1">
+            <a:schemeClr val="accent1"/>
+          </a:lnRef>
+          <a:fillRef idx="3">
+            <a:schemeClr val="accent1"/>
+          </a:fillRef>
+          <a:effectRef idx="2">
+            <a:schemeClr val="accent1"/>
+          </a:effectRef>
+          <a:fontRef idx="minor">
+            <a:schemeClr val="lt1"/>
+          </a:fontRef>
+        </p:style>
+        <p:txBody>
+          <a:bodyPr rtlCol="0" anchor="ctr" wrap="none"/>
+          <a:lstStyle/>
+          <a:p>
+            <a:pPr algn="ctr">
+              <a:defRPr sz="1200" b="1">
+                <a:solidFill>
+                  <a:srgbClr val="FFFFFF"/>
+                </a:solidFill>
+                <a:latin typeface="Calibri"/>
+              </a:defRPr>
+            </a:pPr>
+            <a:r>
+              <a:t>L3: Operational</a:t>
+            </a:r>
+          </a:p>
+        </p:txBody>
+      </p:sp>
+      <p:sp>
+        <p:nvSpPr>
+          <p:cNvPr id="24" name="Rounded Rectangle 23"/>
+          <p:cNvSpPr/>
+          <p:nvPr/>
+        </p:nvSpPr>
+        <p:spPr>
+          <a:xfrm>
+            <a:off x="7238847" y="6035040"/>
+            <a:ext cx="2011680" cy="411480"/>
           </a:xfrm>
           <a:prstGeom prst="roundRect">
             <a:avLst/>
@@ -16442,255 +16980,6 @@
           </a:fontRef>
         </p:style>
         <p:txBody>
-          <a:bodyPr rtlCol="0" anchor="ctr"/>
-          <a:lstStyle/>
-          <a:p>
-            <a:pPr algn="ctr"/>
-          </a:p>
-        </p:txBody>
-      </p:sp>
-      <p:sp>
-        <p:nvSpPr>
-          <p:cNvPr id="13" name="TextBox 12"/>
-          <p:cNvSpPr txBox="1"/>
-          <p:nvPr/>
-        </p:nvSpPr>
-        <p:spPr>
-          <a:xfrm>
-            <a:off x="4800600" y="4754880"/>
-            <a:ext cx="2926080" cy="914400"/>
-          </a:xfrm>
-          <a:prstGeom prst="rect">
-            <a:avLst/>
-          </a:prstGeom>
-          <a:noFill/>
-        </p:spPr>
-        <p:txBody>
-          <a:bodyPr wrap="square">
-            <a:spAutoFit/>
-          </a:bodyPr>
-          <a:lstStyle/>
-          <a:p>
-            <a:pPr algn="ctr">
-              <a:defRPr sz="1400" b="1">
-                <a:solidFill>
-                  <a:srgbClr val="FFFFFF"/>
-                </a:solidFill>
-                <a:latin typeface="Calibri"/>
-              </a:defRPr>
-            </a:pPr>
-            <a:r>
-              <a:t>Deploy a pro-code agent</a:t>
-            </a:r>
-            <a:br/>
-            <a:r>
-              <a:t>with GPT-4.1.</a:t>
-            </a:r>
-          </a:p>
-        </p:txBody>
-      </p:sp>
-      <p:sp>
-        <p:nvSpPr>
-          <p:cNvPr id="14" name="Rounded Rectangle 13"/>
-          <p:cNvSpPr/>
-          <p:nvPr/>
-        </p:nvSpPr>
-        <p:spPr>
-          <a:xfrm>
-            <a:off x="8229600" y="3657600"/>
-            <a:ext cx="3200400" cy="914400"/>
-          </a:xfrm>
-          <a:prstGeom prst="roundRect">
-            <a:avLst/>
-          </a:prstGeom>
-          <a:solidFill>
-            <a:srgbClr val="F2F2F2"/>
-          </a:solidFill>
-          <a:ln>
-            <a:noFill/>
-          </a:ln>
-        </p:spPr>
-        <p:style>
-          <a:lnRef idx="1">
-            <a:schemeClr val="accent1"/>
-          </a:lnRef>
-          <a:fillRef idx="3">
-            <a:schemeClr val="accent1"/>
-          </a:fillRef>
-          <a:effectRef idx="2">
-            <a:schemeClr val="accent1"/>
-          </a:effectRef>
-          <a:fontRef idx="minor">
-            <a:schemeClr val="lt1"/>
-          </a:fontRef>
-        </p:style>
-        <p:txBody>
-          <a:bodyPr rtlCol="0" anchor="ctr"/>
-          <a:lstStyle/>
-          <a:p>
-            <a:pPr algn="ctr"/>
-          </a:p>
-        </p:txBody>
-      </p:sp>
-      <p:sp>
-        <p:nvSpPr>
-          <p:cNvPr id="15" name="TextBox 14"/>
-          <p:cNvSpPr txBox="1"/>
-          <p:nvPr/>
-        </p:nvSpPr>
-        <p:spPr>
-          <a:xfrm>
-            <a:off x="8366760" y="3657600"/>
-            <a:ext cx="2926080" cy="914400"/>
-          </a:xfrm>
-          <a:prstGeom prst="rect">
-            <a:avLst/>
-          </a:prstGeom>
-          <a:noFill/>
-        </p:spPr>
-        <p:txBody>
-          <a:bodyPr wrap="square">
-            <a:spAutoFit/>
-          </a:bodyPr>
-          <a:lstStyle/>
-          <a:p>
-            <a:pPr algn="ctr">
-              <a:defRPr sz="1400" b="1">
-                <a:solidFill>
-                  <a:srgbClr val="2D2D2D"/>
-                </a:solidFill>
-                <a:latin typeface="Calibri"/>
-              </a:defRPr>
-            </a:pPr>
-            <a:r>
-              <a:t>Planning for Level 4-5</a:t>
-            </a:r>
-            <a:br/>
-            <a:r>
-              <a:t>in the future?</a:t>
-            </a:r>
-          </a:p>
-        </p:txBody>
-      </p:sp>
-      <p:sp>
-        <p:nvSpPr>
-          <p:cNvPr id="16" name="Rounded Rectangle 15"/>
-          <p:cNvSpPr/>
-          <p:nvPr/>
-        </p:nvSpPr>
-        <p:spPr>
-          <a:xfrm>
-            <a:off x="8229600" y="4754880"/>
-            <a:ext cx="3200400" cy="914400"/>
-          </a:xfrm>
-          <a:prstGeom prst="roundRect">
-            <a:avLst/>
-          </a:prstGeom>
-          <a:solidFill>
-            <a:srgbClr val="2C5F8A"/>
-          </a:solidFill>
-          <a:ln>
-            <a:noFill/>
-          </a:ln>
-        </p:spPr>
-        <p:style>
-          <a:lnRef idx="1">
-            <a:schemeClr val="accent1"/>
-          </a:lnRef>
-          <a:fillRef idx="3">
-            <a:schemeClr val="accent1"/>
-          </a:fillRef>
-          <a:effectRef idx="2">
-            <a:schemeClr val="accent1"/>
-          </a:effectRef>
-          <a:fontRef idx="minor">
-            <a:schemeClr val="lt1"/>
-          </a:fontRef>
-        </p:style>
-        <p:txBody>
-          <a:bodyPr rtlCol="0" anchor="ctr"/>
-          <a:lstStyle/>
-          <a:p>
-            <a:pPr algn="ctr"/>
-          </a:p>
-        </p:txBody>
-      </p:sp>
-      <p:sp>
-        <p:nvSpPr>
-          <p:cNvPr id="17" name="TextBox 16"/>
-          <p:cNvSpPr txBox="1"/>
-          <p:nvPr/>
-        </p:nvSpPr>
-        <p:spPr>
-          <a:xfrm>
-            <a:off x="8366760" y="4754880"/>
-            <a:ext cx="2926080" cy="914400"/>
-          </a:xfrm>
-          <a:prstGeom prst="rect">
-            <a:avLst/>
-          </a:prstGeom>
-          <a:noFill/>
-        </p:spPr>
-        <p:txBody>
-          <a:bodyPr wrap="square">
-            <a:spAutoFit/>
-          </a:bodyPr>
-          <a:lstStyle/>
-          <a:p>
-            <a:pPr algn="ctr">
-              <a:defRPr sz="1400" b="1">
-                <a:solidFill>
-                  <a:srgbClr val="FFFFFF"/>
-                </a:solidFill>
-                <a:latin typeface="Calibri"/>
-              </a:defRPr>
-            </a:pPr>
-            <a:r>
-              <a:t>Start building ground truth</a:t>
-            </a:r>
-            <a:br/>
-            <a:r>
-              <a:t>test suites now.</a:t>
-            </a:r>
-          </a:p>
-        </p:txBody>
-      </p:sp>
-      <p:sp>
-        <p:nvSpPr>
-          <p:cNvPr id="18" name="Rounded Rectangle 17"/>
-          <p:cNvSpPr/>
-          <p:nvPr/>
-        </p:nvSpPr>
-        <p:spPr>
-          <a:xfrm>
-            <a:off x="792327" y="6035040"/>
-            <a:ext cx="2011680" cy="411480"/>
-          </a:xfrm>
-          <a:prstGeom prst="roundRect">
-            <a:avLst/>
-          </a:prstGeom>
-          <a:solidFill>
-            <a:srgbClr val="4CAF50"/>
-          </a:solidFill>
-          <a:ln>
-            <a:noFill/>
-          </a:ln>
-        </p:spPr>
-        <p:style>
-          <a:lnRef idx="1">
-            <a:schemeClr val="accent1"/>
-          </a:lnRef>
-          <a:fillRef idx="3">
-            <a:schemeClr val="accent1"/>
-          </a:fillRef>
-          <a:effectRef idx="2">
-            <a:schemeClr val="accent1"/>
-          </a:effectRef>
-          <a:fontRef idx="minor">
-            <a:schemeClr val="lt1"/>
-          </a:fontRef>
-        </p:style>
-        <p:txBody>
           <a:bodyPr rtlCol="0" anchor="ctr" wrap="none"/>
           <a:lstStyle/>
           <a:p>
@@ -16703,165 +16992,6 @@
               </a:defRPr>
             </a:pPr>
             <a:r>
-              <a:t>L1: Discovery</a:t>
-            </a:r>
-          </a:p>
-        </p:txBody>
-      </p:sp>
-      <p:sp>
-        <p:nvSpPr>
-          <p:cNvPr id="19" name="Rounded Rectangle 18"/>
-          <p:cNvSpPr/>
-          <p:nvPr/>
-        </p:nvSpPr>
-        <p:spPr>
-          <a:xfrm>
-            <a:off x="2941167" y="6035040"/>
-            <a:ext cx="2011680" cy="411480"/>
-          </a:xfrm>
-          <a:prstGeom prst="roundRect">
-            <a:avLst/>
-          </a:prstGeom>
-          <a:solidFill>
-            <a:srgbClr val="8BC34A"/>
-          </a:solidFill>
-          <a:ln>
-            <a:noFill/>
-          </a:ln>
-        </p:spPr>
-        <p:style>
-          <a:lnRef idx="1">
-            <a:schemeClr val="accent1"/>
-          </a:lnRef>
-          <a:fillRef idx="3">
-            <a:schemeClr val="accent1"/>
-          </a:fillRef>
-          <a:effectRef idx="2">
-            <a:schemeClr val="accent1"/>
-          </a:effectRef>
-          <a:fontRef idx="minor">
-            <a:schemeClr val="lt1"/>
-          </a:fontRef>
-        </p:style>
-        <p:txBody>
-          <a:bodyPr rtlCol="0" anchor="ctr" wrap="none"/>
-          <a:lstStyle/>
-          <a:p>
-            <a:pPr algn="ctr">
-              <a:defRPr sz="1200" b="1">
-                <a:solidFill>
-                  <a:srgbClr val="FFFFFF"/>
-                </a:solidFill>
-                <a:latin typeface="Calibri"/>
-              </a:defRPr>
-            </a:pPr>
-            <a:r>
-              <a:t>L2: Summarization</a:t>
-            </a:r>
-          </a:p>
-        </p:txBody>
-      </p:sp>
-      <p:sp>
-        <p:nvSpPr>
-          <p:cNvPr id="20" name="Rounded Rectangle 19"/>
-          <p:cNvSpPr/>
-          <p:nvPr/>
-        </p:nvSpPr>
-        <p:spPr>
-          <a:xfrm>
-            <a:off x="5090007" y="6035040"/>
-            <a:ext cx="2011680" cy="411480"/>
-          </a:xfrm>
-          <a:prstGeom prst="roundRect">
-            <a:avLst/>
-          </a:prstGeom>
-          <a:solidFill>
-            <a:srgbClr val="FF9800"/>
-          </a:solidFill>
-          <a:ln>
-            <a:noFill/>
-          </a:ln>
-        </p:spPr>
-        <p:style>
-          <a:lnRef idx="1">
-            <a:schemeClr val="accent1"/>
-          </a:lnRef>
-          <a:fillRef idx="3">
-            <a:schemeClr val="accent1"/>
-          </a:fillRef>
-          <a:effectRef idx="2">
-            <a:schemeClr val="accent1"/>
-          </a:effectRef>
-          <a:fontRef idx="minor">
-            <a:schemeClr val="lt1"/>
-          </a:fontRef>
-        </p:style>
-        <p:txBody>
-          <a:bodyPr rtlCol="0" anchor="ctr" wrap="none"/>
-          <a:lstStyle/>
-          <a:p>
-            <a:pPr algn="ctr">
-              <a:defRPr sz="1200" b="1">
-                <a:solidFill>
-                  <a:srgbClr val="FFFFFF"/>
-                </a:solidFill>
-                <a:latin typeface="Calibri"/>
-              </a:defRPr>
-            </a:pPr>
-            <a:r>
-              <a:t>L3: Operational</a:t>
-            </a:r>
-          </a:p>
-        </p:txBody>
-      </p:sp>
-      <p:sp>
-        <p:nvSpPr>
-          <p:cNvPr id="21" name="Rounded Rectangle 20"/>
-          <p:cNvSpPr/>
-          <p:nvPr/>
-        </p:nvSpPr>
-        <p:spPr>
-          <a:xfrm>
-            <a:off x="7238847" y="6035040"/>
-            <a:ext cx="2011680" cy="411480"/>
-          </a:xfrm>
-          <a:prstGeom prst="roundRect">
-            <a:avLst/>
-          </a:prstGeom>
-          <a:solidFill>
-            <a:srgbClr val="F4511E"/>
-          </a:solidFill>
-          <a:ln>
-            <a:noFill/>
-          </a:ln>
-        </p:spPr>
-        <p:style>
-          <a:lnRef idx="1">
-            <a:schemeClr val="accent1"/>
-          </a:lnRef>
-          <a:fillRef idx="3">
-            <a:schemeClr val="accent1"/>
-          </a:fillRef>
-          <a:effectRef idx="2">
-            <a:schemeClr val="accent1"/>
-          </a:effectRef>
-          <a:fontRef idx="minor">
-            <a:schemeClr val="lt1"/>
-          </a:fontRef>
-        </p:style>
-        <p:txBody>
-          <a:bodyPr rtlCol="0" anchor="ctr" wrap="none"/>
-          <a:lstStyle/>
-          <a:p>
-            <a:pPr algn="ctr">
-              <a:defRPr sz="1200" b="1">
-                <a:solidFill>
-                  <a:srgbClr val="FFFFFF"/>
-                </a:solidFill>
-                <a:latin typeface="Calibri"/>
-              </a:defRPr>
-            </a:pPr>
-            <a:r>
               <a:t>L4: Investigative</a:t>
             </a:r>
           </a:p>
@@ -16869,7 +16999,7 @@
       </p:sp>
       <p:sp>
         <p:nvSpPr>
-          <p:cNvPr id="22" name="Rounded Rectangle 21"/>
+          <p:cNvPr id="25" name="Rounded Rectangle 24"/>
           <p:cNvSpPr/>
           <p:nvPr/>
         </p:nvSpPr>
@@ -16922,7 +17052,7 @@
       </p:sp>
       <p:sp>
         <p:nvSpPr>
-          <p:cNvPr id="23" name="TextBox 22"/>
+          <p:cNvPr id="26" name="TextBox 25"/>
           <p:cNvSpPr txBox="1"/>
           <p:nvPr/>
         </p:nvSpPr>

</xml_diff>

<commit_message>
docs: Copilot Studio supports Levels 4-5 for documents, add GPT-5 Reasoning
Changed "Level 4 (Documents)" to "Levels 4-5 (Documents)" since Level 5
is human-in-the-loop review of Level 4 output -- a process decision, not
a platform limitation. Renamed third tier to "Structured Data Gap" and
added GPT-5 Reasoning (10/11) alongside Sonnet 4.6 (11/11).

Co-Authored-By: Claude Opus 4.6 <noreply@anthropic.com>
</commit_message>
<xml_diff>
--- a/decks/agent-fidelity-spectrum.pptx
+++ b/decks/agent-fidelity-spectrum.pptx
@@ -16377,7 +16377,7 @@
               </a:defRPr>
             </a:pPr>
             <a:r>
-              <a:t>Level 4 (Documents)</a:t>
+              <a:t>Levels 4-5 (Documents)</a:t>
             </a:r>
           </a:p>
         </p:txBody>
@@ -16543,7 +16543,7 @@
               </a:defRPr>
             </a:pPr>
             <a:r>
-              <a:t>Level 4-5 (Structured Data)</a:t>
+              <a:t>Structured Data Gap</a:t>
             </a:r>
           </a:p>
         </p:txBody>
@@ -16584,6 +16584,10 @@
             <a:br/>
             <a:r>
               <a:t>Sonnet 4.6 = 11/11 (Commercial)</a:t>
+            </a:r>
+            <a:br/>
+            <a:r>
+              <a:t>GPT-5 Reasoning = 10/11 (Commercial)</a:t>
             </a:r>
             <a:br/>
             <a:r>

</xml_diff>

<commit_message>
docs: Add author attribution (Patrick O'Gorman | Microsoft) to all cover pages
Added author line to 10 PDF generator scripts and slide deck generator.
Regenerated all PDFs and PowerPoint deck.

Co-Authored-By: Claude Opus 4.6 <noreply@anthropic.com>
</commit_message>
<xml_diff>
--- a/decks/agent-fidelity-spectrum.pptx
+++ b/decks/agent-fidelity-spectrum.pptx
@@ -4568,7 +4568,43 @@
       </p:sp>
       <p:sp>
         <p:nvSpPr>
-          <p:cNvPr id="7" name="Rounded Rectangle 6"/>
+          <p:cNvPr id="7" name="TextBox 6"/>
+          <p:cNvSpPr txBox="1"/>
+          <p:nvPr/>
+        </p:nvSpPr>
+        <p:spPr>
+          <a:xfrm>
+            <a:off x="3657600" y="4754880"/>
+            <a:ext cx="4846320" cy="365760"/>
+          </a:xfrm>
+          <a:prstGeom prst="rect">
+            <a:avLst/>
+          </a:prstGeom>
+          <a:noFill/>
+        </p:spPr>
+        <p:txBody>
+          <a:bodyPr wrap="square">
+            <a:spAutoFit/>
+          </a:bodyPr>
+          <a:lstStyle/>
+          <a:p>
+            <a:pPr algn="ctr">
+              <a:defRPr sz="1400" b="0">
+                <a:solidFill>
+                  <a:srgbClr val="555555"/>
+                </a:solidFill>
+                <a:latin typeface="Calibri"/>
+              </a:defRPr>
+            </a:pPr>
+            <a:r>
+              <a:t>Patrick O'Gorman  |  Microsoft</a:t>
+            </a:r>
+          </a:p>
+        </p:txBody>
+      </p:sp>
+      <p:sp>
+        <p:nvSpPr>
+          <p:cNvPr id="8" name="Rounded Rectangle 7"/>
           <p:cNvSpPr/>
           <p:nvPr/>
         </p:nvSpPr>
@@ -4621,7 +4657,7 @@
       </p:sp>
       <p:sp>
         <p:nvSpPr>
-          <p:cNvPr id="8" name="Rounded Rectangle 7"/>
+          <p:cNvPr id="9" name="Rounded Rectangle 8"/>
           <p:cNvSpPr/>
           <p:nvPr/>
         </p:nvSpPr>
@@ -4674,7 +4710,7 @@
       </p:sp>
       <p:sp>
         <p:nvSpPr>
-          <p:cNvPr id="9" name="Rounded Rectangle 8"/>
+          <p:cNvPr id="10" name="Rounded Rectangle 9"/>
           <p:cNvSpPr/>
           <p:nvPr/>
         </p:nvSpPr>
@@ -4727,7 +4763,7 @@
       </p:sp>
       <p:sp>
         <p:nvSpPr>
-          <p:cNvPr id="10" name="Rounded Rectangle 9"/>
+          <p:cNvPr id="11" name="Rounded Rectangle 10"/>
           <p:cNvSpPr/>
           <p:nvPr/>
         </p:nvSpPr>
@@ -4780,7 +4816,7 @@
       </p:sp>
       <p:sp>
         <p:nvSpPr>
-          <p:cNvPr id="11" name="Rounded Rectangle 10"/>
+          <p:cNvPr id="12" name="Rounded Rectangle 11"/>
           <p:cNvSpPr/>
           <p:nvPr/>
         </p:nvSpPr>
@@ -4833,7 +4869,7 @@
       </p:sp>
       <p:sp>
         <p:nvSpPr>
-          <p:cNvPr id="12" name="TextBox 11"/>
+          <p:cNvPr id="13" name="TextBox 12"/>
           <p:cNvSpPr txBox="1"/>
           <p:nvPr/>
         </p:nvSpPr>

</xml_diff>